<commit_message>
Entregable 1 v4: oportunidades de La Piedad y GAO, Lagos a PARCIAL, apendice 3
Incorpora las nomenclaturas que dio Marcos el 14-oct-2026: Bafar La
Piedad 813492 (650,220 MXN) y 814010 (265,000 MXN), y GAO (Grupo
Occidente, Acatlan) sin numero ni monto. Quedan como DECLARADAS: no
estan en Base_Simbiosis (corte 12-ago-2026).

Hallazgo: la Cliente clave de Grupo Occidente Acatlan ya tiene dos
oportunidades Lost 2025 (742222 y 782913), asi que GAO no es terreno
virgen. Que sea la empresa de gaoaluminio.com lo afirma Marcos; la web no
lo confirma.

Bachoco Lagos baja a PARCIAL (mismo criterio que Pilgrim's Toluca).
Nuevos CSV: OPORTUNIDADES_VERIFICADAS_CRM, OPORTUNIDADES_DECLARADAS y
DECLARACIONES_CAMPO. Siguen como BORRADOR hasta cerrar la tercera
auditoria.

Co-Authored-By: Claude Sonnet 5.5 <noreply@anthropic.com>
Claude-Session: https://claude.ai/code/session_01NzdY9gSJuZdYXnSeKazui4
</commit_message>
<xml_diff>
--- a/entregables/Simbiosis_IR_Proteina_Animal_Entregable1.pptx
+++ b/entregables/Simbiosis_IR_Proteina_Animal_Entregable1.pptx
@@ -15,9 +15,10 @@
     <p:sldId id="263" r:id="rId9"/>
     <p:sldId id="264" r:id="rId10"/>
     <p:sldId id="265" r:id="rId11"/>
+    <p:sldId id="266" r:id="rId12"/>
   </p:sldIdLst>
   <p:notesMasterIdLst>
-    <p:notesMasterId r:id="rId12"/>
+    <p:notesMasterId r:id="rId13"/>
   </p:notesMasterIdLst>
   <p:sldSz cx="12192000" cy="6858000"/>
   <p:notesSz cx="6858000" cy="12192000"/>
@@ -116,40 +117,41 @@
   <p:extLst>
     <p:ext uri="{521415D9-36F7-43E2-AB2F-B90AF26B5E84}">
       <p14:sectionLst xmlns:p14="http://schemas.microsoft.com/office/powerpoint/2010/main">
-        <p14:section name="Resumen" id="{fb938481-a8ea-e793-db41-9d4a9f1ada43}">
+        <p14:section name="Resumen" id="{a0d70c26-75b7-63a4-3bec-9b66aa141751}">
           <p14:sldIdLst>
             <p14:sldId id="257"/>
           </p14:sldIdLst>
         </p14:section>
-        <p14:section name="Mercado" id="{aa503397-a3e1-b15e-054b-aeaa85ffafd2}">
+        <p14:section name="Mercado" id="{41db5a8a-d61d-0a16-b3aa-572b6c01e3ec}">
           <p14:sldIdLst>
             <p14:sldId id="258"/>
             <p14:sldId id="259"/>
           </p14:sldIdLst>
         </p14:section>
-        <p14:section name="Experiencia" id="{2c524937-aca1-ea9b-ef36-f95be39e4af4}">
+        <p14:section name="Experiencia" id="{6c3cac80-1947-bea7-5a2e-44065b3baefb}">
           <p14:sldIdLst>
             <p14:sldId id="260"/>
           </p14:sldIdLst>
         </p14:section>
-        <p14:section name="Grupos" id="{0d1a2647-b45b-b3b9-a521-55c0e40de8d7}">
+        <p14:section name="Grupos" id="{e4d561f9-bb7e-f2f0-aed4-41f6abe68a67}">
           <p14:sldIdLst>
             <p14:sldId id="261"/>
           </p14:sldIdLst>
         </p14:section>
-        <p14:section name="Plantas" id="{0a6c08e6-84f9-537c-bc0b-d2de37a40d37}">
+        <p14:section name="Plantas" id="{02a37fdd-8b3e-8837-c656-880701316c00}">
           <p14:sldIdLst>
             <p14:sldId id="262"/>
           </p14:sldIdLst>
         </p14:section>
-        <p14:section name="Cierre" id="{3bc73627-c92d-19d1-e848-da3fdeabf4a4}">
+        <p14:section name="Cierre" id="{f07915fc-6b58-c44c-3e73-f0ae05cf8cf5}">
           <p14:sldIdLst>
             <p14:sldId id="263"/>
             <p14:sldId id="264"/>
             <p14:sldId id="265"/>
+            <p14:sldId id="266"/>
           </p14:sldIdLst>
         </p14:section>
-        <p14:section name="Default-1" id="{801db13c-e992-216a-c92f-619f6beffd43}">
+        <p14:section name="Default-1" id="{980d443d-4922-a1b8-fc84-5f58625e9212}">
           <p14:sldIdLst>
             <p14:sldId id="256"/>
           </p14:sldIdLst>
@@ -1279,6 +1281,94 @@
 </p:notes>
 </file>
 
+<file path=ppt/notesSlides/notesSlide11.xml><?xml version="1.0" encoding="utf-8"?>
+<p:notes xmlns:a="http://schemas.openxmlformats.org/drawingml/2006/main" xmlns:r="http://schemas.openxmlformats.org/officeDocument/2006/relationships" xmlns:p="http://schemas.openxmlformats.org/presentationml/2006/main">
+  <p:cSld>
+    <p:spTree>
+      <p:nvGrpSpPr>
+        <p:cNvPr id="1" name=""/>
+        <p:cNvGrpSpPr/>
+        <p:nvPr/>
+      </p:nvGrpSpPr>
+      <p:grpSpPr>
+        <a:xfrm>
+          <a:off x="0" y="0"/>
+          <a:ext cx="0" cy="0"/>
+          <a:chOff x="0" y="0"/>
+          <a:chExt cx="0" cy="0"/>
+        </a:xfrm>
+      </p:grpSpPr>
+      <p:sp>
+        <p:nvSpPr>
+          <p:cNvPr id="2" name="Slide Image Placeholder 1"/>
+          <p:cNvSpPr>
+            <a:spLocks noGrp="1" noRot="1" noChangeAspect="1"/>
+          </p:cNvSpPr>
+          <p:nvPr>
+            <p:ph type="sldImg"/>
+          </p:nvPr>
+        </p:nvSpPr>
+        <p:spPr/>
+      </p:sp>
+      <p:sp>
+        <p:nvSpPr>
+          <p:cNvPr id="3" name="Notes Placeholder 2"/>
+          <p:cNvSpPr>
+            <a:spLocks noGrp="1"/>
+          </p:cNvSpPr>
+          <p:nvPr>
+            <p:ph type="body" idx="1"/>
+          </p:nvPr>
+        </p:nvSpPr>
+        <p:spPr/>
+        <p:txBody>
+          <a:bodyPr/>
+          <a:lstStyle/>
+          <a:p>
+            <a:r>
+              <a:rPr lang="en-US" dirty="0"/>
+              <a:t/>
+            </a:r>
+            <a:endParaRPr lang="en-US" dirty="0"/>
+          </a:p>
+        </p:txBody>
+      </p:sp>
+      <p:sp>
+        <p:nvSpPr>
+          <p:cNvPr id="4" name="Slide Number Placeholder 3"/>
+          <p:cNvSpPr>
+            <a:spLocks noGrp="1"/>
+          </p:cNvSpPr>
+          <p:nvPr>
+            <p:ph type="sldNum" sz="quarter" idx="10"/>
+          </p:nvPr>
+        </p:nvSpPr>
+        <p:spPr/>
+        <p:txBody>
+          <a:bodyPr/>
+          <a:lstStyle/>
+          <a:p>
+            <a:fld id="{F7021451-1387-4CA6-816F-3879F97B5CBC}" type="slidenum">
+              <a:rPr lang="en-US"/>
+              <a:t>11</a:t>
+            </a:fld>
+            <a:endParaRPr lang="en-US"/>
+          </a:p>
+        </p:txBody>
+      </p:sp>
+    </p:spTree>
+    <p:extLst>
+      <p:ext uri="{BB962C8B-B14F-4D97-AF65-F5344CB8AC3E}">
+        <p14:creationId xmlns:p14="http://schemas.microsoft.com/office/powerpoint/2010/main" val="1024086991"/>
+      </p:ext>
+    </p:extLst>
+  </p:cSld>
+  <p:clrMapOvr>
+    <a:masterClrMapping/>
+  </p:clrMapOvr>
+</p:notes>
+</file>
+
 <file path=ppt/notesSlides/notesSlide2.xml><?xml version="1.0" encoding="utf-8"?>
 <p:notes xmlns:a="http://schemas.openxmlformats.org/drawingml/2006/main" xmlns:r="http://schemas.openxmlformats.org/officeDocument/2006/relationships" xmlns:p="http://schemas.openxmlformats.org/presentationml/2006/main">
   <p:cSld>
@@ -1765,7 +1855,7 @@
           <a:p>
             <a:r>
               <a:rPr lang="en-US" dirty="0"/>
-              <a:t>Siete plantas; seis tienen veredicto de réplica. La Piedad no lo tiene porque Bafar no tiene caso ganado propio. Los dos SÍ quedan condicionados a confirmar la identidad del sitio: sin eso, la composición del destino no está verificada. Ninguna fila asigna trabajo a una persona.</a:t>
+              <a:t>Siete plantas; seis tienen veredicto de réplica. La Piedad no lo tiene porque Bafar no tiene caso ganado propio. El SÍ de Tepeji queda condicionado a confirmar la identidad del sitio. Lagos baja a PARCIAL con el mismo criterio que Toluca: sin áreas verificadas en el destino. Ninguna fila asigna trabajo a una persona.</a:t>
             </a:r>
             <a:endParaRPr lang="en-US" dirty="0"/>
           </a:p>
@@ -3892,7 +3982,7 @@
                           <a:ea typeface="Calibri" pitchFamily="34" charset="-122"/>
                           <a:cs typeface="Calibri" pitchFamily="34" charset="-120"/>
                         </a:rPr>
-                        <a:t>Bafar: 4 complejos productivos; La Piedad; compra de carne a terceros</a:t>
+                        <a:t>Bafar: 4 complejos productivos; La Piedad (Complejo Agroindustrial, 650 mdd); compra de carne a terceros</a:t>
                       </a:r>
                       <a:endParaRPr lang="en-US" sz="1000" dirty="0">
                         <a:latin typeface="Calibri" charset="0"/>
@@ -5531,7 +5621,7 @@
         <p:spPr>
           <a:xfrm>
             <a:off x="548640" y="4846320"/>
-            <a:ext cx="11091672" cy="1463040"/>
+            <a:ext cx="11091672" cy="365760"/>
           </a:xfrm>
           <a:prstGeom prst="rect">
             <a:avLst/>
@@ -5540,17 +5630,14 @@
           <a:ln/>
         </p:spPr>
         <p:txBody>
-          <a:bodyPr wrap="square" lIns="0" tIns="0" rIns="0" bIns="0" rtlCol="0" anchor="t"/>
+          <a:bodyPr wrap="square" lIns="0" tIns="0" rIns="0" bIns="0" rtlCol="0" anchor="ctr"/>
           <a:lstStyle/>
           <a:p>
             <a:pPr indent="0" marL="0">
-              <a:spcAft>
-                <a:spcPts val="200"/>
-              </a:spcAft>
               <a:buNone/>
             </a:pPr>
             <a:r>
-              <a:rPr lang="en-US" sz="1200" b="1" dirty="0">
+              <a:rPr lang="en-US" sz="1200" dirty="0">
                 <a:solidFill>
                   <a:schemeClr val="tx1"/>
                 </a:solidFill>
@@ -5558,63 +5645,9 @@
                 <a:ea typeface="Calibri" pitchFamily="34" charset="-122"/>
                 <a:cs typeface="Calibri" pitchFamily="34" charset="-120"/>
               </a:rPr>
-              <a:t>Oportunidades del CRM citadas fuera de la lámina 5 (Base_Simbiosis.xlsx, hoja DETALLE, Elegible, verificadas el 14-oct-2026; Lost; MXN de potencial anual registrado)</a:t>
+              <a:t>Oportunidades del CRM y declaradas por Marcos: ver apéndice 3.</a:t>
             </a:r>
-            <a:endParaRPr lang="en-US" sz="1100" dirty="0"/>
-          </a:p>
-          <a:p>
-            <a:pPr marL="342900" indent="-342900">
-              <a:buSzPct val="100000"/>
-              <a:buChar char="•"/>
-            </a:pPr>
-            <a:r>
-              <a:rPr lang="en-US" sz="1100" dirty="0">
-                <a:solidFill>
-                  <a:schemeClr val="tx1"/>
-                </a:solidFill>
-                <a:latin typeface="Calibri" pitchFamily="34" charset="0"/>
-                <a:ea typeface="Calibri" pitchFamily="34" charset="-122"/>
-                <a:cs typeface="Calibri" pitchFamily="34" charset="-120"/>
-              </a:rPr>
-              <a:t>O-00218689 · 7.1 PCC C2B-Bachoco Lagos- Bamac Guadalajara · 2020 · 834,766.20</a:t>
-            </a:r>
-            <a:endParaRPr lang="en-US" sz="1100" dirty="0"/>
-          </a:p>
-          <a:p>
-            <a:pPr marL="342900" indent="-342900">
-              <a:buSzPct val="100000"/>
-              <a:buChar char="•"/>
-            </a:pPr>
-            <a:r>
-              <a:rPr lang="en-US" sz="1100" dirty="0">
-                <a:solidFill>
-                  <a:schemeClr val="tx1"/>
-                </a:solidFill>
-                <a:latin typeface="Calibri" pitchFamily="34" charset="0"/>
-                <a:ea typeface="Calibri" pitchFamily="34" charset="-122"/>
-                <a:cs typeface="Calibri" pitchFamily="34" charset="-120"/>
-              </a:rPr>
-              <a:t>566392 · 7.1 TPU Grupo Bafar Chihuahua - Rorisa Chihuahua PT-PU BELTS-566392 · 2023 · 591,804.81</a:t>
-            </a:r>
-            <a:endParaRPr lang="en-US" sz="1100" dirty="0"/>
-          </a:p>
-          <a:p>
-            <a:pPr marL="342900" indent="-342900">
-              <a:buSzPct val="100000"/>
-              <a:buChar char="•"/>
-            </a:pPr>
-            <a:r>
-              <a:rPr lang="en-US" sz="1100" dirty="0">
-                <a:solidFill>
-                  <a:schemeClr val="tx1"/>
-                </a:solidFill>
-                <a:latin typeface="Calibri" pitchFamily="34" charset="0"/>
-                <a:ea typeface="Calibri" pitchFamily="34" charset="-122"/>
-                <a:cs typeface="Calibri" pitchFamily="34" charset="-120"/>
-              </a:rPr>
-              <a:t>656090 · 7.1 - TPU + LINATRIL - Grupo Bafar Chihuahua - Interbandas Chihuahua PT-PU BELTS-656090 · 2023 · 286,935.76</a:t>
-            </a:r>
-            <a:endParaRPr lang="en-US" sz="1100" dirty="0"/>
+            <a:endParaRPr lang="en-US" sz="1200" dirty="0"/>
           </a:p>
         </p:txBody>
       </p:sp>
@@ -5658,6 +5691,3431 @@
             <a:fld id="{F7021451-1387-4CA6-816F-3879F97B5CBC}" type="slidenum">
               <a:rPr b="0" lang="en-US"/>
               <a:t>10</a:t>
+            </a:fld>
+            <a:endParaRPr lang="en-US"/>
+          </a:p>
+        </p:txBody>
+      </p:sp>
+    </p:spTree>
+  </p:cSld>
+  <p:clrMapOvr>
+    <a:masterClrMapping/>
+  </p:clrMapOvr>
+</p:sld>
+</file>
+
+<file path=ppt/slides/slide11.xml><?xml version="1.0" encoding="utf-8"?>
+<p:sld xmlns:a="http://schemas.openxmlformats.org/drawingml/2006/main" xmlns:r="http://schemas.openxmlformats.org/officeDocument/2006/relationships" xmlns:p="http://schemas.openxmlformats.org/presentationml/2006/main">
+  <p:cSld name="Slide 11">
+    <p:spTree>
+      <p:nvGrpSpPr>
+        <p:cNvPr id="1" name=""/>
+        <p:cNvGrpSpPr/>
+        <p:nvPr/>
+      </p:nvGrpSpPr>
+      <p:grpSpPr>
+        <a:xfrm>
+          <a:off x="0" y="0"/>
+          <a:ext cx="0" cy="0"/>
+          <a:chOff x="0" y="0"/>
+          <a:chExt cx="0" cy="0"/>
+        </a:xfrm>
+      </p:grpSpPr>
+      <p:sp>
+        <p:nvSpPr>
+          <p:cNvPr id="2" name="Text 1"/>
+          <p:cNvSpPr/>
+          <p:nvPr>
+            <p:ph idx="101" type="title" hasCustomPrompt="1"/>
+          </p:nvPr>
+        </p:nvSpPr>
+        <p:spPr>
+          <a:xfrm>
+            <a:off x="548640" y="365760"/>
+            <a:ext cx="11091672" cy="822960"/>
+          </a:xfrm>
+          <a:prstGeom prst="rect">
+            <a:avLst/>
+          </a:prstGeom>
+          <a:noFill/>
+          <a:ln/>
+        </p:spPr>
+        <p:txBody>
+          <a:bodyPr wrap="square" lIns="0" tIns="0" rIns="0" bIns="0" rtlCol="0" anchor="t"/>
+          <a:lstStyle/>
+          <a:p>
+            <a:pPr algn="l" indent="0" marL="0">
+              <a:buNone/>
+            </a:pPr>
+            <a:r>
+              <a:rPr lang="en-US" sz="2800" b="1" dirty="0">
+                <a:solidFill>
+                  <a:schemeClr val="tx1"/>
+                </a:solidFill>
+                <a:latin typeface="Cambria" pitchFamily="34" charset="0"/>
+                <a:ea typeface="Cambria" pitchFamily="34" charset="-122"/>
+                <a:cs typeface="Cambria" pitchFamily="34" charset="-120"/>
+              </a:rPr>
+              <a:t>Apéndice 3: oportunidades citadas fuera de la lámina 5</a:t>
+            </a:r>
+            <a:endParaRPr lang="en-US" sz="2800" dirty="0"/>
+          </a:p>
+        </p:txBody>
+      </p:sp>
+      <p:graphicFrame>
+        <p:nvGraphicFramePr>
+          <p:cNvPr id="12" name="Table 0"/>
+          <p:cNvGraphicFramePr>
+            <a:graphicFrameLocks noGrp="1"/>
+          </p:cNvGraphicFramePr>
+          <p:nvPr>
+            <p:extLst>
+              <p:ext uri="{D42A27DB-BD31-4B8C-83A1-F6EECF244321}">
+                <p14:modId xmlns:p14="http://schemas.microsoft.com/office/powerpoint/2010/main" val="1579011935"/>
+              </p:ext>
+            </p:extLst>
+          </p:nvPr>
+        </p:nvGraphicFramePr>
+        <p:xfrm>
+          <a:off x="548640" y="1234440"/>
+          <a:ext cx="11091672" cy="914400"/>
+        </p:xfrm>
+        <a:graphic>
+          <a:graphicData uri="http://schemas.openxmlformats.org/drawingml/2006/table">
+            <a:tbl>
+              <a:tblPr/>
+              <a:tblGrid>
+                <a:gridCol w="4754880"/>
+                <a:gridCol w="1005840"/>
+                <a:gridCol w="1188720"/>
+                <a:gridCol w="1737360"/>
+                <a:gridCol w="2404872"/>
+              </a:tblGrid>
+              <a:tr h="0">
+                <a:tc>
+                  <a:txBody>
+                    <a:bodyPr/>
+                    <a:lstStyle/>
+                    <a:p>
+                      <a:pPr indent="0" marL="0">
+                        <a:buNone/>
+                      </a:pPr>
+                      <a:r>
+                        <a:rPr lang="en-US" sz="1100" b="1" dirty="0">
+                          <a:solidFill>
+                            <a:schemeClr val="bg1"/>
+                          </a:solidFill>
+                          <a:latin typeface="Calibri" pitchFamily="34" charset="0"/>
+                          <a:ea typeface="Calibri" pitchFamily="34" charset="-122"/>
+                          <a:cs typeface="Calibri" pitchFamily="34" charset="-120"/>
+                        </a:rPr>
+                        <a:t>Nomenclatura completa</a:t>
+                      </a:r>
+                      <a:endParaRPr lang="en-US" sz="1100" dirty="0">
+                        <a:latin typeface="Calibri" charset="0"/>
+                        <a:ea typeface="Calibri" charset="0"/>
+                        <a:cs typeface="Calibri" charset="0"/>
+                      </a:endParaRPr>
+                    </a:p>
+                  </a:txBody>
+                  <a:tcPr marL="54864" marR="54864" marT="27432" marB="27432" anchor="ctr">
+                    <a:lnL w="6350" cap="flat" cmpd="sng" algn="ctr">
+                      <a:solidFill>
+                        <a:srgbClr val="D9DEE0"/>
+                      </a:solidFill>
+                      <a:prstDash val="solid"/>
+                      <a:round/>
+                      <a:headEnd type="none" w="med" len="med"/>
+                      <a:tailEnd type="none" w="med" len="med"/>
+                    </a:lnL>
+                    <a:lnR w="6350" cap="flat" cmpd="sng" algn="ctr">
+                      <a:solidFill>
+                        <a:srgbClr val="D9DEE0"/>
+                      </a:solidFill>
+                      <a:prstDash val="solid"/>
+                      <a:round/>
+                      <a:headEnd type="none" w="med" len="med"/>
+                      <a:tailEnd type="none" w="med" len="med"/>
+                    </a:lnR>
+                    <a:lnT w="6350" cap="flat" cmpd="sng" algn="ctr">
+                      <a:solidFill>
+                        <a:srgbClr val="D9DEE0"/>
+                      </a:solidFill>
+                      <a:prstDash val="solid"/>
+                      <a:round/>
+                      <a:headEnd type="none" w="med" len="med"/>
+                      <a:tailEnd type="none" w="med" len="med"/>
+                    </a:lnT>
+                    <a:lnB w="6350" cap="flat" cmpd="sng" algn="ctr">
+                      <a:solidFill>
+                        <a:srgbClr val="D9DEE0"/>
+                      </a:solidFill>
+                      <a:prstDash val="solid"/>
+                      <a:round/>
+                      <a:headEnd type="none" w="med" len="med"/>
+                      <a:tailEnd type="none" w="med" len="med"/>
+                    </a:lnB>
+                    <a:solidFill>
+                      <a:schemeClr val="tx1"/>
+                    </a:solidFill>
+                  </a:tcPr>
+                </a:tc>
+                <a:tc>
+                  <a:txBody>
+                    <a:bodyPr/>
+                    <a:lstStyle/>
+                    <a:p>
+                      <a:pPr indent="0" marL="0">
+                        <a:buNone/>
+                      </a:pPr>
+                      <a:r>
+                        <a:rPr lang="en-US" sz="1100" b="1" dirty="0">
+                          <a:solidFill>
+                            <a:schemeClr val="bg1"/>
+                          </a:solidFill>
+                          <a:latin typeface="Calibri" pitchFamily="34" charset="0"/>
+                          <a:ea typeface="Calibri" pitchFamily="34" charset="-122"/>
+                          <a:cs typeface="Calibri" pitchFamily="34" charset="-120"/>
+                        </a:rPr>
+                        <a:t>N.º</a:t>
+                      </a:r>
+                      <a:endParaRPr lang="en-US" sz="1100" dirty="0">
+                        <a:latin typeface="Calibri" charset="0"/>
+                        <a:ea typeface="Calibri" charset="0"/>
+                        <a:cs typeface="Calibri" charset="0"/>
+                      </a:endParaRPr>
+                    </a:p>
+                  </a:txBody>
+                  <a:tcPr marL="54864" marR="54864" marT="27432" marB="27432" anchor="ctr">
+                    <a:lnL w="6350" cap="flat" cmpd="sng" algn="ctr">
+                      <a:solidFill>
+                        <a:srgbClr val="D9DEE0"/>
+                      </a:solidFill>
+                      <a:prstDash val="solid"/>
+                      <a:round/>
+                      <a:headEnd type="none" w="med" len="med"/>
+                      <a:tailEnd type="none" w="med" len="med"/>
+                    </a:lnL>
+                    <a:lnR w="6350" cap="flat" cmpd="sng" algn="ctr">
+                      <a:solidFill>
+                        <a:srgbClr val="D9DEE0"/>
+                      </a:solidFill>
+                      <a:prstDash val="solid"/>
+                      <a:round/>
+                      <a:headEnd type="none" w="med" len="med"/>
+                      <a:tailEnd type="none" w="med" len="med"/>
+                    </a:lnR>
+                    <a:lnT w="6350" cap="flat" cmpd="sng" algn="ctr">
+                      <a:solidFill>
+                        <a:srgbClr val="D9DEE0"/>
+                      </a:solidFill>
+                      <a:prstDash val="solid"/>
+                      <a:round/>
+                      <a:headEnd type="none" w="med" len="med"/>
+                      <a:tailEnd type="none" w="med" len="med"/>
+                    </a:lnT>
+                    <a:lnB w="6350" cap="flat" cmpd="sng" algn="ctr">
+                      <a:solidFill>
+                        <a:srgbClr val="D9DEE0"/>
+                      </a:solidFill>
+                      <a:prstDash val="solid"/>
+                      <a:round/>
+                      <a:headEnd type="none" w="med" len="med"/>
+                      <a:tailEnd type="none" w="med" len="med"/>
+                    </a:lnB>
+                    <a:solidFill>
+                      <a:schemeClr val="tx1"/>
+                    </a:solidFill>
+                  </a:tcPr>
+                </a:tc>
+                <a:tc>
+                  <a:txBody>
+                    <a:bodyPr/>
+                    <a:lstStyle/>
+                    <a:p>
+                      <a:pPr indent="0" marL="0">
+                        <a:buNone/>
+                      </a:pPr>
+                      <a:r>
+                        <a:rPr lang="en-US" sz="1100" b="1" dirty="0">
+                          <a:solidFill>
+                            <a:schemeClr val="bg1"/>
+                          </a:solidFill>
+                          <a:latin typeface="Calibri" pitchFamily="34" charset="0"/>
+                          <a:ea typeface="Calibri" pitchFamily="34" charset="-122"/>
+                          <a:cs typeface="Calibri" pitchFamily="34" charset="-120"/>
+                        </a:rPr>
+                        <a:t>Estado y año</a:t>
+                      </a:r>
+                      <a:endParaRPr lang="en-US" sz="1100" dirty="0">
+                        <a:latin typeface="Calibri" charset="0"/>
+                        <a:ea typeface="Calibri" charset="0"/>
+                        <a:cs typeface="Calibri" charset="0"/>
+                      </a:endParaRPr>
+                    </a:p>
+                  </a:txBody>
+                  <a:tcPr marL="54864" marR="54864" marT="27432" marB="27432" anchor="ctr">
+                    <a:lnL w="6350" cap="flat" cmpd="sng" algn="ctr">
+                      <a:solidFill>
+                        <a:srgbClr val="D9DEE0"/>
+                      </a:solidFill>
+                      <a:prstDash val="solid"/>
+                      <a:round/>
+                      <a:headEnd type="none" w="med" len="med"/>
+                      <a:tailEnd type="none" w="med" len="med"/>
+                    </a:lnL>
+                    <a:lnR w="6350" cap="flat" cmpd="sng" algn="ctr">
+                      <a:solidFill>
+                        <a:srgbClr val="D9DEE0"/>
+                      </a:solidFill>
+                      <a:prstDash val="solid"/>
+                      <a:round/>
+                      <a:headEnd type="none" w="med" len="med"/>
+                      <a:tailEnd type="none" w="med" len="med"/>
+                    </a:lnR>
+                    <a:lnT w="6350" cap="flat" cmpd="sng" algn="ctr">
+                      <a:solidFill>
+                        <a:srgbClr val="D9DEE0"/>
+                      </a:solidFill>
+                      <a:prstDash val="solid"/>
+                      <a:round/>
+                      <a:headEnd type="none" w="med" len="med"/>
+                      <a:tailEnd type="none" w="med" len="med"/>
+                    </a:lnT>
+                    <a:lnB w="6350" cap="flat" cmpd="sng" algn="ctr">
+                      <a:solidFill>
+                        <a:srgbClr val="D9DEE0"/>
+                      </a:solidFill>
+                      <a:prstDash val="solid"/>
+                      <a:round/>
+                      <a:headEnd type="none" w="med" len="med"/>
+                      <a:tailEnd type="none" w="med" len="med"/>
+                    </a:lnB>
+                    <a:solidFill>
+                      <a:schemeClr val="tx1"/>
+                    </a:solidFill>
+                  </a:tcPr>
+                </a:tc>
+                <a:tc>
+                  <a:txBody>
+                    <a:bodyPr/>
+                    <a:lstStyle/>
+                    <a:p>
+                      <a:pPr indent="0" marL="0">
+                        <a:buNone/>
+                      </a:pPr>
+                      <a:r>
+                        <a:rPr lang="en-US" sz="1100" b="1" dirty="0">
+                          <a:solidFill>
+                            <a:schemeClr val="bg1"/>
+                          </a:solidFill>
+                          <a:latin typeface="Calibri" pitchFamily="34" charset="0"/>
+                          <a:ea typeface="Calibri" pitchFamily="34" charset="-122"/>
+                          <a:cs typeface="Calibri" pitchFamily="34" charset="-120"/>
+                        </a:rPr>
+                        <a:t>MXN (potencial anual registrado)</a:t>
+                      </a:r>
+                      <a:endParaRPr lang="en-US" sz="1100" dirty="0">
+                        <a:latin typeface="Calibri" charset="0"/>
+                        <a:ea typeface="Calibri" charset="0"/>
+                        <a:cs typeface="Calibri" charset="0"/>
+                      </a:endParaRPr>
+                    </a:p>
+                  </a:txBody>
+                  <a:tcPr marL="54864" marR="54864" marT="27432" marB="27432" anchor="ctr">
+                    <a:lnL w="6350" cap="flat" cmpd="sng" algn="ctr">
+                      <a:solidFill>
+                        <a:srgbClr val="D9DEE0"/>
+                      </a:solidFill>
+                      <a:prstDash val="solid"/>
+                      <a:round/>
+                      <a:headEnd type="none" w="med" len="med"/>
+                      <a:tailEnd type="none" w="med" len="med"/>
+                    </a:lnL>
+                    <a:lnR w="6350" cap="flat" cmpd="sng" algn="ctr">
+                      <a:solidFill>
+                        <a:srgbClr val="D9DEE0"/>
+                      </a:solidFill>
+                      <a:prstDash val="solid"/>
+                      <a:round/>
+                      <a:headEnd type="none" w="med" len="med"/>
+                      <a:tailEnd type="none" w="med" len="med"/>
+                    </a:lnR>
+                    <a:lnT w="6350" cap="flat" cmpd="sng" algn="ctr">
+                      <a:solidFill>
+                        <a:srgbClr val="D9DEE0"/>
+                      </a:solidFill>
+                      <a:prstDash val="solid"/>
+                      <a:round/>
+                      <a:headEnd type="none" w="med" len="med"/>
+                      <a:tailEnd type="none" w="med" len="med"/>
+                    </a:lnT>
+                    <a:lnB w="6350" cap="flat" cmpd="sng" algn="ctr">
+                      <a:solidFill>
+                        <a:srgbClr val="D9DEE0"/>
+                      </a:solidFill>
+                      <a:prstDash val="solid"/>
+                      <a:round/>
+                      <a:headEnd type="none" w="med" len="med"/>
+                      <a:tailEnd type="none" w="med" len="med"/>
+                    </a:lnB>
+                    <a:solidFill>
+                      <a:schemeClr val="tx1"/>
+                    </a:solidFill>
+                  </a:tcPr>
+                </a:tc>
+                <a:tc>
+                  <a:txBody>
+                    <a:bodyPr/>
+                    <a:lstStyle/>
+                    <a:p>
+                      <a:pPr indent="0" marL="0">
+                        <a:buNone/>
+                      </a:pPr>
+                      <a:r>
+                        <a:rPr lang="en-US" sz="1100" b="1" dirty="0">
+                          <a:solidFill>
+                            <a:schemeClr val="bg1"/>
+                          </a:solidFill>
+                          <a:latin typeface="Calibri" pitchFamily="34" charset="0"/>
+                          <a:ea typeface="Calibri" pitchFamily="34" charset="-122"/>
+                          <a:cs typeface="Calibri" pitchFamily="34" charset="-120"/>
+                        </a:rPr>
+                        <a:t>Canal / nota</a:t>
+                      </a:r>
+                      <a:endParaRPr lang="en-US" sz="1100" dirty="0">
+                        <a:latin typeface="Calibri" charset="0"/>
+                        <a:ea typeface="Calibri" charset="0"/>
+                        <a:cs typeface="Calibri" charset="0"/>
+                      </a:endParaRPr>
+                    </a:p>
+                  </a:txBody>
+                  <a:tcPr marL="54864" marR="54864" marT="27432" marB="27432" anchor="ctr">
+                    <a:lnL w="6350" cap="flat" cmpd="sng" algn="ctr">
+                      <a:solidFill>
+                        <a:srgbClr val="D9DEE0"/>
+                      </a:solidFill>
+                      <a:prstDash val="solid"/>
+                      <a:round/>
+                      <a:headEnd type="none" w="med" len="med"/>
+                      <a:tailEnd type="none" w="med" len="med"/>
+                    </a:lnL>
+                    <a:lnR w="6350" cap="flat" cmpd="sng" algn="ctr">
+                      <a:solidFill>
+                        <a:srgbClr val="D9DEE0"/>
+                      </a:solidFill>
+                      <a:prstDash val="solid"/>
+                      <a:round/>
+                      <a:headEnd type="none" w="med" len="med"/>
+                      <a:tailEnd type="none" w="med" len="med"/>
+                    </a:lnR>
+                    <a:lnT w="6350" cap="flat" cmpd="sng" algn="ctr">
+                      <a:solidFill>
+                        <a:srgbClr val="D9DEE0"/>
+                      </a:solidFill>
+                      <a:prstDash val="solid"/>
+                      <a:round/>
+                      <a:headEnd type="none" w="med" len="med"/>
+                      <a:tailEnd type="none" w="med" len="med"/>
+                    </a:lnT>
+                    <a:lnB w="6350" cap="flat" cmpd="sng" algn="ctr">
+                      <a:solidFill>
+                        <a:srgbClr val="D9DEE0"/>
+                      </a:solidFill>
+                      <a:prstDash val="solid"/>
+                      <a:round/>
+                      <a:headEnd type="none" w="med" len="med"/>
+                      <a:tailEnd type="none" w="med" len="med"/>
+                    </a:lnB>
+                    <a:solidFill>
+                      <a:schemeClr val="tx1"/>
+                    </a:solidFill>
+                  </a:tcPr>
+                </a:tc>
+              </a:tr>
+              <a:tr h="0">
+                <a:tc gridSpan="5">
+                  <a:txBody>
+                    <a:bodyPr/>
+                    <a:lstStyle/>
+                    <a:p>
+                      <a:pPr indent="0" marL="0">
+                        <a:buNone/>
+                      </a:pPr>
+                      <a:r>
+                        <a:rPr lang="en-US" sz="1100" b="1" dirty="0">
+                          <a:solidFill>
+                            <a:schemeClr val="tx1"/>
+                          </a:solidFill>
+                          <a:latin typeface="Calibri" pitchFamily="34" charset="0"/>
+                          <a:ea typeface="Calibri" pitchFamily="34" charset="-122"/>
+                          <a:cs typeface="Calibri" pitchFamily="34" charset="-120"/>
+                        </a:rPr>
+                        <a:t>En Base_Simbiosis.xlsx (hoja DETALLE, Elegible), verificadas el 14-oct-2026; año = Año cierre</a:t>
+                      </a:r>
+                      <a:endParaRPr lang="en-US" sz="1100" dirty="0">
+                        <a:latin typeface="Calibri" charset="0"/>
+                        <a:ea typeface="Calibri" charset="0"/>
+                        <a:cs typeface="Calibri" charset="0"/>
+                      </a:endParaRPr>
+                    </a:p>
+                  </a:txBody>
+                  <a:tcPr marL="54864" marR="54864" marT="27432" marB="27432">
+                    <a:lnL w="6350" cap="flat" cmpd="sng" algn="ctr">
+                      <a:solidFill>
+                        <a:srgbClr val="D9DEE0"/>
+                      </a:solidFill>
+                      <a:prstDash val="solid"/>
+                      <a:round/>
+                      <a:headEnd type="none" w="med" len="med"/>
+                      <a:tailEnd type="none" w="med" len="med"/>
+                    </a:lnL>
+                    <a:lnR w="6350" cap="flat" cmpd="sng" algn="ctr">
+                      <a:solidFill>
+                        <a:srgbClr val="D9DEE0"/>
+                      </a:solidFill>
+                      <a:prstDash val="solid"/>
+                      <a:round/>
+                      <a:headEnd type="none" w="med" len="med"/>
+                      <a:tailEnd type="none" w="med" len="med"/>
+                    </a:lnR>
+                    <a:lnT w="6350" cap="flat" cmpd="sng" algn="ctr">
+                      <a:solidFill>
+                        <a:srgbClr val="D9DEE0"/>
+                      </a:solidFill>
+                      <a:prstDash val="solid"/>
+                      <a:round/>
+                      <a:headEnd type="none" w="med" len="med"/>
+                      <a:tailEnd type="none" w="med" len="med"/>
+                    </a:lnT>
+                    <a:lnB w="6350" cap="flat" cmpd="sng" algn="ctr">
+                      <a:solidFill>
+                        <a:srgbClr val="D9DEE0"/>
+                      </a:solidFill>
+                      <a:prstDash val="solid"/>
+                      <a:round/>
+                      <a:headEnd type="none" w="med" len="med"/>
+                      <a:tailEnd type="none" w="med" len="med"/>
+                    </a:lnB>
+                    <a:solidFill>
+                      <a:schemeClr val="bg2"/>
+                    </a:solidFill>
+                  </a:tcPr>
+                </a:tc>
+                <a:tc hMerge="1">
+                  <a:tcPr/>
+                </a:tc>
+                <a:tc hMerge="1">
+                  <a:tcPr/>
+                </a:tc>
+                <a:tc hMerge="1">
+                  <a:tcPr/>
+                </a:tc>
+                <a:tc hMerge="1">
+                  <a:tcPr/>
+                </a:tc>
+              </a:tr>
+              <a:tr h="0">
+                <a:tc>
+                  <a:txBody>
+                    <a:bodyPr/>
+                    <a:lstStyle/>
+                    <a:p>
+                      <a:pPr indent="0" marL="0">
+                        <a:buNone/>
+                      </a:pPr>
+                      <a:r>
+                        <a:rPr lang="en-US" sz="1000" dirty="0">
+                          <a:solidFill>
+                            <a:schemeClr val="tx1"/>
+                          </a:solidFill>
+                          <a:latin typeface="Calibri" pitchFamily="34" charset="0"/>
+                          <a:ea typeface="Calibri" pitchFamily="34" charset="-122"/>
+                          <a:cs typeface="Calibri" pitchFamily="34" charset="-120"/>
+                        </a:rPr>
+                        <a:t>7.1 PCC C2B-Bachoco Lagos- Bamac Guadalajara</a:t>
+                      </a:r>
+                      <a:endParaRPr lang="en-US" sz="1000" dirty="0">
+                        <a:latin typeface="Calibri" charset="0"/>
+                        <a:ea typeface="Calibri" charset="0"/>
+                        <a:cs typeface="Calibri" charset="0"/>
+                      </a:endParaRPr>
+                    </a:p>
+                  </a:txBody>
+                  <a:tcPr marL="54864" marR="54864" marT="27432" marB="27432" anchor="t">
+                    <a:lnL w="6350" cap="flat" cmpd="sng" algn="ctr">
+                      <a:solidFill>
+                        <a:srgbClr val="D9DEE0"/>
+                      </a:solidFill>
+                      <a:prstDash val="solid"/>
+                      <a:round/>
+                      <a:headEnd type="none" w="med" len="med"/>
+                      <a:tailEnd type="none" w="med" len="med"/>
+                    </a:lnL>
+                    <a:lnR w="6350" cap="flat" cmpd="sng" algn="ctr">
+                      <a:solidFill>
+                        <a:srgbClr val="D9DEE0"/>
+                      </a:solidFill>
+                      <a:prstDash val="solid"/>
+                      <a:round/>
+                      <a:headEnd type="none" w="med" len="med"/>
+                      <a:tailEnd type="none" w="med" len="med"/>
+                    </a:lnR>
+                    <a:lnT w="6350" cap="flat" cmpd="sng" algn="ctr">
+                      <a:solidFill>
+                        <a:srgbClr val="D9DEE0"/>
+                      </a:solidFill>
+                      <a:prstDash val="solid"/>
+                      <a:round/>
+                      <a:headEnd type="none" w="med" len="med"/>
+                      <a:tailEnd type="none" w="med" len="med"/>
+                    </a:lnT>
+                    <a:lnB w="6350" cap="flat" cmpd="sng" algn="ctr">
+                      <a:solidFill>
+                        <a:srgbClr val="D9DEE0"/>
+                      </a:solidFill>
+                      <a:prstDash val="solid"/>
+                      <a:round/>
+                      <a:headEnd type="none" w="med" len="med"/>
+                      <a:tailEnd type="none" w="med" len="med"/>
+                    </a:lnB>
+                    <a:solidFill>
+                      <a:schemeClr val="bg1"/>
+                    </a:solidFill>
+                  </a:tcPr>
+                </a:tc>
+                <a:tc>
+                  <a:txBody>
+                    <a:bodyPr/>
+                    <a:lstStyle/>
+                    <a:p>
+                      <a:pPr indent="0" marL="0">
+                        <a:buNone/>
+                      </a:pPr>
+                      <a:r>
+                        <a:rPr lang="en-US" sz="1000" dirty="0">
+                          <a:solidFill>
+                            <a:schemeClr val="tx1"/>
+                          </a:solidFill>
+                          <a:latin typeface="Calibri" pitchFamily="34" charset="0"/>
+                          <a:ea typeface="Calibri" pitchFamily="34" charset="-122"/>
+                          <a:cs typeface="Calibri" pitchFamily="34" charset="-120"/>
+                        </a:rPr>
+                        <a:t>O-00218689</a:t>
+                      </a:r>
+                      <a:endParaRPr lang="en-US" sz="1000" dirty="0">
+                        <a:latin typeface="Calibri" charset="0"/>
+                        <a:ea typeface="Calibri" charset="0"/>
+                        <a:cs typeface="Calibri" charset="0"/>
+                      </a:endParaRPr>
+                    </a:p>
+                  </a:txBody>
+                  <a:tcPr marL="54864" marR="54864" marT="27432" marB="27432" anchor="t">
+                    <a:lnL w="6350" cap="flat" cmpd="sng" algn="ctr">
+                      <a:solidFill>
+                        <a:srgbClr val="D9DEE0"/>
+                      </a:solidFill>
+                      <a:prstDash val="solid"/>
+                      <a:round/>
+                      <a:headEnd type="none" w="med" len="med"/>
+                      <a:tailEnd type="none" w="med" len="med"/>
+                    </a:lnL>
+                    <a:lnR w="6350" cap="flat" cmpd="sng" algn="ctr">
+                      <a:solidFill>
+                        <a:srgbClr val="D9DEE0"/>
+                      </a:solidFill>
+                      <a:prstDash val="solid"/>
+                      <a:round/>
+                      <a:headEnd type="none" w="med" len="med"/>
+                      <a:tailEnd type="none" w="med" len="med"/>
+                    </a:lnR>
+                    <a:lnT w="6350" cap="flat" cmpd="sng" algn="ctr">
+                      <a:solidFill>
+                        <a:srgbClr val="D9DEE0"/>
+                      </a:solidFill>
+                      <a:prstDash val="solid"/>
+                      <a:round/>
+                      <a:headEnd type="none" w="med" len="med"/>
+                      <a:tailEnd type="none" w="med" len="med"/>
+                    </a:lnT>
+                    <a:lnB w="6350" cap="flat" cmpd="sng" algn="ctr">
+                      <a:solidFill>
+                        <a:srgbClr val="D9DEE0"/>
+                      </a:solidFill>
+                      <a:prstDash val="solid"/>
+                      <a:round/>
+                      <a:headEnd type="none" w="med" len="med"/>
+                      <a:tailEnd type="none" w="med" len="med"/>
+                    </a:lnB>
+                    <a:solidFill>
+                      <a:schemeClr val="bg1"/>
+                    </a:solidFill>
+                  </a:tcPr>
+                </a:tc>
+                <a:tc>
+                  <a:txBody>
+                    <a:bodyPr/>
+                    <a:lstStyle/>
+                    <a:p>
+                      <a:pPr indent="0" marL="0">
+                        <a:buNone/>
+                      </a:pPr>
+                      <a:r>
+                        <a:rPr lang="en-US" sz="1000" dirty="0">
+                          <a:solidFill>
+                            <a:schemeClr val="tx1"/>
+                          </a:solidFill>
+                          <a:latin typeface="Calibri" pitchFamily="34" charset="0"/>
+                          <a:ea typeface="Calibri" pitchFamily="34" charset="-122"/>
+                          <a:cs typeface="Calibri" pitchFamily="34" charset="-120"/>
+                        </a:rPr>
+                        <a:t>Lost 2020</a:t>
+                      </a:r>
+                      <a:endParaRPr lang="en-US" sz="1000" dirty="0">
+                        <a:latin typeface="Calibri" charset="0"/>
+                        <a:ea typeface="Calibri" charset="0"/>
+                        <a:cs typeface="Calibri" charset="0"/>
+                      </a:endParaRPr>
+                    </a:p>
+                  </a:txBody>
+                  <a:tcPr marL="54864" marR="54864" marT="27432" marB="27432" anchor="t">
+                    <a:lnL w="6350" cap="flat" cmpd="sng" algn="ctr">
+                      <a:solidFill>
+                        <a:srgbClr val="D9DEE0"/>
+                      </a:solidFill>
+                      <a:prstDash val="solid"/>
+                      <a:round/>
+                      <a:headEnd type="none" w="med" len="med"/>
+                      <a:tailEnd type="none" w="med" len="med"/>
+                    </a:lnL>
+                    <a:lnR w="6350" cap="flat" cmpd="sng" algn="ctr">
+                      <a:solidFill>
+                        <a:srgbClr val="D9DEE0"/>
+                      </a:solidFill>
+                      <a:prstDash val="solid"/>
+                      <a:round/>
+                      <a:headEnd type="none" w="med" len="med"/>
+                      <a:tailEnd type="none" w="med" len="med"/>
+                    </a:lnR>
+                    <a:lnT w="6350" cap="flat" cmpd="sng" algn="ctr">
+                      <a:solidFill>
+                        <a:srgbClr val="D9DEE0"/>
+                      </a:solidFill>
+                      <a:prstDash val="solid"/>
+                      <a:round/>
+                      <a:headEnd type="none" w="med" len="med"/>
+                      <a:tailEnd type="none" w="med" len="med"/>
+                    </a:lnT>
+                    <a:lnB w="6350" cap="flat" cmpd="sng" algn="ctr">
+                      <a:solidFill>
+                        <a:srgbClr val="D9DEE0"/>
+                      </a:solidFill>
+                      <a:prstDash val="solid"/>
+                      <a:round/>
+                      <a:headEnd type="none" w="med" len="med"/>
+                      <a:tailEnd type="none" w="med" len="med"/>
+                    </a:lnB>
+                    <a:solidFill>
+                      <a:schemeClr val="bg1"/>
+                    </a:solidFill>
+                  </a:tcPr>
+                </a:tc>
+                <a:tc>
+                  <a:txBody>
+                    <a:bodyPr/>
+                    <a:lstStyle/>
+                    <a:p>
+                      <a:pPr indent="0" marL="0">
+                        <a:buNone/>
+                      </a:pPr>
+                      <a:r>
+                        <a:rPr lang="en-US" sz="1000" dirty="0">
+                          <a:solidFill>
+                            <a:schemeClr val="tx1"/>
+                          </a:solidFill>
+                          <a:latin typeface="Calibri" pitchFamily="34" charset="0"/>
+                          <a:ea typeface="Calibri" pitchFamily="34" charset="-122"/>
+                          <a:cs typeface="Calibri" pitchFamily="34" charset="-120"/>
+                        </a:rPr>
+                        <a:t>834,766.20</a:t>
+                      </a:r>
+                      <a:endParaRPr lang="en-US" sz="1000" dirty="0">
+                        <a:latin typeface="Calibri" charset="0"/>
+                        <a:ea typeface="Calibri" charset="0"/>
+                        <a:cs typeface="Calibri" charset="0"/>
+                      </a:endParaRPr>
+                    </a:p>
+                  </a:txBody>
+                  <a:tcPr marL="54864" marR="54864" marT="27432" marB="27432" anchor="t">
+                    <a:lnL w="6350" cap="flat" cmpd="sng" algn="ctr">
+                      <a:solidFill>
+                        <a:srgbClr val="D9DEE0"/>
+                      </a:solidFill>
+                      <a:prstDash val="solid"/>
+                      <a:round/>
+                      <a:headEnd type="none" w="med" len="med"/>
+                      <a:tailEnd type="none" w="med" len="med"/>
+                    </a:lnL>
+                    <a:lnR w="6350" cap="flat" cmpd="sng" algn="ctr">
+                      <a:solidFill>
+                        <a:srgbClr val="D9DEE0"/>
+                      </a:solidFill>
+                      <a:prstDash val="solid"/>
+                      <a:round/>
+                      <a:headEnd type="none" w="med" len="med"/>
+                      <a:tailEnd type="none" w="med" len="med"/>
+                    </a:lnR>
+                    <a:lnT w="6350" cap="flat" cmpd="sng" algn="ctr">
+                      <a:solidFill>
+                        <a:srgbClr val="D9DEE0"/>
+                      </a:solidFill>
+                      <a:prstDash val="solid"/>
+                      <a:round/>
+                      <a:headEnd type="none" w="med" len="med"/>
+                      <a:tailEnd type="none" w="med" len="med"/>
+                    </a:lnT>
+                    <a:lnB w="6350" cap="flat" cmpd="sng" algn="ctr">
+                      <a:solidFill>
+                        <a:srgbClr val="D9DEE0"/>
+                      </a:solidFill>
+                      <a:prstDash val="solid"/>
+                      <a:round/>
+                      <a:headEnd type="none" w="med" len="med"/>
+                      <a:tailEnd type="none" w="med" len="med"/>
+                    </a:lnB>
+                    <a:solidFill>
+                      <a:schemeClr val="bg1"/>
+                    </a:solidFill>
+                  </a:tcPr>
+                </a:tc>
+                <a:tc>
+                  <a:txBody>
+                    <a:bodyPr/>
+                    <a:lstStyle/>
+                    <a:p>
+                      <a:pPr indent="0" marL="0">
+                        <a:buNone/>
+                      </a:pPr>
+                      <a:r>
+                        <a:rPr lang="en-US" sz="1000" dirty="0">
+                          <a:solidFill>
+                            <a:schemeClr val="tx1"/>
+                          </a:solidFill>
+                          <a:latin typeface="Calibri" pitchFamily="34" charset="0"/>
+                          <a:ea typeface="Calibri" pitchFamily="34" charset="-122"/>
+                          <a:cs typeface="Calibri" pitchFamily="34" charset="-120"/>
+                        </a:rPr>
+                        <a:t>Bamac: canal</a:t>
+                      </a:r>
+                      <a:endParaRPr lang="en-US" sz="1000" dirty="0">
+                        <a:latin typeface="Calibri" charset="0"/>
+                        <a:ea typeface="Calibri" charset="0"/>
+                        <a:cs typeface="Calibri" charset="0"/>
+                      </a:endParaRPr>
+                    </a:p>
+                  </a:txBody>
+                  <a:tcPr marL="54864" marR="54864" marT="27432" marB="27432" anchor="t">
+                    <a:lnL w="6350" cap="flat" cmpd="sng" algn="ctr">
+                      <a:solidFill>
+                        <a:srgbClr val="D9DEE0"/>
+                      </a:solidFill>
+                      <a:prstDash val="solid"/>
+                      <a:round/>
+                      <a:headEnd type="none" w="med" len="med"/>
+                      <a:tailEnd type="none" w="med" len="med"/>
+                    </a:lnL>
+                    <a:lnR w="6350" cap="flat" cmpd="sng" algn="ctr">
+                      <a:solidFill>
+                        <a:srgbClr val="D9DEE0"/>
+                      </a:solidFill>
+                      <a:prstDash val="solid"/>
+                      <a:round/>
+                      <a:headEnd type="none" w="med" len="med"/>
+                      <a:tailEnd type="none" w="med" len="med"/>
+                    </a:lnR>
+                    <a:lnT w="6350" cap="flat" cmpd="sng" algn="ctr">
+                      <a:solidFill>
+                        <a:srgbClr val="D9DEE0"/>
+                      </a:solidFill>
+                      <a:prstDash val="solid"/>
+                      <a:round/>
+                      <a:headEnd type="none" w="med" len="med"/>
+                      <a:tailEnd type="none" w="med" len="med"/>
+                    </a:lnT>
+                    <a:lnB w="6350" cap="flat" cmpd="sng" algn="ctr">
+                      <a:solidFill>
+                        <a:srgbClr val="D9DEE0"/>
+                      </a:solidFill>
+                      <a:prstDash val="solid"/>
+                      <a:round/>
+                      <a:headEnd type="none" w="med" len="med"/>
+                      <a:tailEnd type="none" w="med" len="med"/>
+                    </a:lnB>
+                    <a:solidFill>
+                      <a:schemeClr val="bg1"/>
+                    </a:solidFill>
+                  </a:tcPr>
+                </a:tc>
+              </a:tr>
+              <a:tr h="0">
+                <a:tc>
+                  <a:txBody>
+                    <a:bodyPr/>
+                    <a:lstStyle/>
+                    <a:p>
+                      <a:pPr indent="0" marL="0">
+                        <a:buNone/>
+                      </a:pPr>
+                      <a:r>
+                        <a:rPr lang="en-US" sz="1000" dirty="0">
+                          <a:solidFill>
+                            <a:schemeClr val="tx1"/>
+                          </a:solidFill>
+                          <a:latin typeface="Calibri" pitchFamily="34" charset="0"/>
+                          <a:ea typeface="Calibri" pitchFamily="34" charset="-122"/>
+                          <a:cs typeface="Calibri" pitchFamily="34" charset="-120"/>
+                        </a:rPr>
+                        <a:t>7.1 TPU Grupo Bafar Chihuahua - Rorisa Chihuahua PT-PU BELTS-566392</a:t>
+                      </a:r>
+                      <a:endParaRPr lang="en-US" sz="1000" dirty="0">
+                        <a:latin typeface="Calibri" charset="0"/>
+                        <a:ea typeface="Calibri" charset="0"/>
+                        <a:cs typeface="Calibri" charset="0"/>
+                      </a:endParaRPr>
+                    </a:p>
+                  </a:txBody>
+                  <a:tcPr marL="54864" marR="54864" marT="27432" marB="27432" anchor="t">
+                    <a:lnL w="6350" cap="flat" cmpd="sng" algn="ctr">
+                      <a:solidFill>
+                        <a:srgbClr val="D9DEE0"/>
+                      </a:solidFill>
+                      <a:prstDash val="solid"/>
+                      <a:round/>
+                      <a:headEnd type="none" w="med" len="med"/>
+                      <a:tailEnd type="none" w="med" len="med"/>
+                    </a:lnL>
+                    <a:lnR w="6350" cap="flat" cmpd="sng" algn="ctr">
+                      <a:solidFill>
+                        <a:srgbClr val="D9DEE0"/>
+                      </a:solidFill>
+                      <a:prstDash val="solid"/>
+                      <a:round/>
+                      <a:headEnd type="none" w="med" len="med"/>
+                      <a:tailEnd type="none" w="med" len="med"/>
+                    </a:lnR>
+                    <a:lnT w="6350" cap="flat" cmpd="sng" algn="ctr">
+                      <a:solidFill>
+                        <a:srgbClr val="D9DEE0"/>
+                      </a:solidFill>
+                      <a:prstDash val="solid"/>
+                      <a:round/>
+                      <a:headEnd type="none" w="med" len="med"/>
+                      <a:tailEnd type="none" w="med" len="med"/>
+                    </a:lnT>
+                    <a:lnB w="6350" cap="flat" cmpd="sng" algn="ctr">
+                      <a:solidFill>
+                        <a:srgbClr val="D9DEE0"/>
+                      </a:solidFill>
+                      <a:prstDash val="solid"/>
+                      <a:round/>
+                      <a:headEnd type="none" w="med" len="med"/>
+                      <a:tailEnd type="none" w="med" len="med"/>
+                    </a:lnB>
+                    <a:solidFill>
+                      <a:schemeClr val="bg1"/>
+                    </a:solidFill>
+                  </a:tcPr>
+                </a:tc>
+                <a:tc>
+                  <a:txBody>
+                    <a:bodyPr/>
+                    <a:lstStyle/>
+                    <a:p>
+                      <a:pPr indent="0" marL="0">
+                        <a:buNone/>
+                      </a:pPr>
+                      <a:r>
+                        <a:rPr lang="en-US" sz="1000" dirty="0">
+                          <a:solidFill>
+                            <a:schemeClr val="tx1"/>
+                          </a:solidFill>
+                          <a:latin typeface="Calibri" pitchFamily="34" charset="0"/>
+                          <a:ea typeface="Calibri" pitchFamily="34" charset="-122"/>
+                          <a:cs typeface="Calibri" pitchFamily="34" charset="-120"/>
+                        </a:rPr>
+                        <a:t>566392</a:t>
+                      </a:r>
+                      <a:endParaRPr lang="en-US" sz="1000" dirty="0">
+                        <a:latin typeface="Calibri" charset="0"/>
+                        <a:ea typeface="Calibri" charset="0"/>
+                        <a:cs typeface="Calibri" charset="0"/>
+                      </a:endParaRPr>
+                    </a:p>
+                  </a:txBody>
+                  <a:tcPr marL="54864" marR="54864" marT="27432" marB="27432" anchor="t">
+                    <a:lnL w="6350" cap="flat" cmpd="sng" algn="ctr">
+                      <a:solidFill>
+                        <a:srgbClr val="D9DEE0"/>
+                      </a:solidFill>
+                      <a:prstDash val="solid"/>
+                      <a:round/>
+                      <a:headEnd type="none" w="med" len="med"/>
+                      <a:tailEnd type="none" w="med" len="med"/>
+                    </a:lnL>
+                    <a:lnR w="6350" cap="flat" cmpd="sng" algn="ctr">
+                      <a:solidFill>
+                        <a:srgbClr val="D9DEE0"/>
+                      </a:solidFill>
+                      <a:prstDash val="solid"/>
+                      <a:round/>
+                      <a:headEnd type="none" w="med" len="med"/>
+                      <a:tailEnd type="none" w="med" len="med"/>
+                    </a:lnR>
+                    <a:lnT w="6350" cap="flat" cmpd="sng" algn="ctr">
+                      <a:solidFill>
+                        <a:srgbClr val="D9DEE0"/>
+                      </a:solidFill>
+                      <a:prstDash val="solid"/>
+                      <a:round/>
+                      <a:headEnd type="none" w="med" len="med"/>
+                      <a:tailEnd type="none" w="med" len="med"/>
+                    </a:lnT>
+                    <a:lnB w="6350" cap="flat" cmpd="sng" algn="ctr">
+                      <a:solidFill>
+                        <a:srgbClr val="D9DEE0"/>
+                      </a:solidFill>
+                      <a:prstDash val="solid"/>
+                      <a:round/>
+                      <a:headEnd type="none" w="med" len="med"/>
+                      <a:tailEnd type="none" w="med" len="med"/>
+                    </a:lnB>
+                    <a:solidFill>
+                      <a:schemeClr val="bg1"/>
+                    </a:solidFill>
+                  </a:tcPr>
+                </a:tc>
+                <a:tc>
+                  <a:txBody>
+                    <a:bodyPr/>
+                    <a:lstStyle/>
+                    <a:p>
+                      <a:pPr indent="0" marL="0">
+                        <a:buNone/>
+                      </a:pPr>
+                      <a:r>
+                        <a:rPr lang="en-US" sz="1000" dirty="0">
+                          <a:solidFill>
+                            <a:schemeClr val="tx1"/>
+                          </a:solidFill>
+                          <a:latin typeface="Calibri" pitchFamily="34" charset="0"/>
+                          <a:ea typeface="Calibri" pitchFamily="34" charset="-122"/>
+                          <a:cs typeface="Calibri" pitchFamily="34" charset="-120"/>
+                        </a:rPr>
+                        <a:t>Lost 2023</a:t>
+                      </a:r>
+                      <a:endParaRPr lang="en-US" sz="1000" dirty="0">
+                        <a:latin typeface="Calibri" charset="0"/>
+                        <a:ea typeface="Calibri" charset="0"/>
+                        <a:cs typeface="Calibri" charset="0"/>
+                      </a:endParaRPr>
+                    </a:p>
+                  </a:txBody>
+                  <a:tcPr marL="54864" marR="54864" marT="27432" marB="27432" anchor="t">
+                    <a:lnL w="6350" cap="flat" cmpd="sng" algn="ctr">
+                      <a:solidFill>
+                        <a:srgbClr val="D9DEE0"/>
+                      </a:solidFill>
+                      <a:prstDash val="solid"/>
+                      <a:round/>
+                      <a:headEnd type="none" w="med" len="med"/>
+                      <a:tailEnd type="none" w="med" len="med"/>
+                    </a:lnL>
+                    <a:lnR w="6350" cap="flat" cmpd="sng" algn="ctr">
+                      <a:solidFill>
+                        <a:srgbClr val="D9DEE0"/>
+                      </a:solidFill>
+                      <a:prstDash val="solid"/>
+                      <a:round/>
+                      <a:headEnd type="none" w="med" len="med"/>
+                      <a:tailEnd type="none" w="med" len="med"/>
+                    </a:lnR>
+                    <a:lnT w="6350" cap="flat" cmpd="sng" algn="ctr">
+                      <a:solidFill>
+                        <a:srgbClr val="D9DEE0"/>
+                      </a:solidFill>
+                      <a:prstDash val="solid"/>
+                      <a:round/>
+                      <a:headEnd type="none" w="med" len="med"/>
+                      <a:tailEnd type="none" w="med" len="med"/>
+                    </a:lnT>
+                    <a:lnB w="6350" cap="flat" cmpd="sng" algn="ctr">
+                      <a:solidFill>
+                        <a:srgbClr val="D9DEE0"/>
+                      </a:solidFill>
+                      <a:prstDash val="solid"/>
+                      <a:round/>
+                      <a:headEnd type="none" w="med" len="med"/>
+                      <a:tailEnd type="none" w="med" len="med"/>
+                    </a:lnB>
+                    <a:solidFill>
+                      <a:schemeClr val="bg1"/>
+                    </a:solidFill>
+                  </a:tcPr>
+                </a:tc>
+                <a:tc>
+                  <a:txBody>
+                    <a:bodyPr/>
+                    <a:lstStyle/>
+                    <a:p>
+                      <a:pPr indent="0" marL="0">
+                        <a:buNone/>
+                      </a:pPr>
+                      <a:r>
+                        <a:rPr lang="en-US" sz="1000" dirty="0">
+                          <a:solidFill>
+                            <a:schemeClr val="tx1"/>
+                          </a:solidFill>
+                          <a:latin typeface="Calibri" pitchFamily="34" charset="0"/>
+                          <a:ea typeface="Calibri" pitchFamily="34" charset="-122"/>
+                          <a:cs typeface="Calibri" pitchFamily="34" charset="-120"/>
+                        </a:rPr>
+                        <a:t>591,804.81</a:t>
+                      </a:r>
+                      <a:endParaRPr lang="en-US" sz="1000" dirty="0">
+                        <a:latin typeface="Calibri" charset="0"/>
+                        <a:ea typeface="Calibri" charset="0"/>
+                        <a:cs typeface="Calibri" charset="0"/>
+                      </a:endParaRPr>
+                    </a:p>
+                  </a:txBody>
+                  <a:tcPr marL="54864" marR="54864" marT="27432" marB="27432" anchor="t">
+                    <a:lnL w="6350" cap="flat" cmpd="sng" algn="ctr">
+                      <a:solidFill>
+                        <a:srgbClr val="D9DEE0"/>
+                      </a:solidFill>
+                      <a:prstDash val="solid"/>
+                      <a:round/>
+                      <a:headEnd type="none" w="med" len="med"/>
+                      <a:tailEnd type="none" w="med" len="med"/>
+                    </a:lnL>
+                    <a:lnR w="6350" cap="flat" cmpd="sng" algn="ctr">
+                      <a:solidFill>
+                        <a:srgbClr val="D9DEE0"/>
+                      </a:solidFill>
+                      <a:prstDash val="solid"/>
+                      <a:round/>
+                      <a:headEnd type="none" w="med" len="med"/>
+                      <a:tailEnd type="none" w="med" len="med"/>
+                    </a:lnR>
+                    <a:lnT w="6350" cap="flat" cmpd="sng" algn="ctr">
+                      <a:solidFill>
+                        <a:srgbClr val="D9DEE0"/>
+                      </a:solidFill>
+                      <a:prstDash val="solid"/>
+                      <a:round/>
+                      <a:headEnd type="none" w="med" len="med"/>
+                      <a:tailEnd type="none" w="med" len="med"/>
+                    </a:lnT>
+                    <a:lnB w="6350" cap="flat" cmpd="sng" algn="ctr">
+                      <a:solidFill>
+                        <a:srgbClr val="D9DEE0"/>
+                      </a:solidFill>
+                      <a:prstDash val="solid"/>
+                      <a:round/>
+                      <a:headEnd type="none" w="med" len="med"/>
+                      <a:tailEnd type="none" w="med" len="med"/>
+                    </a:lnB>
+                    <a:solidFill>
+                      <a:schemeClr val="bg1"/>
+                    </a:solidFill>
+                  </a:tcPr>
+                </a:tc>
+                <a:tc>
+                  <a:txBody>
+                    <a:bodyPr/>
+                    <a:lstStyle/>
+                    <a:p>
+                      <a:pPr indent="0" marL="0">
+                        <a:buNone/>
+                      </a:pPr>
+                      <a:r>
+                        <a:rPr lang="en-US" sz="1000" dirty="0">
+                          <a:solidFill>
+                            <a:schemeClr val="tx1"/>
+                          </a:solidFill>
+                          <a:latin typeface="Calibri" pitchFamily="34" charset="0"/>
+                          <a:ea typeface="Calibri" pitchFamily="34" charset="-122"/>
+                          <a:cs typeface="Calibri" pitchFamily="34" charset="-120"/>
+                        </a:rPr>
+                        <a:t>Rorisa: canal</a:t>
+                      </a:r>
+                      <a:endParaRPr lang="en-US" sz="1000" dirty="0">
+                        <a:latin typeface="Calibri" charset="0"/>
+                        <a:ea typeface="Calibri" charset="0"/>
+                        <a:cs typeface="Calibri" charset="0"/>
+                      </a:endParaRPr>
+                    </a:p>
+                  </a:txBody>
+                  <a:tcPr marL="54864" marR="54864" marT="27432" marB="27432" anchor="t">
+                    <a:lnL w="6350" cap="flat" cmpd="sng" algn="ctr">
+                      <a:solidFill>
+                        <a:srgbClr val="D9DEE0"/>
+                      </a:solidFill>
+                      <a:prstDash val="solid"/>
+                      <a:round/>
+                      <a:headEnd type="none" w="med" len="med"/>
+                      <a:tailEnd type="none" w="med" len="med"/>
+                    </a:lnL>
+                    <a:lnR w="6350" cap="flat" cmpd="sng" algn="ctr">
+                      <a:solidFill>
+                        <a:srgbClr val="D9DEE0"/>
+                      </a:solidFill>
+                      <a:prstDash val="solid"/>
+                      <a:round/>
+                      <a:headEnd type="none" w="med" len="med"/>
+                      <a:tailEnd type="none" w="med" len="med"/>
+                    </a:lnR>
+                    <a:lnT w="6350" cap="flat" cmpd="sng" algn="ctr">
+                      <a:solidFill>
+                        <a:srgbClr val="D9DEE0"/>
+                      </a:solidFill>
+                      <a:prstDash val="solid"/>
+                      <a:round/>
+                      <a:headEnd type="none" w="med" len="med"/>
+                      <a:tailEnd type="none" w="med" len="med"/>
+                    </a:lnT>
+                    <a:lnB w="6350" cap="flat" cmpd="sng" algn="ctr">
+                      <a:solidFill>
+                        <a:srgbClr val="D9DEE0"/>
+                      </a:solidFill>
+                      <a:prstDash val="solid"/>
+                      <a:round/>
+                      <a:headEnd type="none" w="med" len="med"/>
+                      <a:tailEnd type="none" w="med" len="med"/>
+                    </a:lnB>
+                    <a:solidFill>
+                      <a:schemeClr val="bg1"/>
+                    </a:solidFill>
+                  </a:tcPr>
+                </a:tc>
+              </a:tr>
+              <a:tr h="0">
+                <a:tc>
+                  <a:txBody>
+                    <a:bodyPr/>
+                    <a:lstStyle/>
+                    <a:p>
+                      <a:pPr indent="0" marL="0">
+                        <a:buNone/>
+                      </a:pPr>
+                      <a:r>
+                        <a:rPr lang="en-US" sz="1000" dirty="0">
+                          <a:solidFill>
+                            <a:schemeClr val="tx1"/>
+                          </a:solidFill>
+                          <a:latin typeface="Calibri" pitchFamily="34" charset="0"/>
+                          <a:ea typeface="Calibri" pitchFamily="34" charset="-122"/>
+                          <a:cs typeface="Calibri" pitchFamily="34" charset="-120"/>
+                        </a:rPr>
+                        <a:t>7.1 - TPU + LINATRIL - Grupo Bafar Chihuahua - Interbandas Chihuahua PT-PU BELTS-656090</a:t>
+                      </a:r>
+                      <a:endParaRPr lang="en-US" sz="1000" dirty="0">
+                        <a:latin typeface="Calibri" charset="0"/>
+                        <a:ea typeface="Calibri" charset="0"/>
+                        <a:cs typeface="Calibri" charset="0"/>
+                      </a:endParaRPr>
+                    </a:p>
+                  </a:txBody>
+                  <a:tcPr marL="54864" marR="54864" marT="27432" marB="27432" anchor="t">
+                    <a:lnL w="6350" cap="flat" cmpd="sng" algn="ctr">
+                      <a:solidFill>
+                        <a:srgbClr val="D9DEE0"/>
+                      </a:solidFill>
+                      <a:prstDash val="solid"/>
+                      <a:round/>
+                      <a:headEnd type="none" w="med" len="med"/>
+                      <a:tailEnd type="none" w="med" len="med"/>
+                    </a:lnL>
+                    <a:lnR w="6350" cap="flat" cmpd="sng" algn="ctr">
+                      <a:solidFill>
+                        <a:srgbClr val="D9DEE0"/>
+                      </a:solidFill>
+                      <a:prstDash val="solid"/>
+                      <a:round/>
+                      <a:headEnd type="none" w="med" len="med"/>
+                      <a:tailEnd type="none" w="med" len="med"/>
+                    </a:lnR>
+                    <a:lnT w="6350" cap="flat" cmpd="sng" algn="ctr">
+                      <a:solidFill>
+                        <a:srgbClr val="D9DEE0"/>
+                      </a:solidFill>
+                      <a:prstDash val="solid"/>
+                      <a:round/>
+                      <a:headEnd type="none" w="med" len="med"/>
+                      <a:tailEnd type="none" w="med" len="med"/>
+                    </a:lnT>
+                    <a:lnB w="6350" cap="flat" cmpd="sng" algn="ctr">
+                      <a:solidFill>
+                        <a:srgbClr val="D9DEE0"/>
+                      </a:solidFill>
+                      <a:prstDash val="solid"/>
+                      <a:round/>
+                      <a:headEnd type="none" w="med" len="med"/>
+                      <a:tailEnd type="none" w="med" len="med"/>
+                    </a:lnB>
+                    <a:solidFill>
+                      <a:schemeClr val="bg1"/>
+                    </a:solidFill>
+                  </a:tcPr>
+                </a:tc>
+                <a:tc>
+                  <a:txBody>
+                    <a:bodyPr/>
+                    <a:lstStyle/>
+                    <a:p>
+                      <a:pPr indent="0" marL="0">
+                        <a:buNone/>
+                      </a:pPr>
+                      <a:r>
+                        <a:rPr lang="en-US" sz="1000" dirty="0">
+                          <a:solidFill>
+                            <a:schemeClr val="tx1"/>
+                          </a:solidFill>
+                          <a:latin typeface="Calibri" pitchFamily="34" charset="0"/>
+                          <a:ea typeface="Calibri" pitchFamily="34" charset="-122"/>
+                          <a:cs typeface="Calibri" pitchFamily="34" charset="-120"/>
+                        </a:rPr>
+                        <a:t>656090</a:t>
+                      </a:r>
+                      <a:endParaRPr lang="en-US" sz="1000" dirty="0">
+                        <a:latin typeface="Calibri" charset="0"/>
+                        <a:ea typeface="Calibri" charset="0"/>
+                        <a:cs typeface="Calibri" charset="0"/>
+                      </a:endParaRPr>
+                    </a:p>
+                  </a:txBody>
+                  <a:tcPr marL="54864" marR="54864" marT="27432" marB="27432" anchor="t">
+                    <a:lnL w="6350" cap="flat" cmpd="sng" algn="ctr">
+                      <a:solidFill>
+                        <a:srgbClr val="D9DEE0"/>
+                      </a:solidFill>
+                      <a:prstDash val="solid"/>
+                      <a:round/>
+                      <a:headEnd type="none" w="med" len="med"/>
+                      <a:tailEnd type="none" w="med" len="med"/>
+                    </a:lnL>
+                    <a:lnR w="6350" cap="flat" cmpd="sng" algn="ctr">
+                      <a:solidFill>
+                        <a:srgbClr val="D9DEE0"/>
+                      </a:solidFill>
+                      <a:prstDash val="solid"/>
+                      <a:round/>
+                      <a:headEnd type="none" w="med" len="med"/>
+                      <a:tailEnd type="none" w="med" len="med"/>
+                    </a:lnR>
+                    <a:lnT w="6350" cap="flat" cmpd="sng" algn="ctr">
+                      <a:solidFill>
+                        <a:srgbClr val="D9DEE0"/>
+                      </a:solidFill>
+                      <a:prstDash val="solid"/>
+                      <a:round/>
+                      <a:headEnd type="none" w="med" len="med"/>
+                      <a:tailEnd type="none" w="med" len="med"/>
+                    </a:lnT>
+                    <a:lnB w="6350" cap="flat" cmpd="sng" algn="ctr">
+                      <a:solidFill>
+                        <a:srgbClr val="D9DEE0"/>
+                      </a:solidFill>
+                      <a:prstDash val="solid"/>
+                      <a:round/>
+                      <a:headEnd type="none" w="med" len="med"/>
+                      <a:tailEnd type="none" w="med" len="med"/>
+                    </a:lnB>
+                    <a:solidFill>
+                      <a:schemeClr val="bg1"/>
+                    </a:solidFill>
+                  </a:tcPr>
+                </a:tc>
+                <a:tc>
+                  <a:txBody>
+                    <a:bodyPr/>
+                    <a:lstStyle/>
+                    <a:p>
+                      <a:pPr indent="0" marL="0">
+                        <a:buNone/>
+                      </a:pPr>
+                      <a:r>
+                        <a:rPr lang="en-US" sz="1000" dirty="0">
+                          <a:solidFill>
+                            <a:schemeClr val="tx1"/>
+                          </a:solidFill>
+                          <a:latin typeface="Calibri" pitchFamily="34" charset="0"/>
+                          <a:ea typeface="Calibri" pitchFamily="34" charset="-122"/>
+                          <a:cs typeface="Calibri" pitchFamily="34" charset="-120"/>
+                        </a:rPr>
+                        <a:t>Lost 2023</a:t>
+                      </a:r>
+                      <a:endParaRPr lang="en-US" sz="1000" dirty="0">
+                        <a:latin typeface="Calibri" charset="0"/>
+                        <a:ea typeface="Calibri" charset="0"/>
+                        <a:cs typeface="Calibri" charset="0"/>
+                      </a:endParaRPr>
+                    </a:p>
+                  </a:txBody>
+                  <a:tcPr marL="54864" marR="54864" marT="27432" marB="27432" anchor="t">
+                    <a:lnL w="6350" cap="flat" cmpd="sng" algn="ctr">
+                      <a:solidFill>
+                        <a:srgbClr val="D9DEE0"/>
+                      </a:solidFill>
+                      <a:prstDash val="solid"/>
+                      <a:round/>
+                      <a:headEnd type="none" w="med" len="med"/>
+                      <a:tailEnd type="none" w="med" len="med"/>
+                    </a:lnL>
+                    <a:lnR w="6350" cap="flat" cmpd="sng" algn="ctr">
+                      <a:solidFill>
+                        <a:srgbClr val="D9DEE0"/>
+                      </a:solidFill>
+                      <a:prstDash val="solid"/>
+                      <a:round/>
+                      <a:headEnd type="none" w="med" len="med"/>
+                      <a:tailEnd type="none" w="med" len="med"/>
+                    </a:lnR>
+                    <a:lnT w="6350" cap="flat" cmpd="sng" algn="ctr">
+                      <a:solidFill>
+                        <a:srgbClr val="D9DEE0"/>
+                      </a:solidFill>
+                      <a:prstDash val="solid"/>
+                      <a:round/>
+                      <a:headEnd type="none" w="med" len="med"/>
+                      <a:tailEnd type="none" w="med" len="med"/>
+                    </a:lnT>
+                    <a:lnB w="6350" cap="flat" cmpd="sng" algn="ctr">
+                      <a:solidFill>
+                        <a:srgbClr val="D9DEE0"/>
+                      </a:solidFill>
+                      <a:prstDash val="solid"/>
+                      <a:round/>
+                      <a:headEnd type="none" w="med" len="med"/>
+                      <a:tailEnd type="none" w="med" len="med"/>
+                    </a:lnB>
+                    <a:solidFill>
+                      <a:schemeClr val="bg1"/>
+                    </a:solidFill>
+                  </a:tcPr>
+                </a:tc>
+                <a:tc>
+                  <a:txBody>
+                    <a:bodyPr/>
+                    <a:lstStyle/>
+                    <a:p>
+                      <a:pPr indent="0" marL="0">
+                        <a:buNone/>
+                      </a:pPr>
+                      <a:r>
+                        <a:rPr lang="en-US" sz="1000" dirty="0">
+                          <a:solidFill>
+                            <a:schemeClr val="tx1"/>
+                          </a:solidFill>
+                          <a:latin typeface="Calibri" pitchFamily="34" charset="0"/>
+                          <a:ea typeface="Calibri" pitchFamily="34" charset="-122"/>
+                          <a:cs typeface="Calibri" pitchFamily="34" charset="-120"/>
+                        </a:rPr>
+                        <a:t>286,935.76</a:t>
+                      </a:r>
+                      <a:endParaRPr lang="en-US" sz="1000" dirty="0">
+                        <a:latin typeface="Calibri" charset="0"/>
+                        <a:ea typeface="Calibri" charset="0"/>
+                        <a:cs typeface="Calibri" charset="0"/>
+                      </a:endParaRPr>
+                    </a:p>
+                  </a:txBody>
+                  <a:tcPr marL="54864" marR="54864" marT="27432" marB="27432" anchor="t">
+                    <a:lnL w="6350" cap="flat" cmpd="sng" algn="ctr">
+                      <a:solidFill>
+                        <a:srgbClr val="D9DEE0"/>
+                      </a:solidFill>
+                      <a:prstDash val="solid"/>
+                      <a:round/>
+                      <a:headEnd type="none" w="med" len="med"/>
+                      <a:tailEnd type="none" w="med" len="med"/>
+                    </a:lnL>
+                    <a:lnR w="6350" cap="flat" cmpd="sng" algn="ctr">
+                      <a:solidFill>
+                        <a:srgbClr val="D9DEE0"/>
+                      </a:solidFill>
+                      <a:prstDash val="solid"/>
+                      <a:round/>
+                      <a:headEnd type="none" w="med" len="med"/>
+                      <a:tailEnd type="none" w="med" len="med"/>
+                    </a:lnR>
+                    <a:lnT w="6350" cap="flat" cmpd="sng" algn="ctr">
+                      <a:solidFill>
+                        <a:srgbClr val="D9DEE0"/>
+                      </a:solidFill>
+                      <a:prstDash val="solid"/>
+                      <a:round/>
+                      <a:headEnd type="none" w="med" len="med"/>
+                      <a:tailEnd type="none" w="med" len="med"/>
+                    </a:lnT>
+                    <a:lnB w="6350" cap="flat" cmpd="sng" algn="ctr">
+                      <a:solidFill>
+                        <a:srgbClr val="D9DEE0"/>
+                      </a:solidFill>
+                      <a:prstDash val="solid"/>
+                      <a:round/>
+                      <a:headEnd type="none" w="med" len="med"/>
+                      <a:tailEnd type="none" w="med" len="med"/>
+                    </a:lnB>
+                    <a:solidFill>
+                      <a:schemeClr val="bg1"/>
+                    </a:solidFill>
+                  </a:tcPr>
+                </a:tc>
+                <a:tc>
+                  <a:txBody>
+                    <a:bodyPr/>
+                    <a:lstStyle/>
+                    <a:p>
+                      <a:pPr indent="0" marL="0">
+                        <a:buNone/>
+                      </a:pPr>
+                      <a:r>
+                        <a:rPr lang="en-US" sz="1000" dirty="0">
+                          <a:solidFill>
+                            <a:schemeClr val="tx1"/>
+                          </a:solidFill>
+                          <a:latin typeface="Calibri" pitchFamily="34" charset="0"/>
+                          <a:ea typeface="Calibri" pitchFamily="34" charset="-122"/>
+                          <a:cs typeface="Calibri" pitchFamily="34" charset="-120"/>
+                        </a:rPr>
+                        <a:t>Interbandas: canal</a:t>
+                      </a:r>
+                      <a:endParaRPr lang="en-US" sz="1000" dirty="0">
+                        <a:latin typeface="Calibri" charset="0"/>
+                        <a:ea typeface="Calibri" charset="0"/>
+                        <a:cs typeface="Calibri" charset="0"/>
+                      </a:endParaRPr>
+                    </a:p>
+                  </a:txBody>
+                  <a:tcPr marL="54864" marR="54864" marT="27432" marB="27432" anchor="t">
+                    <a:lnL w="6350" cap="flat" cmpd="sng" algn="ctr">
+                      <a:solidFill>
+                        <a:srgbClr val="D9DEE0"/>
+                      </a:solidFill>
+                      <a:prstDash val="solid"/>
+                      <a:round/>
+                      <a:headEnd type="none" w="med" len="med"/>
+                      <a:tailEnd type="none" w="med" len="med"/>
+                    </a:lnL>
+                    <a:lnR w="6350" cap="flat" cmpd="sng" algn="ctr">
+                      <a:solidFill>
+                        <a:srgbClr val="D9DEE0"/>
+                      </a:solidFill>
+                      <a:prstDash val="solid"/>
+                      <a:round/>
+                      <a:headEnd type="none" w="med" len="med"/>
+                      <a:tailEnd type="none" w="med" len="med"/>
+                    </a:lnR>
+                    <a:lnT w="6350" cap="flat" cmpd="sng" algn="ctr">
+                      <a:solidFill>
+                        <a:srgbClr val="D9DEE0"/>
+                      </a:solidFill>
+                      <a:prstDash val="solid"/>
+                      <a:round/>
+                      <a:headEnd type="none" w="med" len="med"/>
+                      <a:tailEnd type="none" w="med" len="med"/>
+                    </a:lnT>
+                    <a:lnB w="6350" cap="flat" cmpd="sng" algn="ctr">
+                      <a:solidFill>
+                        <a:srgbClr val="D9DEE0"/>
+                      </a:solidFill>
+                      <a:prstDash val="solid"/>
+                      <a:round/>
+                      <a:headEnd type="none" w="med" len="med"/>
+                      <a:tailEnd type="none" w="med" len="med"/>
+                    </a:lnB>
+                    <a:solidFill>
+                      <a:schemeClr val="bg1"/>
+                    </a:solidFill>
+                  </a:tcPr>
+                </a:tc>
+              </a:tr>
+              <a:tr h="0">
+                <a:tc>
+                  <a:txBody>
+                    <a:bodyPr/>
+                    <a:lstStyle/>
+                    <a:p>
+                      <a:pPr indent="0" marL="0">
+                        <a:buNone/>
+                      </a:pPr>
+                      <a:r>
+                        <a:rPr lang="en-US" sz="1000" dirty="0">
+                          <a:solidFill>
+                            <a:schemeClr val="tx1"/>
+                          </a:solidFill>
+                          <a:latin typeface="Calibri" pitchFamily="34" charset="0"/>
+                          <a:ea typeface="Calibri" pitchFamily="34" charset="-122"/>
+                          <a:cs typeface="Calibri" pitchFamily="34" charset="-120"/>
+                        </a:rPr>
+                        <a:t>7.1 HID MXT Grupo Occidente Acatlan - Binasa Tlaquepaque -742222</a:t>
+                      </a:r>
+                      <a:endParaRPr lang="en-US" sz="1000" dirty="0">
+                        <a:latin typeface="Calibri" charset="0"/>
+                        <a:ea typeface="Calibri" charset="0"/>
+                        <a:cs typeface="Calibri" charset="0"/>
+                      </a:endParaRPr>
+                    </a:p>
+                  </a:txBody>
+                  <a:tcPr marL="54864" marR="54864" marT="27432" marB="27432" anchor="t">
+                    <a:lnL w="6350" cap="flat" cmpd="sng" algn="ctr">
+                      <a:solidFill>
+                        <a:srgbClr val="D9DEE0"/>
+                      </a:solidFill>
+                      <a:prstDash val="solid"/>
+                      <a:round/>
+                      <a:headEnd type="none" w="med" len="med"/>
+                      <a:tailEnd type="none" w="med" len="med"/>
+                    </a:lnL>
+                    <a:lnR w="6350" cap="flat" cmpd="sng" algn="ctr">
+                      <a:solidFill>
+                        <a:srgbClr val="D9DEE0"/>
+                      </a:solidFill>
+                      <a:prstDash val="solid"/>
+                      <a:round/>
+                      <a:headEnd type="none" w="med" len="med"/>
+                      <a:tailEnd type="none" w="med" len="med"/>
+                    </a:lnR>
+                    <a:lnT w="6350" cap="flat" cmpd="sng" algn="ctr">
+                      <a:solidFill>
+                        <a:srgbClr val="D9DEE0"/>
+                      </a:solidFill>
+                      <a:prstDash val="solid"/>
+                      <a:round/>
+                      <a:headEnd type="none" w="med" len="med"/>
+                      <a:tailEnd type="none" w="med" len="med"/>
+                    </a:lnT>
+                    <a:lnB w="6350" cap="flat" cmpd="sng" algn="ctr">
+                      <a:solidFill>
+                        <a:srgbClr val="D9DEE0"/>
+                      </a:solidFill>
+                      <a:prstDash val="solid"/>
+                      <a:round/>
+                      <a:headEnd type="none" w="med" len="med"/>
+                      <a:tailEnd type="none" w="med" len="med"/>
+                    </a:lnB>
+                    <a:solidFill>
+                      <a:schemeClr val="bg1"/>
+                    </a:solidFill>
+                  </a:tcPr>
+                </a:tc>
+                <a:tc>
+                  <a:txBody>
+                    <a:bodyPr/>
+                    <a:lstStyle/>
+                    <a:p>
+                      <a:pPr indent="0" marL="0">
+                        <a:buNone/>
+                      </a:pPr>
+                      <a:r>
+                        <a:rPr lang="en-US" sz="1000" dirty="0">
+                          <a:solidFill>
+                            <a:schemeClr val="tx1"/>
+                          </a:solidFill>
+                          <a:latin typeface="Calibri" pitchFamily="34" charset="0"/>
+                          <a:ea typeface="Calibri" pitchFamily="34" charset="-122"/>
+                          <a:cs typeface="Calibri" pitchFamily="34" charset="-120"/>
+                        </a:rPr>
+                        <a:t>742222</a:t>
+                      </a:r>
+                      <a:endParaRPr lang="en-US" sz="1000" dirty="0">
+                        <a:latin typeface="Calibri" charset="0"/>
+                        <a:ea typeface="Calibri" charset="0"/>
+                        <a:cs typeface="Calibri" charset="0"/>
+                      </a:endParaRPr>
+                    </a:p>
+                  </a:txBody>
+                  <a:tcPr marL="54864" marR="54864" marT="27432" marB="27432" anchor="t">
+                    <a:lnL w="6350" cap="flat" cmpd="sng" algn="ctr">
+                      <a:solidFill>
+                        <a:srgbClr val="D9DEE0"/>
+                      </a:solidFill>
+                      <a:prstDash val="solid"/>
+                      <a:round/>
+                      <a:headEnd type="none" w="med" len="med"/>
+                      <a:tailEnd type="none" w="med" len="med"/>
+                    </a:lnL>
+                    <a:lnR w="6350" cap="flat" cmpd="sng" algn="ctr">
+                      <a:solidFill>
+                        <a:srgbClr val="D9DEE0"/>
+                      </a:solidFill>
+                      <a:prstDash val="solid"/>
+                      <a:round/>
+                      <a:headEnd type="none" w="med" len="med"/>
+                      <a:tailEnd type="none" w="med" len="med"/>
+                    </a:lnR>
+                    <a:lnT w="6350" cap="flat" cmpd="sng" algn="ctr">
+                      <a:solidFill>
+                        <a:srgbClr val="D9DEE0"/>
+                      </a:solidFill>
+                      <a:prstDash val="solid"/>
+                      <a:round/>
+                      <a:headEnd type="none" w="med" len="med"/>
+                      <a:tailEnd type="none" w="med" len="med"/>
+                    </a:lnT>
+                    <a:lnB w="6350" cap="flat" cmpd="sng" algn="ctr">
+                      <a:solidFill>
+                        <a:srgbClr val="D9DEE0"/>
+                      </a:solidFill>
+                      <a:prstDash val="solid"/>
+                      <a:round/>
+                      <a:headEnd type="none" w="med" len="med"/>
+                      <a:tailEnd type="none" w="med" len="med"/>
+                    </a:lnB>
+                    <a:solidFill>
+                      <a:schemeClr val="bg1"/>
+                    </a:solidFill>
+                  </a:tcPr>
+                </a:tc>
+                <a:tc>
+                  <a:txBody>
+                    <a:bodyPr/>
+                    <a:lstStyle/>
+                    <a:p>
+                      <a:pPr indent="0" marL="0">
+                        <a:buNone/>
+                      </a:pPr>
+                      <a:r>
+                        <a:rPr lang="en-US" sz="1000" dirty="0">
+                          <a:solidFill>
+                            <a:schemeClr val="tx1"/>
+                          </a:solidFill>
+                          <a:latin typeface="Calibri" pitchFamily="34" charset="0"/>
+                          <a:ea typeface="Calibri" pitchFamily="34" charset="-122"/>
+                          <a:cs typeface="Calibri" pitchFamily="34" charset="-120"/>
+                        </a:rPr>
+                        <a:t>Lost 2025</a:t>
+                      </a:r>
+                      <a:endParaRPr lang="en-US" sz="1000" dirty="0">
+                        <a:latin typeface="Calibri" charset="0"/>
+                        <a:ea typeface="Calibri" charset="0"/>
+                        <a:cs typeface="Calibri" charset="0"/>
+                      </a:endParaRPr>
+                    </a:p>
+                  </a:txBody>
+                  <a:tcPr marL="54864" marR="54864" marT="27432" marB="27432" anchor="t">
+                    <a:lnL w="6350" cap="flat" cmpd="sng" algn="ctr">
+                      <a:solidFill>
+                        <a:srgbClr val="D9DEE0"/>
+                      </a:solidFill>
+                      <a:prstDash val="solid"/>
+                      <a:round/>
+                      <a:headEnd type="none" w="med" len="med"/>
+                      <a:tailEnd type="none" w="med" len="med"/>
+                    </a:lnL>
+                    <a:lnR w="6350" cap="flat" cmpd="sng" algn="ctr">
+                      <a:solidFill>
+                        <a:srgbClr val="D9DEE0"/>
+                      </a:solidFill>
+                      <a:prstDash val="solid"/>
+                      <a:round/>
+                      <a:headEnd type="none" w="med" len="med"/>
+                      <a:tailEnd type="none" w="med" len="med"/>
+                    </a:lnR>
+                    <a:lnT w="6350" cap="flat" cmpd="sng" algn="ctr">
+                      <a:solidFill>
+                        <a:srgbClr val="D9DEE0"/>
+                      </a:solidFill>
+                      <a:prstDash val="solid"/>
+                      <a:round/>
+                      <a:headEnd type="none" w="med" len="med"/>
+                      <a:tailEnd type="none" w="med" len="med"/>
+                    </a:lnT>
+                    <a:lnB w="6350" cap="flat" cmpd="sng" algn="ctr">
+                      <a:solidFill>
+                        <a:srgbClr val="D9DEE0"/>
+                      </a:solidFill>
+                      <a:prstDash val="solid"/>
+                      <a:round/>
+                      <a:headEnd type="none" w="med" len="med"/>
+                      <a:tailEnd type="none" w="med" len="med"/>
+                    </a:lnB>
+                    <a:solidFill>
+                      <a:schemeClr val="bg1"/>
+                    </a:solidFill>
+                  </a:tcPr>
+                </a:tc>
+                <a:tc>
+                  <a:txBody>
+                    <a:bodyPr/>
+                    <a:lstStyle/>
+                    <a:p>
+                      <a:pPr indent="0" marL="0">
+                        <a:buNone/>
+                      </a:pPr>
+                      <a:r>
+                        <a:rPr lang="en-US" sz="1000" dirty="0">
+                          <a:solidFill>
+                            <a:schemeClr val="tx1"/>
+                          </a:solidFill>
+                          <a:latin typeface="Calibri" pitchFamily="34" charset="0"/>
+                          <a:ea typeface="Calibri" pitchFamily="34" charset="-122"/>
+                          <a:cs typeface="Calibri" pitchFamily="34" charset="-120"/>
+                        </a:rPr>
+                        <a:t>483,084.08</a:t>
+                      </a:r>
+                      <a:endParaRPr lang="en-US" sz="1000" dirty="0">
+                        <a:latin typeface="Calibri" charset="0"/>
+                        <a:ea typeface="Calibri" charset="0"/>
+                        <a:cs typeface="Calibri" charset="0"/>
+                      </a:endParaRPr>
+                    </a:p>
+                  </a:txBody>
+                  <a:tcPr marL="54864" marR="54864" marT="27432" marB="27432" anchor="t">
+                    <a:lnL w="6350" cap="flat" cmpd="sng" algn="ctr">
+                      <a:solidFill>
+                        <a:srgbClr val="D9DEE0"/>
+                      </a:solidFill>
+                      <a:prstDash val="solid"/>
+                      <a:round/>
+                      <a:headEnd type="none" w="med" len="med"/>
+                      <a:tailEnd type="none" w="med" len="med"/>
+                    </a:lnL>
+                    <a:lnR w="6350" cap="flat" cmpd="sng" algn="ctr">
+                      <a:solidFill>
+                        <a:srgbClr val="D9DEE0"/>
+                      </a:solidFill>
+                      <a:prstDash val="solid"/>
+                      <a:round/>
+                      <a:headEnd type="none" w="med" len="med"/>
+                      <a:tailEnd type="none" w="med" len="med"/>
+                    </a:lnR>
+                    <a:lnT w="6350" cap="flat" cmpd="sng" algn="ctr">
+                      <a:solidFill>
+                        <a:srgbClr val="D9DEE0"/>
+                      </a:solidFill>
+                      <a:prstDash val="solid"/>
+                      <a:round/>
+                      <a:headEnd type="none" w="med" len="med"/>
+                      <a:tailEnd type="none" w="med" len="med"/>
+                    </a:lnT>
+                    <a:lnB w="6350" cap="flat" cmpd="sng" algn="ctr">
+                      <a:solidFill>
+                        <a:srgbClr val="D9DEE0"/>
+                      </a:solidFill>
+                      <a:prstDash val="solid"/>
+                      <a:round/>
+                      <a:headEnd type="none" w="med" len="med"/>
+                      <a:tailEnd type="none" w="med" len="med"/>
+                    </a:lnB>
+                    <a:solidFill>
+                      <a:schemeClr val="bg1"/>
+                    </a:solidFill>
+                  </a:tcPr>
+                </a:tc>
+                <a:tc>
+                  <a:txBody>
+                    <a:bodyPr/>
+                    <a:lstStyle/>
+                    <a:p>
+                      <a:pPr indent="0" marL="0">
+                        <a:buNone/>
+                      </a:pPr>
+                      <a:r>
+                        <a:rPr lang="en-US" sz="1000" dirty="0">
+                          <a:solidFill>
+                            <a:schemeClr val="tx1"/>
+                          </a:solidFill>
+                          <a:latin typeface="Calibri" pitchFamily="34" charset="0"/>
+                          <a:ea typeface="Calibri" pitchFamily="34" charset="-122"/>
+                          <a:cs typeface="Calibri" pitchFamily="34" charset="-120"/>
+                        </a:rPr>
+                        <a:t>Binasa: canal</a:t>
+                      </a:r>
+                      <a:endParaRPr lang="en-US" sz="1000" dirty="0">
+                        <a:latin typeface="Calibri" charset="0"/>
+                        <a:ea typeface="Calibri" charset="0"/>
+                        <a:cs typeface="Calibri" charset="0"/>
+                      </a:endParaRPr>
+                    </a:p>
+                  </a:txBody>
+                  <a:tcPr marL="54864" marR="54864" marT="27432" marB="27432" anchor="t">
+                    <a:lnL w="6350" cap="flat" cmpd="sng" algn="ctr">
+                      <a:solidFill>
+                        <a:srgbClr val="D9DEE0"/>
+                      </a:solidFill>
+                      <a:prstDash val="solid"/>
+                      <a:round/>
+                      <a:headEnd type="none" w="med" len="med"/>
+                      <a:tailEnd type="none" w="med" len="med"/>
+                    </a:lnL>
+                    <a:lnR w="6350" cap="flat" cmpd="sng" algn="ctr">
+                      <a:solidFill>
+                        <a:srgbClr val="D9DEE0"/>
+                      </a:solidFill>
+                      <a:prstDash val="solid"/>
+                      <a:round/>
+                      <a:headEnd type="none" w="med" len="med"/>
+                      <a:tailEnd type="none" w="med" len="med"/>
+                    </a:lnR>
+                    <a:lnT w="6350" cap="flat" cmpd="sng" algn="ctr">
+                      <a:solidFill>
+                        <a:srgbClr val="D9DEE0"/>
+                      </a:solidFill>
+                      <a:prstDash val="solid"/>
+                      <a:round/>
+                      <a:headEnd type="none" w="med" len="med"/>
+                      <a:tailEnd type="none" w="med" len="med"/>
+                    </a:lnT>
+                    <a:lnB w="6350" cap="flat" cmpd="sng" algn="ctr">
+                      <a:solidFill>
+                        <a:srgbClr val="D9DEE0"/>
+                      </a:solidFill>
+                      <a:prstDash val="solid"/>
+                      <a:round/>
+                      <a:headEnd type="none" w="med" len="med"/>
+                      <a:tailEnd type="none" w="med" len="med"/>
+                    </a:lnB>
+                    <a:solidFill>
+                      <a:schemeClr val="bg1"/>
+                    </a:solidFill>
+                  </a:tcPr>
+                </a:tc>
+              </a:tr>
+              <a:tr h="0">
+                <a:tc>
+                  <a:txBody>
+                    <a:bodyPr/>
+                    <a:lstStyle/>
+                    <a:p>
+                      <a:pPr indent="0" marL="0">
+                        <a:buNone/>
+                      </a:pPr>
+                      <a:r>
+                        <a:rPr lang="en-US" sz="1000" dirty="0">
+                          <a:solidFill>
+                            <a:schemeClr val="tx1"/>
+                          </a:solidFill>
+                          <a:latin typeface="Calibri" pitchFamily="34" charset="0"/>
+                          <a:ea typeface="Calibri" pitchFamily="34" charset="-122"/>
+                          <a:cs typeface="Calibri" pitchFamily="34" charset="-120"/>
+                        </a:rPr>
+                        <a:t>7.1 HID MXT Grupo Occidente Acatlan - BRR Binasa -782913</a:t>
+                      </a:r>
+                      <a:endParaRPr lang="en-US" sz="1000" dirty="0">
+                        <a:latin typeface="Calibri" charset="0"/>
+                        <a:ea typeface="Calibri" charset="0"/>
+                        <a:cs typeface="Calibri" charset="0"/>
+                      </a:endParaRPr>
+                    </a:p>
+                  </a:txBody>
+                  <a:tcPr marL="54864" marR="54864" marT="27432" marB="27432" anchor="t">
+                    <a:lnL w="6350" cap="flat" cmpd="sng" algn="ctr">
+                      <a:solidFill>
+                        <a:srgbClr val="D9DEE0"/>
+                      </a:solidFill>
+                      <a:prstDash val="solid"/>
+                      <a:round/>
+                      <a:headEnd type="none" w="med" len="med"/>
+                      <a:tailEnd type="none" w="med" len="med"/>
+                    </a:lnL>
+                    <a:lnR w="6350" cap="flat" cmpd="sng" algn="ctr">
+                      <a:solidFill>
+                        <a:srgbClr val="D9DEE0"/>
+                      </a:solidFill>
+                      <a:prstDash val="solid"/>
+                      <a:round/>
+                      <a:headEnd type="none" w="med" len="med"/>
+                      <a:tailEnd type="none" w="med" len="med"/>
+                    </a:lnR>
+                    <a:lnT w="6350" cap="flat" cmpd="sng" algn="ctr">
+                      <a:solidFill>
+                        <a:srgbClr val="D9DEE0"/>
+                      </a:solidFill>
+                      <a:prstDash val="solid"/>
+                      <a:round/>
+                      <a:headEnd type="none" w="med" len="med"/>
+                      <a:tailEnd type="none" w="med" len="med"/>
+                    </a:lnT>
+                    <a:lnB w="6350" cap="flat" cmpd="sng" algn="ctr">
+                      <a:solidFill>
+                        <a:srgbClr val="D9DEE0"/>
+                      </a:solidFill>
+                      <a:prstDash val="solid"/>
+                      <a:round/>
+                      <a:headEnd type="none" w="med" len="med"/>
+                      <a:tailEnd type="none" w="med" len="med"/>
+                    </a:lnB>
+                    <a:solidFill>
+                      <a:schemeClr val="bg1"/>
+                    </a:solidFill>
+                  </a:tcPr>
+                </a:tc>
+                <a:tc>
+                  <a:txBody>
+                    <a:bodyPr/>
+                    <a:lstStyle/>
+                    <a:p>
+                      <a:pPr indent="0" marL="0">
+                        <a:buNone/>
+                      </a:pPr>
+                      <a:r>
+                        <a:rPr lang="en-US" sz="1000" dirty="0">
+                          <a:solidFill>
+                            <a:schemeClr val="tx1"/>
+                          </a:solidFill>
+                          <a:latin typeface="Calibri" pitchFamily="34" charset="0"/>
+                          <a:ea typeface="Calibri" pitchFamily="34" charset="-122"/>
+                          <a:cs typeface="Calibri" pitchFamily="34" charset="-120"/>
+                        </a:rPr>
+                        <a:t>782913</a:t>
+                      </a:r>
+                      <a:endParaRPr lang="en-US" sz="1000" dirty="0">
+                        <a:latin typeface="Calibri" charset="0"/>
+                        <a:ea typeface="Calibri" charset="0"/>
+                        <a:cs typeface="Calibri" charset="0"/>
+                      </a:endParaRPr>
+                    </a:p>
+                  </a:txBody>
+                  <a:tcPr marL="54864" marR="54864" marT="27432" marB="27432" anchor="t">
+                    <a:lnL w="6350" cap="flat" cmpd="sng" algn="ctr">
+                      <a:solidFill>
+                        <a:srgbClr val="D9DEE0"/>
+                      </a:solidFill>
+                      <a:prstDash val="solid"/>
+                      <a:round/>
+                      <a:headEnd type="none" w="med" len="med"/>
+                      <a:tailEnd type="none" w="med" len="med"/>
+                    </a:lnL>
+                    <a:lnR w="6350" cap="flat" cmpd="sng" algn="ctr">
+                      <a:solidFill>
+                        <a:srgbClr val="D9DEE0"/>
+                      </a:solidFill>
+                      <a:prstDash val="solid"/>
+                      <a:round/>
+                      <a:headEnd type="none" w="med" len="med"/>
+                      <a:tailEnd type="none" w="med" len="med"/>
+                    </a:lnR>
+                    <a:lnT w="6350" cap="flat" cmpd="sng" algn="ctr">
+                      <a:solidFill>
+                        <a:srgbClr val="D9DEE0"/>
+                      </a:solidFill>
+                      <a:prstDash val="solid"/>
+                      <a:round/>
+                      <a:headEnd type="none" w="med" len="med"/>
+                      <a:tailEnd type="none" w="med" len="med"/>
+                    </a:lnT>
+                    <a:lnB w="6350" cap="flat" cmpd="sng" algn="ctr">
+                      <a:solidFill>
+                        <a:srgbClr val="D9DEE0"/>
+                      </a:solidFill>
+                      <a:prstDash val="solid"/>
+                      <a:round/>
+                      <a:headEnd type="none" w="med" len="med"/>
+                      <a:tailEnd type="none" w="med" len="med"/>
+                    </a:lnB>
+                    <a:solidFill>
+                      <a:schemeClr val="bg1"/>
+                    </a:solidFill>
+                  </a:tcPr>
+                </a:tc>
+                <a:tc>
+                  <a:txBody>
+                    <a:bodyPr/>
+                    <a:lstStyle/>
+                    <a:p>
+                      <a:pPr indent="0" marL="0">
+                        <a:buNone/>
+                      </a:pPr>
+                      <a:r>
+                        <a:rPr lang="en-US" sz="1000" dirty="0">
+                          <a:solidFill>
+                            <a:schemeClr val="tx1"/>
+                          </a:solidFill>
+                          <a:latin typeface="Calibri" pitchFamily="34" charset="0"/>
+                          <a:ea typeface="Calibri" pitchFamily="34" charset="-122"/>
+                          <a:cs typeface="Calibri" pitchFamily="34" charset="-120"/>
+                        </a:rPr>
+                        <a:t>Lost 2025</a:t>
+                      </a:r>
+                      <a:endParaRPr lang="en-US" sz="1000" dirty="0">
+                        <a:latin typeface="Calibri" charset="0"/>
+                        <a:ea typeface="Calibri" charset="0"/>
+                        <a:cs typeface="Calibri" charset="0"/>
+                      </a:endParaRPr>
+                    </a:p>
+                  </a:txBody>
+                  <a:tcPr marL="54864" marR="54864" marT="27432" marB="27432" anchor="t">
+                    <a:lnL w="6350" cap="flat" cmpd="sng" algn="ctr">
+                      <a:solidFill>
+                        <a:srgbClr val="D9DEE0"/>
+                      </a:solidFill>
+                      <a:prstDash val="solid"/>
+                      <a:round/>
+                      <a:headEnd type="none" w="med" len="med"/>
+                      <a:tailEnd type="none" w="med" len="med"/>
+                    </a:lnL>
+                    <a:lnR w="6350" cap="flat" cmpd="sng" algn="ctr">
+                      <a:solidFill>
+                        <a:srgbClr val="D9DEE0"/>
+                      </a:solidFill>
+                      <a:prstDash val="solid"/>
+                      <a:round/>
+                      <a:headEnd type="none" w="med" len="med"/>
+                      <a:tailEnd type="none" w="med" len="med"/>
+                    </a:lnR>
+                    <a:lnT w="6350" cap="flat" cmpd="sng" algn="ctr">
+                      <a:solidFill>
+                        <a:srgbClr val="D9DEE0"/>
+                      </a:solidFill>
+                      <a:prstDash val="solid"/>
+                      <a:round/>
+                      <a:headEnd type="none" w="med" len="med"/>
+                      <a:tailEnd type="none" w="med" len="med"/>
+                    </a:lnT>
+                    <a:lnB w="6350" cap="flat" cmpd="sng" algn="ctr">
+                      <a:solidFill>
+                        <a:srgbClr val="D9DEE0"/>
+                      </a:solidFill>
+                      <a:prstDash val="solid"/>
+                      <a:round/>
+                      <a:headEnd type="none" w="med" len="med"/>
+                      <a:tailEnd type="none" w="med" len="med"/>
+                    </a:lnB>
+                    <a:solidFill>
+                      <a:schemeClr val="bg1"/>
+                    </a:solidFill>
+                  </a:tcPr>
+                </a:tc>
+                <a:tc>
+                  <a:txBody>
+                    <a:bodyPr/>
+                    <a:lstStyle/>
+                    <a:p>
+                      <a:pPr indent="0" marL="0">
+                        <a:buNone/>
+                      </a:pPr>
+                      <a:r>
+                        <a:rPr lang="en-US" sz="1000" dirty="0">
+                          <a:solidFill>
+                            <a:schemeClr val="tx1"/>
+                          </a:solidFill>
+                          <a:latin typeface="Calibri" pitchFamily="34" charset="0"/>
+                          <a:ea typeface="Calibri" pitchFamily="34" charset="-122"/>
+                          <a:cs typeface="Calibri" pitchFamily="34" charset="-120"/>
+                        </a:rPr>
+                        <a:t>258,795.07</a:t>
+                      </a:r>
+                      <a:endParaRPr lang="en-US" sz="1000" dirty="0">
+                        <a:latin typeface="Calibri" charset="0"/>
+                        <a:ea typeface="Calibri" charset="0"/>
+                        <a:cs typeface="Calibri" charset="0"/>
+                      </a:endParaRPr>
+                    </a:p>
+                  </a:txBody>
+                  <a:tcPr marL="54864" marR="54864" marT="27432" marB="27432" anchor="t">
+                    <a:lnL w="6350" cap="flat" cmpd="sng" algn="ctr">
+                      <a:solidFill>
+                        <a:srgbClr val="D9DEE0"/>
+                      </a:solidFill>
+                      <a:prstDash val="solid"/>
+                      <a:round/>
+                      <a:headEnd type="none" w="med" len="med"/>
+                      <a:tailEnd type="none" w="med" len="med"/>
+                    </a:lnL>
+                    <a:lnR w="6350" cap="flat" cmpd="sng" algn="ctr">
+                      <a:solidFill>
+                        <a:srgbClr val="D9DEE0"/>
+                      </a:solidFill>
+                      <a:prstDash val="solid"/>
+                      <a:round/>
+                      <a:headEnd type="none" w="med" len="med"/>
+                      <a:tailEnd type="none" w="med" len="med"/>
+                    </a:lnR>
+                    <a:lnT w="6350" cap="flat" cmpd="sng" algn="ctr">
+                      <a:solidFill>
+                        <a:srgbClr val="D9DEE0"/>
+                      </a:solidFill>
+                      <a:prstDash val="solid"/>
+                      <a:round/>
+                      <a:headEnd type="none" w="med" len="med"/>
+                      <a:tailEnd type="none" w="med" len="med"/>
+                    </a:lnT>
+                    <a:lnB w="6350" cap="flat" cmpd="sng" algn="ctr">
+                      <a:solidFill>
+                        <a:srgbClr val="D9DEE0"/>
+                      </a:solidFill>
+                      <a:prstDash val="solid"/>
+                      <a:round/>
+                      <a:headEnd type="none" w="med" len="med"/>
+                      <a:tailEnd type="none" w="med" len="med"/>
+                    </a:lnB>
+                    <a:solidFill>
+                      <a:schemeClr val="bg1"/>
+                    </a:solidFill>
+                  </a:tcPr>
+                </a:tc>
+                <a:tc>
+                  <a:txBody>
+                    <a:bodyPr/>
+                    <a:lstStyle/>
+                    <a:p>
+                      <a:pPr indent="0" marL="0">
+                        <a:buNone/>
+                      </a:pPr>
+                      <a:r>
+                        <a:rPr lang="en-US" sz="1000" dirty="0">
+                          <a:solidFill>
+                            <a:schemeClr val="tx1"/>
+                          </a:solidFill>
+                          <a:latin typeface="Calibri" pitchFamily="34" charset="0"/>
+                          <a:ea typeface="Calibri" pitchFamily="34" charset="-122"/>
+                          <a:cs typeface="Calibri" pitchFamily="34" charset="-120"/>
+                        </a:rPr>
+                        <a:t>Binasa y BRR: canal</a:t>
+                      </a:r>
+                      <a:endParaRPr lang="en-US" sz="1000" dirty="0">
+                        <a:latin typeface="Calibri" charset="0"/>
+                        <a:ea typeface="Calibri" charset="0"/>
+                        <a:cs typeface="Calibri" charset="0"/>
+                      </a:endParaRPr>
+                    </a:p>
+                  </a:txBody>
+                  <a:tcPr marL="54864" marR="54864" marT="27432" marB="27432" anchor="t">
+                    <a:lnL w="6350" cap="flat" cmpd="sng" algn="ctr">
+                      <a:solidFill>
+                        <a:srgbClr val="D9DEE0"/>
+                      </a:solidFill>
+                      <a:prstDash val="solid"/>
+                      <a:round/>
+                      <a:headEnd type="none" w="med" len="med"/>
+                      <a:tailEnd type="none" w="med" len="med"/>
+                    </a:lnL>
+                    <a:lnR w="6350" cap="flat" cmpd="sng" algn="ctr">
+                      <a:solidFill>
+                        <a:srgbClr val="D9DEE0"/>
+                      </a:solidFill>
+                      <a:prstDash val="solid"/>
+                      <a:round/>
+                      <a:headEnd type="none" w="med" len="med"/>
+                      <a:tailEnd type="none" w="med" len="med"/>
+                    </a:lnR>
+                    <a:lnT w="6350" cap="flat" cmpd="sng" algn="ctr">
+                      <a:solidFill>
+                        <a:srgbClr val="D9DEE0"/>
+                      </a:solidFill>
+                      <a:prstDash val="solid"/>
+                      <a:round/>
+                      <a:headEnd type="none" w="med" len="med"/>
+                      <a:tailEnd type="none" w="med" len="med"/>
+                    </a:lnT>
+                    <a:lnB w="6350" cap="flat" cmpd="sng" algn="ctr">
+                      <a:solidFill>
+                        <a:srgbClr val="D9DEE0"/>
+                      </a:solidFill>
+                      <a:prstDash val="solid"/>
+                      <a:round/>
+                      <a:headEnd type="none" w="med" len="med"/>
+                      <a:tailEnd type="none" w="med" len="med"/>
+                    </a:lnB>
+                    <a:solidFill>
+                      <a:schemeClr val="bg1"/>
+                    </a:solidFill>
+                  </a:tcPr>
+                </a:tc>
+              </a:tr>
+              <a:tr h="0">
+                <a:tc gridSpan="5">
+                  <a:txBody>
+                    <a:bodyPr/>
+                    <a:lstStyle/>
+                    <a:p>
+                      <a:pPr indent="0" marL="0">
+                        <a:buNone/>
+                      </a:pPr>
+                      <a:r>
+                        <a:rPr lang="en-US" sz="1100" b="1" dirty="0">
+                          <a:solidFill>
+                            <a:schemeClr val="tx1"/>
+                          </a:solidFill>
+                          <a:latin typeface="Calibri" pitchFamily="34" charset="0"/>
+                          <a:ea typeface="Calibri" pitchFamily="34" charset="-122"/>
+                          <a:cs typeface="Calibri" pitchFamily="34" charset="-120"/>
+                        </a:rPr>
+                        <a:t>Declaradas por Marcos el 14-oct-2026; no están en el CRM del 12-ago-2026; sin verificar</a:t>
+                      </a:r>
+                      <a:endParaRPr lang="en-US" sz="1100" dirty="0">
+                        <a:latin typeface="Calibri" charset="0"/>
+                        <a:ea typeface="Calibri" charset="0"/>
+                        <a:cs typeface="Calibri" charset="0"/>
+                      </a:endParaRPr>
+                    </a:p>
+                  </a:txBody>
+                  <a:tcPr marL="54864" marR="54864" marT="27432" marB="27432">
+                    <a:lnL w="6350" cap="flat" cmpd="sng" algn="ctr">
+                      <a:solidFill>
+                        <a:srgbClr val="D9DEE0"/>
+                      </a:solidFill>
+                      <a:prstDash val="solid"/>
+                      <a:round/>
+                      <a:headEnd type="none" w="med" len="med"/>
+                      <a:tailEnd type="none" w="med" len="med"/>
+                    </a:lnL>
+                    <a:lnR w="6350" cap="flat" cmpd="sng" algn="ctr">
+                      <a:solidFill>
+                        <a:srgbClr val="D9DEE0"/>
+                      </a:solidFill>
+                      <a:prstDash val="solid"/>
+                      <a:round/>
+                      <a:headEnd type="none" w="med" len="med"/>
+                      <a:tailEnd type="none" w="med" len="med"/>
+                    </a:lnR>
+                    <a:lnT w="6350" cap="flat" cmpd="sng" algn="ctr">
+                      <a:solidFill>
+                        <a:srgbClr val="D9DEE0"/>
+                      </a:solidFill>
+                      <a:prstDash val="solid"/>
+                      <a:round/>
+                      <a:headEnd type="none" w="med" len="med"/>
+                      <a:tailEnd type="none" w="med" len="med"/>
+                    </a:lnT>
+                    <a:lnB w="6350" cap="flat" cmpd="sng" algn="ctr">
+                      <a:solidFill>
+                        <a:srgbClr val="D9DEE0"/>
+                      </a:solidFill>
+                      <a:prstDash val="solid"/>
+                      <a:round/>
+                      <a:headEnd type="none" w="med" len="med"/>
+                      <a:tailEnd type="none" w="med" len="med"/>
+                    </a:lnB>
+                    <a:solidFill>
+                      <a:schemeClr val="bg2"/>
+                    </a:solidFill>
+                  </a:tcPr>
+                </a:tc>
+                <a:tc hMerge="1">
+                  <a:tcPr/>
+                </a:tc>
+                <a:tc hMerge="1">
+                  <a:tcPr/>
+                </a:tc>
+                <a:tc hMerge="1">
+                  <a:tcPr/>
+                </a:tc>
+                <a:tc hMerge="1">
+                  <a:tcPr/>
+                </a:tc>
+              </a:tr>
+              <a:tr h="0">
+                <a:tc>
+                  <a:txBody>
+                    <a:bodyPr/>
+                    <a:lstStyle/>
+                    <a:p>
+                      <a:pPr indent="0" marL="0">
+                        <a:buNone/>
+                      </a:pPr>
+                      <a:r>
+                        <a:rPr lang="en-US" sz="1000" dirty="0">
+                          <a:solidFill>
+                            <a:schemeClr val="tx1"/>
+                          </a:solidFill>
+                          <a:latin typeface="Calibri" pitchFamily="34" charset="0"/>
+                          <a:ea typeface="Calibri" pitchFamily="34" charset="-122"/>
+                          <a:cs typeface="Calibri" pitchFamily="34" charset="-120"/>
+                        </a:rPr>
+                        <a:t>3.1 MI Grupo bafar, sab de cv - La piedad FP-HYDRAULICS-813492</a:t>
+                      </a:r>
+                      <a:endParaRPr lang="en-US" sz="1000" dirty="0">
+                        <a:latin typeface="Calibri" charset="0"/>
+                        <a:ea typeface="Calibri" charset="0"/>
+                        <a:cs typeface="Calibri" charset="0"/>
+                      </a:endParaRPr>
+                    </a:p>
+                  </a:txBody>
+                  <a:tcPr marL="54864" marR="54864" marT="27432" marB="27432" anchor="t">
+                    <a:lnL w="6350" cap="flat" cmpd="sng" algn="ctr">
+                      <a:solidFill>
+                        <a:srgbClr val="D9DEE0"/>
+                      </a:solidFill>
+                      <a:prstDash val="solid"/>
+                      <a:round/>
+                      <a:headEnd type="none" w="med" len="med"/>
+                      <a:tailEnd type="none" w="med" len="med"/>
+                    </a:lnL>
+                    <a:lnR w="6350" cap="flat" cmpd="sng" algn="ctr">
+                      <a:solidFill>
+                        <a:srgbClr val="D9DEE0"/>
+                      </a:solidFill>
+                      <a:prstDash val="solid"/>
+                      <a:round/>
+                      <a:headEnd type="none" w="med" len="med"/>
+                      <a:tailEnd type="none" w="med" len="med"/>
+                    </a:lnR>
+                    <a:lnT w="6350" cap="flat" cmpd="sng" algn="ctr">
+                      <a:solidFill>
+                        <a:srgbClr val="D9DEE0"/>
+                      </a:solidFill>
+                      <a:prstDash val="solid"/>
+                      <a:round/>
+                      <a:headEnd type="none" w="med" len="med"/>
+                      <a:tailEnd type="none" w="med" len="med"/>
+                    </a:lnT>
+                    <a:lnB w="6350" cap="flat" cmpd="sng" algn="ctr">
+                      <a:solidFill>
+                        <a:srgbClr val="D9DEE0"/>
+                      </a:solidFill>
+                      <a:prstDash val="solid"/>
+                      <a:round/>
+                      <a:headEnd type="none" w="med" len="med"/>
+                      <a:tailEnd type="none" w="med" len="med"/>
+                    </a:lnB>
+                    <a:solidFill>
+                      <a:schemeClr val="bg1"/>
+                    </a:solidFill>
+                  </a:tcPr>
+                </a:tc>
+                <a:tc>
+                  <a:txBody>
+                    <a:bodyPr/>
+                    <a:lstStyle/>
+                    <a:p>
+                      <a:pPr indent="0" marL="0">
+                        <a:buNone/>
+                      </a:pPr>
+                      <a:r>
+                        <a:rPr lang="en-US" sz="1000" dirty="0">
+                          <a:solidFill>
+                            <a:schemeClr val="tx1"/>
+                          </a:solidFill>
+                          <a:latin typeface="Calibri" pitchFamily="34" charset="0"/>
+                          <a:ea typeface="Calibri" pitchFamily="34" charset="-122"/>
+                          <a:cs typeface="Calibri" pitchFamily="34" charset="-120"/>
+                        </a:rPr>
+                        <a:t>813492</a:t>
+                      </a:r>
+                      <a:endParaRPr lang="en-US" sz="1000" dirty="0">
+                        <a:latin typeface="Calibri" charset="0"/>
+                        <a:ea typeface="Calibri" charset="0"/>
+                        <a:cs typeface="Calibri" charset="0"/>
+                      </a:endParaRPr>
+                    </a:p>
+                  </a:txBody>
+                  <a:tcPr marL="54864" marR="54864" marT="27432" marB="27432" anchor="t">
+                    <a:lnL w="6350" cap="flat" cmpd="sng" algn="ctr">
+                      <a:solidFill>
+                        <a:srgbClr val="D9DEE0"/>
+                      </a:solidFill>
+                      <a:prstDash val="solid"/>
+                      <a:round/>
+                      <a:headEnd type="none" w="med" len="med"/>
+                      <a:tailEnd type="none" w="med" len="med"/>
+                    </a:lnL>
+                    <a:lnR w="6350" cap="flat" cmpd="sng" algn="ctr">
+                      <a:solidFill>
+                        <a:srgbClr val="D9DEE0"/>
+                      </a:solidFill>
+                      <a:prstDash val="solid"/>
+                      <a:round/>
+                      <a:headEnd type="none" w="med" len="med"/>
+                      <a:tailEnd type="none" w="med" len="med"/>
+                    </a:lnR>
+                    <a:lnT w="6350" cap="flat" cmpd="sng" algn="ctr">
+                      <a:solidFill>
+                        <a:srgbClr val="D9DEE0"/>
+                      </a:solidFill>
+                      <a:prstDash val="solid"/>
+                      <a:round/>
+                      <a:headEnd type="none" w="med" len="med"/>
+                      <a:tailEnd type="none" w="med" len="med"/>
+                    </a:lnT>
+                    <a:lnB w="6350" cap="flat" cmpd="sng" algn="ctr">
+                      <a:solidFill>
+                        <a:srgbClr val="D9DEE0"/>
+                      </a:solidFill>
+                      <a:prstDash val="solid"/>
+                      <a:round/>
+                      <a:headEnd type="none" w="med" len="med"/>
+                      <a:tailEnd type="none" w="med" len="med"/>
+                    </a:lnB>
+                    <a:solidFill>
+                      <a:schemeClr val="bg1"/>
+                    </a:solidFill>
+                  </a:tcPr>
+                </a:tc>
+                <a:tc>
+                  <a:txBody>
+                    <a:bodyPr/>
+                    <a:lstStyle/>
+                    <a:p>
+                      <a:pPr indent="0" marL="0">
+                        <a:buNone/>
+                      </a:pPr>
+                      <a:r>
+                        <a:rPr lang="en-US" sz="1000" dirty="0">
+                          <a:solidFill>
+                            <a:schemeClr val="tx1"/>
+                          </a:solidFill>
+                          <a:latin typeface="Calibri" pitchFamily="34" charset="0"/>
+                          <a:ea typeface="Calibri" pitchFamily="34" charset="-122"/>
+                          <a:cs typeface="Calibri" pitchFamily="34" charset="-120"/>
+                        </a:rPr>
+                        <a:t>Abierta</a:t>
+                      </a:r>
+                      <a:endParaRPr lang="en-US" sz="1000" dirty="0">
+                        <a:latin typeface="Calibri" charset="0"/>
+                        <a:ea typeface="Calibri" charset="0"/>
+                        <a:cs typeface="Calibri" charset="0"/>
+                      </a:endParaRPr>
+                    </a:p>
+                  </a:txBody>
+                  <a:tcPr marL="54864" marR="54864" marT="27432" marB="27432" anchor="t">
+                    <a:lnL w="6350" cap="flat" cmpd="sng" algn="ctr">
+                      <a:solidFill>
+                        <a:srgbClr val="D9DEE0"/>
+                      </a:solidFill>
+                      <a:prstDash val="solid"/>
+                      <a:round/>
+                      <a:headEnd type="none" w="med" len="med"/>
+                      <a:tailEnd type="none" w="med" len="med"/>
+                    </a:lnL>
+                    <a:lnR w="6350" cap="flat" cmpd="sng" algn="ctr">
+                      <a:solidFill>
+                        <a:srgbClr val="D9DEE0"/>
+                      </a:solidFill>
+                      <a:prstDash val="solid"/>
+                      <a:round/>
+                      <a:headEnd type="none" w="med" len="med"/>
+                      <a:tailEnd type="none" w="med" len="med"/>
+                    </a:lnR>
+                    <a:lnT w="6350" cap="flat" cmpd="sng" algn="ctr">
+                      <a:solidFill>
+                        <a:srgbClr val="D9DEE0"/>
+                      </a:solidFill>
+                      <a:prstDash val="solid"/>
+                      <a:round/>
+                      <a:headEnd type="none" w="med" len="med"/>
+                      <a:tailEnd type="none" w="med" len="med"/>
+                    </a:lnT>
+                    <a:lnB w="6350" cap="flat" cmpd="sng" algn="ctr">
+                      <a:solidFill>
+                        <a:srgbClr val="D9DEE0"/>
+                      </a:solidFill>
+                      <a:prstDash val="solid"/>
+                      <a:round/>
+                      <a:headEnd type="none" w="med" len="med"/>
+                      <a:tailEnd type="none" w="med" len="med"/>
+                    </a:lnB>
+                    <a:solidFill>
+                      <a:schemeClr val="bg1"/>
+                    </a:solidFill>
+                  </a:tcPr>
+                </a:tc>
+                <a:tc>
+                  <a:txBody>
+                    <a:bodyPr/>
+                    <a:lstStyle/>
+                    <a:p>
+                      <a:pPr indent="0" marL="0">
+                        <a:buNone/>
+                      </a:pPr>
+                      <a:r>
+                        <a:rPr lang="en-US" sz="1000" dirty="0">
+                          <a:solidFill>
+                            <a:schemeClr val="tx1"/>
+                          </a:solidFill>
+                          <a:latin typeface="Calibri" pitchFamily="34" charset="0"/>
+                          <a:ea typeface="Calibri" pitchFamily="34" charset="-122"/>
+                          <a:cs typeface="Calibri" pitchFamily="34" charset="-120"/>
+                        </a:rPr>
+                        <a:t>650,220</a:t>
+                      </a:r>
+                      <a:endParaRPr lang="en-US" sz="1000" dirty="0">
+                        <a:latin typeface="Calibri" charset="0"/>
+                        <a:ea typeface="Calibri" charset="0"/>
+                        <a:cs typeface="Calibri" charset="0"/>
+                      </a:endParaRPr>
+                    </a:p>
+                  </a:txBody>
+                  <a:tcPr marL="54864" marR="54864" marT="27432" marB="27432" anchor="t">
+                    <a:lnL w="6350" cap="flat" cmpd="sng" algn="ctr">
+                      <a:solidFill>
+                        <a:srgbClr val="D9DEE0"/>
+                      </a:solidFill>
+                      <a:prstDash val="solid"/>
+                      <a:round/>
+                      <a:headEnd type="none" w="med" len="med"/>
+                      <a:tailEnd type="none" w="med" len="med"/>
+                    </a:lnL>
+                    <a:lnR w="6350" cap="flat" cmpd="sng" algn="ctr">
+                      <a:solidFill>
+                        <a:srgbClr val="D9DEE0"/>
+                      </a:solidFill>
+                      <a:prstDash val="solid"/>
+                      <a:round/>
+                      <a:headEnd type="none" w="med" len="med"/>
+                      <a:tailEnd type="none" w="med" len="med"/>
+                    </a:lnR>
+                    <a:lnT w="6350" cap="flat" cmpd="sng" algn="ctr">
+                      <a:solidFill>
+                        <a:srgbClr val="D9DEE0"/>
+                      </a:solidFill>
+                      <a:prstDash val="solid"/>
+                      <a:round/>
+                      <a:headEnd type="none" w="med" len="med"/>
+                      <a:tailEnd type="none" w="med" len="med"/>
+                    </a:lnT>
+                    <a:lnB w="6350" cap="flat" cmpd="sng" algn="ctr">
+                      <a:solidFill>
+                        <a:srgbClr val="D9DEE0"/>
+                      </a:solidFill>
+                      <a:prstDash val="solid"/>
+                      <a:round/>
+                      <a:headEnd type="none" w="med" len="med"/>
+                      <a:tailEnd type="none" w="med" len="med"/>
+                    </a:lnB>
+                    <a:solidFill>
+                      <a:schemeClr val="bg1"/>
+                    </a:solidFill>
+                  </a:tcPr>
+                </a:tc>
+                <a:tc>
+                  <a:txBody>
+                    <a:bodyPr/>
+                    <a:lstStyle/>
+                    <a:p>
+                      <a:pPr indent="0" marL="0">
+                        <a:buNone/>
+                      </a:pPr>
+                      <a:r>
+                        <a:rPr lang="en-US" sz="1000" dirty="0">
+                          <a:solidFill>
+                            <a:schemeClr val="tx1"/>
+                          </a:solidFill>
+                          <a:latin typeface="Calibri" pitchFamily="34" charset="0"/>
+                          <a:ea typeface="Calibri" pitchFamily="34" charset="-122"/>
+                          <a:cs typeface="Calibri" pitchFamily="34" charset="-120"/>
+                        </a:rPr>
+                        <a:t>Familia según la nomenclatura</a:t>
+                      </a:r>
+                      <a:endParaRPr lang="en-US" sz="1000" dirty="0">
+                        <a:latin typeface="Calibri" charset="0"/>
+                        <a:ea typeface="Calibri" charset="0"/>
+                        <a:cs typeface="Calibri" charset="0"/>
+                      </a:endParaRPr>
+                    </a:p>
+                  </a:txBody>
+                  <a:tcPr marL="54864" marR="54864" marT="27432" marB="27432" anchor="t">
+                    <a:lnL w="6350" cap="flat" cmpd="sng" algn="ctr">
+                      <a:solidFill>
+                        <a:srgbClr val="D9DEE0"/>
+                      </a:solidFill>
+                      <a:prstDash val="solid"/>
+                      <a:round/>
+                      <a:headEnd type="none" w="med" len="med"/>
+                      <a:tailEnd type="none" w="med" len="med"/>
+                    </a:lnL>
+                    <a:lnR w="6350" cap="flat" cmpd="sng" algn="ctr">
+                      <a:solidFill>
+                        <a:srgbClr val="D9DEE0"/>
+                      </a:solidFill>
+                      <a:prstDash val="solid"/>
+                      <a:round/>
+                      <a:headEnd type="none" w="med" len="med"/>
+                      <a:tailEnd type="none" w="med" len="med"/>
+                    </a:lnR>
+                    <a:lnT w="6350" cap="flat" cmpd="sng" algn="ctr">
+                      <a:solidFill>
+                        <a:srgbClr val="D9DEE0"/>
+                      </a:solidFill>
+                      <a:prstDash val="solid"/>
+                      <a:round/>
+                      <a:headEnd type="none" w="med" len="med"/>
+                      <a:tailEnd type="none" w="med" len="med"/>
+                    </a:lnT>
+                    <a:lnB w="6350" cap="flat" cmpd="sng" algn="ctr">
+                      <a:solidFill>
+                        <a:srgbClr val="D9DEE0"/>
+                      </a:solidFill>
+                      <a:prstDash val="solid"/>
+                      <a:round/>
+                      <a:headEnd type="none" w="med" len="med"/>
+                      <a:tailEnd type="none" w="med" len="med"/>
+                    </a:lnB>
+                    <a:solidFill>
+                      <a:schemeClr val="bg1"/>
+                    </a:solidFill>
+                  </a:tcPr>
+                </a:tc>
+              </a:tr>
+              <a:tr h="0">
+                <a:tc>
+                  <a:txBody>
+                    <a:bodyPr/>
+                    <a:lstStyle/>
+                    <a:p>
+                      <a:pPr indent="0" marL="0">
+                        <a:buNone/>
+                      </a:pPr>
+                      <a:r>
+                        <a:rPr lang="en-US" sz="1000" dirty="0">
+                          <a:solidFill>
+                            <a:schemeClr val="tx1"/>
+                          </a:solidFill>
+                          <a:latin typeface="Calibri" pitchFamily="34" charset="0"/>
+                          <a:ea typeface="Calibri" pitchFamily="34" charset="-122"/>
+                          <a:cs typeface="Calibri" pitchFamily="34" charset="-120"/>
+                        </a:rPr>
+                        <a:t>7.1 PTI Grupo bafar, sab de cv - La piedad- Ryasa Morelia PT-IND SYNCH BELTS-814010</a:t>
+                      </a:r>
+                      <a:endParaRPr lang="en-US" sz="1000" dirty="0">
+                        <a:latin typeface="Calibri" charset="0"/>
+                        <a:ea typeface="Calibri" charset="0"/>
+                        <a:cs typeface="Calibri" charset="0"/>
+                      </a:endParaRPr>
+                    </a:p>
+                  </a:txBody>
+                  <a:tcPr marL="54864" marR="54864" marT="27432" marB="27432" anchor="t">
+                    <a:lnL w="6350" cap="flat" cmpd="sng" algn="ctr">
+                      <a:solidFill>
+                        <a:srgbClr val="D9DEE0"/>
+                      </a:solidFill>
+                      <a:prstDash val="solid"/>
+                      <a:round/>
+                      <a:headEnd type="none" w="med" len="med"/>
+                      <a:tailEnd type="none" w="med" len="med"/>
+                    </a:lnL>
+                    <a:lnR w="6350" cap="flat" cmpd="sng" algn="ctr">
+                      <a:solidFill>
+                        <a:srgbClr val="D9DEE0"/>
+                      </a:solidFill>
+                      <a:prstDash val="solid"/>
+                      <a:round/>
+                      <a:headEnd type="none" w="med" len="med"/>
+                      <a:tailEnd type="none" w="med" len="med"/>
+                    </a:lnR>
+                    <a:lnT w="6350" cap="flat" cmpd="sng" algn="ctr">
+                      <a:solidFill>
+                        <a:srgbClr val="D9DEE0"/>
+                      </a:solidFill>
+                      <a:prstDash val="solid"/>
+                      <a:round/>
+                      <a:headEnd type="none" w="med" len="med"/>
+                      <a:tailEnd type="none" w="med" len="med"/>
+                    </a:lnT>
+                    <a:lnB w="6350" cap="flat" cmpd="sng" algn="ctr">
+                      <a:solidFill>
+                        <a:srgbClr val="D9DEE0"/>
+                      </a:solidFill>
+                      <a:prstDash val="solid"/>
+                      <a:round/>
+                      <a:headEnd type="none" w="med" len="med"/>
+                      <a:tailEnd type="none" w="med" len="med"/>
+                    </a:lnB>
+                    <a:solidFill>
+                      <a:schemeClr val="bg1"/>
+                    </a:solidFill>
+                  </a:tcPr>
+                </a:tc>
+                <a:tc>
+                  <a:txBody>
+                    <a:bodyPr/>
+                    <a:lstStyle/>
+                    <a:p>
+                      <a:pPr indent="0" marL="0">
+                        <a:buNone/>
+                      </a:pPr>
+                      <a:r>
+                        <a:rPr lang="en-US" sz="1000" dirty="0">
+                          <a:solidFill>
+                            <a:schemeClr val="tx1"/>
+                          </a:solidFill>
+                          <a:latin typeface="Calibri" pitchFamily="34" charset="0"/>
+                          <a:ea typeface="Calibri" pitchFamily="34" charset="-122"/>
+                          <a:cs typeface="Calibri" pitchFamily="34" charset="-120"/>
+                        </a:rPr>
+                        <a:t>814010</a:t>
+                      </a:r>
+                      <a:endParaRPr lang="en-US" sz="1000" dirty="0">
+                        <a:latin typeface="Calibri" charset="0"/>
+                        <a:ea typeface="Calibri" charset="0"/>
+                        <a:cs typeface="Calibri" charset="0"/>
+                      </a:endParaRPr>
+                    </a:p>
+                  </a:txBody>
+                  <a:tcPr marL="54864" marR="54864" marT="27432" marB="27432" anchor="t">
+                    <a:lnL w="6350" cap="flat" cmpd="sng" algn="ctr">
+                      <a:solidFill>
+                        <a:srgbClr val="D9DEE0"/>
+                      </a:solidFill>
+                      <a:prstDash val="solid"/>
+                      <a:round/>
+                      <a:headEnd type="none" w="med" len="med"/>
+                      <a:tailEnd type="none" w="med" len="med"/>
+                    </a:lnL>
+                    <a:lnR w="6350" cap="flat" cmpd="sng" algn="ctr">
+                      <a:solidFill>
+                        <a:srgbClr val="D9DEE0"/>
+                      </a:solidFill>
+                      <a:prstDash val="solid"/>
+                      <a:round/>
+                      <a:headEnd type="none" w="med" len="med"/>
+                      <a:tailEnd type="none" w="med" len="med"/>
+                    </a:lnR>
+                    <a:lnT w="6350" cap="flat" cmpd="sng" algn="ctr">
+                      <a:solidFill>
+                        <a:srgbClr val="D9DEE0"/>
+                      </a:solidFill>
+                      <a:prstDash val="solid"/>
+                      <a:round/>
+                      <a:headEnd type="none" w="med" len="med"/>
+                      <a:tailEnd type="none" w="med" len="med"/>
+                    </a:lnT>
+                    <a:lnB w="6350" cap="flat" cmpd="sng" algn="ctr">
+                      <a:solidFill>
+                        <a:srgbClr val="D9DEE0"/>
+                      </a:solidFill>
+                      <a:prstDash val="solid"/>
+                      <a:round/>
+                      <a:headEnd type="none" w="med" len="med"/>
+                      <a:tailEnd type="none" w="med" len="med"/>
+                    </a:lnB>
+                    <a:solidFill>
+                      <a:schemeClr val="bg1"/>
+                    </a:solidFill>
+                  </a:tcPr>
+                </a:tc>
+                <a:tc>
+                  <a:txBody>
+                    <a:bodyPr/>
+                    <a:lstStyle/>
+                    <a:p>
+                      <a:pPr indent="0" marL="0">
+                        <a:buNone/>
+                      </a:pPr>
+                      <a:r>
+                        <a:rPr lang="en-US" sz="1000" dirty="0">
+                          <a:solidFill>
+                            <a:schemeClr val="tx1"/>
+                          </a:solidFill>
+                          <a:latin typeface="Calibri" pitchFamily="34" charset="0"/>
+                          <a:ea typeface="Calibri" pitchFamily="34" charset="-122"/>
+                          <a:cs typeface="Calibri" pitchFamily="34" charset="-120"/>
+                        </a:rPr>
+                        <a:t>Abierta</a:t>
+                      </a:r>
+                      <a:endParaRPr lang="en-US" sz="1000" dirty="0">
+                        <a:latin typeface="Calibri" charset="0"/>
+                        <a:ea typeface="Calibri" charset="0"/>
+                        <a:cs typeface="Calibri" charset="0"/>
+                      </a:endParaRPr>
+                    </a:p>
+                  </a:txBody>
+                  <a:tcPr marL="54864" marR="54864" marT="27432" marB="27432" anchor="t">
+                    <a:lnL w="6350" cap="flat" cmpd="sng" algn="ctr">
+                      <a:solidFill>
+                        <a:srgbClr val="D9DEE0"/>
+                      </a:solidFill>
+                      <a:prstDash val="solid"/>
+                      <a:round/>
+                      <a:headEnd type="none" w="med" len="med"/>
+                      <a:tailEnd type="none" w="med" len="med"/>
+                    </a:lnL>
+                    <a:lnR w="6350" cap="flat" cmpd="sng" algn="ctr">
+                      <a:solidFill>
+                        <a:srgbClr val="D9DEE0"/>
+                      </a:solidFill>
+                      <a:prstDash val="solid"/>
+                      <a:round/>
+                      <a:headEnd type="none" w="med" len="med"/>
+                      <a:tailEnd type="none" w="med" len="med"/>
+                    </a:lnR>
+                    <a:lnT w="6350" cap="flat" cmpd="sng" algn="ctr">
+                      <a:solidFill>
+                        <a:srgbClr val="D9DEE0"/>
+                      </a:solidFill>
+                      <a:prstDash val="solid"/>
+                      <a:round/>
+                      <a:headEnd type="none" w="med" len="med"/>
+                      <a:tailEnd type="none" w="med" len="med"/>
+                    </a:lnT>
+                    <a:lnB w="6350" cap="flat" cmpd="sng" algn="ctr">
+                      <a:solidFill>
+                        <a:srgbClr val="D9DEE0"/>
+                      </a:solidFill>
+                      <a:prstDash val="solid"/>
+                      <a:round/>
+                      <a:headEnd type="none" w="med" len="med"/>
+                      <a:tailEnd type="none" w="med" len="med"/>
+                    </a:lnB>
+                    <a:solidFill>
+                      <a:schemeClr val="bg1"/>
+                    </a:solidFill>
+                  </a:tcPr>
+                </a:tc>
+                <a:tc>
+                  <a:txBody>
+                    <a:bodyPr/>
+                    <a:lstStyle/>
+                    <a:p>
+                      <a:pPr indent="0" marL="0">
+                        <a:buNone/>
+                      </a:pPr>
+                      <a:r>
+                        <a:rPr lang="en-US" sz="1000" dirty="0">
+                          <a:solidFill>
+                            <a:schemeClr val="tx1"/>
+                          </a:solidFill>
+                          <a:latin typeface="Calibri" pitchFamily="34" charset="0"/>
+                          <a:ea typeface="Calibri" pitchFamily="34" charset="-122"/>
+                          <a:cs typeface="Calibri" pitchFamily="34" charset="-120"/>
+                        </a:rPr>
+                        <a:t>265,000</a:t>
+                      </a:r>
+                      <a:endParaRPr lang="en-US" sz="1000" dirty="0">
+                        <a:latin typeface="Calibri" charset="0"/>
+                        <a:ea typeface="Calibri" charset="0"/>
+                        <a:cs typeface="Calibri" charset="0"/>
+                      </a:endParaRPr>
+                    </a:p>
+                  </a:txBody>
+                  <a:tcPr marL="54864" marR="54864" marT="27432" marB="27432" anchor="t">
+                    <a:lnL w="6350" cap="flat" cmpd="sng" algn="ctr">
+                      <a:solidFill>
+                        <a:srgbClr val="D9DEE0"/>
+                      </a:solidFill>
+                      <a:prstDash val="solid"/>
+                      <a:round/>
+                      <a:headEnd type="none" w="med" len="med"/>
+                      <a:tailEnd type="none" w="med" len="med"/>
+                    </a:lnL>
+                    <a:lnR w="6350" cap="flat" cmpd="sng" algn="ctr">
+                      <a:solidFill>
+                        <a:srgbClr val="D9DEE0"/>
+                      </a:solidFill>
+                      <a:prstDash val="solid"/>
+                      <a:round/>
+                      <a:headEnd type="none" w="med" len="med"/>
+                      <a:tailEnd type="none" w="med" len="med"/>
+                    </a:lnR>
+                    <a:lnT w="6350" cap="flat" cmpd="sng" algn="ctr">
+                      <a:solidFill>
+                        <a:srgbClr val="D9DEE0"/>
+                      </a:solidFill>
+                      <a:prstDash val="solid"/>
+                      <a:round/>
+                      <a:headEnd type="none" w="med" len="med"/>
+                      <a:tailEnd type="none" w="med" len="med"/>
+                    </a:lnT>
+                    <a:lnB w="6350" cap="flat" cmpd="sng" algn="ctr">
+                      <a:solidFill>
+                        <a:srgbClr val="D9DEE0"/>
+                      </a:solidFill>
+                      <a:prstDash val="solid"/>
+                      <a:round/>
+                      <a:headEnd type="none" w="med" len="med"/>
+                      <a:tailEnd type="none" w="med" len="med"/>
+                    </a:lnB>
+                    <a:solidFill>
+                      <a:schemeClr val="bg1"/>
+                    </a:solidFill>
+                  </a:tcPr>
+                </a:tc>
+                <a:tc>
+                  <a:txBody>
+                    <a:bodyPr/>
+                    <a:lstStyle/>
+                    <a:p>
+                      <a:pPr indent="0" marL="0">
+                        <a:buNone/>
+                      </a:pPr>
+                      <a:r>
+                        <a:rPr lang="en-US" sz="1000" dirty="0">
+                          <a:solidFill>
+                            <a:schemeClr val="tx1"/>
+                          </a:solidFill>
+                          <a:latin typeface="Calibri" pitchFamily="34" charset="0"/>
+                          <a:ea typeface="Calibri" pitchFamily="34" charset="-122"/>
+                          <a:cs typeface="Calibri" pitchFamily="34" charset="-120"/>
+                        </a:rPr>
+                        <a:t>Ryasa: canal</a:t>
+                      </a:r>
+                      <a:endParaRPr lang="en-US" sz="1000" dirty="0">
+                        <a:latin typeface="Calibri" charset="0"/>
+                        <a:ea typeface="Calibri" charset="0"/>
+                        <a:cs typeface="Calibri" charset="0"/>
+                      </a:endParaRPr>
+                    </a:p>
+                  </a:txBody>
+                  <a:tcPr marL="54864" marR="54864" marT="27432" marB="27432" anchor="t">
+                    <a:lnL w="6350" cap="flat" cmpd="sng" algn="ctr">
+                      <a:solidFill>
+                        <a:srgbClr val="D9DEE0"/>
+                      </a:solidFill>
+                      <a:prstDash val="solid"/>
+                      <a:round/>
+                      <a:headEnd type="none" w="med" len="med"/>
+                      <a:tailEnd type="none" w="med" len="med"/>
+                    </a:lnL>
+                    <a:lnR w="6350" cap="flat" cmpd="sng" algn="ctr">
+                      <a:solidFill>
+                        <a:srgbClr val="D9DEE0"/>
+                      </a:solidFill>
+                      <a:prstDash val="solid"/>
+                      <a:round/>
+                      <a:headEnd type="none" w="med" len="med"/>
+                      <a:tailEnd type="none" w="med" len="med"/>
+                    </a:lnR>
+                    <a:lnT w="6350" cap="flat" cmpd="sng" algn="ctr">
+                      <a:solidFill>
+                        <a:srgbClr val="D9DEE0"/>
+                      </a:solidFill>
+                      <a:prstDash val="solid"/>
+                      <a:round/>
+                      <a:headEnd type="none" w="med" len="med"/>
+                      <a:tailEnd type="none" w="med" len="med"/>
+                    </a:lnT>
+                    <a:lnB w="6350" cap="flat" cmpd="sng" algn="ctr">
+                      <a:solidFill>
+                        <a:srgbClr val="D9DEE0"/>
+                      </a:solidFill>
+                      <a:prstDash val="solid"/>
+                      <a:round/>
+                      <a:headEnd type="none" w="med" len="med"/>
+                      <a:tailEnd type="none" w="med" len="med"/>
+                    </a:lnB>
+                    <a:solidFill>
+                      <a:schemeClr val="bg1"/>
+                    </a:solidFill>
+                  </a:tcPr>
+                </a:tc>
+              </a:tr>
+              <a:tr h="0">
+                <a:tc>
+                  <a:txBody>
+                    <a:bodyPr/>
+                    <a:lstStyle/>
+                    <a:p>
+                      <a:pPr indent="0" marL="0">
+                        <a:buNone/>
+                      </a:pPr>
+                      <a:r>
+                        <a:rPr lang="en-US" sz="1000" dirty="0">
+                          <a:solidFill>
+                            <a:schemeClr val="tx1"/>
+                          </a:solidFill>
+                          <a:latin typeface="Calibri" pitchFamily="34" charset="0"/>
+                          <a:ea typeface="Calibri" pitchFamily="34" charset="-122"/>
+                          <a:cs typeface="Calibri" pitchFamily="34" charset="-120"/>
+                        </a:rPr>
+                        <a:t>7.1 HID EFG5K Grupo Occidente S.A. de C.V. Acatlan Jal - DBS Gdl</a:t>
+                      </a:r>
+                      <a:endParaRPr lang="en-US" sz="1000" dirty="0">
+                        <a:latin typeface="Calibri" charset="0"/>
+                        <a:ea typeface="Calibri" charset="0"/>
+                        <a:cs typeface="Calibri" charset="0"/>
+                      </a:endParaRPr>
+                    </a:p>
+                  </a:txBody>
+                  <a:tcPr marL="54864" marR="54864" marT="27432" marB="27432" anchor="t">
+                    <a:lnL w="6350" cap="flat" cmpd="sng" algn="ctr">
+                      <a:solidFill>
+                        <a:srgbClr val="D9DEE0"/>
+                      </a:solidFill>
+                      <a:prstDash val="solid"/>
+                      <a:round/>
+                      <a:headEnd type="none" w="med" len="med"/>
+                      <a:tailEnd type="none" w="med" len="med"/>
+                    </a:lnL>
+                    <a:lnR w="6350" cap="flat" cmpd="sng" algn="ctr">
+                      <a:solidFill>
+                        <a:srgbClr val="D9DEE0"/>
+                      </a:solidFill>
+                      <a:prstDash val="solid"/>
+                      <a:round/>
+                      <a:headEnd type="none" w="med" len="med"/>
+                      <a:tailEnd type="none" w="med" len="med"/>
+                    </a:lnR>
+                    <a:lnT w="6350" cap="flat" cmpd="sng" algn="ctr">
+                      <a:solidFill>
+                        <a:srgbClr val="D9DEE0"/>
+                      </a:solidFill>
+                      <a:prstDash val="solid"/>
+                      <a:round/>
+                      <a:headEnd type="none" w="med" len="med"/>
+                      <a:tailEnd type="none" w="med" len="med"/>
+                    </a:lnT>
+                    <a:lnB w="6350" cap="flat" cmpd="sng" algn="ctr">
+                      <a:solidFill>
+                        <a:srgbClr val="D9DEE0"/>
+                      </a:solidFill>
+                      <a:prstDash val="solid"/>
+                      <a:round/>
+                      <a:headEnd type="none" w="med" len="med"/>
+                      <a:tailEnd type="none" w="med" len="med"/>
+                    </a:lnB>
+                    <a:solidFill>
+                      <a:schemeClr val="bg1"/>
+                    </a:solidFill>
+                  </a:tcPr>
+                </a:tc>
+                <a:tc>
+                  <a:txBody>
+                    <a:bodyPr/>
+                    <a:lstStyle/>
+                    <a:p>
+                      <a:pPr indent="0" marL="0">
+                        <a:buNone/>
+                      </a:pPr>
+                      <a:r>
+                        <a:rPr lang="en-US" sz="1000" dirty="0">
+                          <a:solidFill>
+                            <a:schemeClr val="tx1"/>
+                          </a:solidFill>
+                          <a:latin typeface="Calibri" pitchFamily="34" charset="0"/>
+                          <a:ea typeface="Calibri" pitchFamily="34" charset="-122"/>
+                          <a:cs typeface="Calibri" pitchFamily="34" charset="-120"/>
+                        </a:rPr>
+                        <a:t>PENDIENTE</a:t>
+                      </a:r>
+                      <a:endParaRPr lang="en-US" sz="1000" dirty="0">
+                        <a:latin typeface="Calibri" charset="0"/>
+                        <a:ea typeface="Calibri" charset="0"/>
+                        <a:cs typeface="Calibri" charset="0"/>
+                      </a:endParaRPr>
+                    </a:p>
+                  </a:txBody>
+                  <a:tcPr marL="54864" marR="54864" marT="27432" marB="27432" anchor="t">
+                    <a:lnL w="6350" cap="flat" cmpd="sng" algn="ctr">
+                      <a:solidFill>
+                        <a:srgbClr val="D9DEE0"/>
+                      </a:solidFill>
+                      <a:prstDash val="solid"/>
+                      <a:round/>
+                      <a:headEnd type="none" w="med" len="med"/>
+                      <a:tailEnd type="none" w="med" len="med"/>
+                    </a:lnL>
+                    <a:lnR w="6350" cap="flat" cmpd="sng" algn="ctr">
+                      <a:solidFill>
+                        <a:srgbClr val="D9DEE0"/>
+                      </a:solidFill>
+                      <a:prstDash val="solid"/>
+                      <a:round/>
+                      <a:headEnd type="none" w="med" len="med"/>
+                      <a:tailEnd type="none" w="med" len="med"/>
+                    </a:lnR>
+                    <a:lnT w="6350" cap="flat" cmpd="sng" algn="ctr">
+                      <a:solidFill>
+                        <a:srgbClr val="D9DEE0"/>
+                      </a:solidFill>
+                      <a:prstDash val="solid"/>
+                      <a:round/>
+                      <a:headEnd type="none" w="med" len="med"/>
+                      <a:tailEnd type="none" w="med" len="med"/>
+                    </a:lnT>
+                    <a:lnB w="6350" cap="flat" cmpd="sng" algn="ctr">
+                      <a:solidFill>
+                        <a:srgbClr val="D9DEE0"/>
+                      </a:solidFill>
+                      <a:prstDash val="solid"/>
+                      <a:round/>
+                      <a:headEnd type="none" w="med" len="med"/>
+                      <a:tailEnd type="none" w="med" len="med"/>
+                    </a:lnB>
+                    <a:solidFill>
+                      <a:schemeClr val="bg1"/>
+                    </a:solidFill>
+                  </a:tcPr>
+                </a:tc>
+                <a:tc>
+                  <a:txBody>
+                    <a:bodyPr/>
+                    <a:lstStyle/>
+                    <a:p>
+                      <a:pPr indent="0" marL="0">
+                        <a:buNone/>
+                      </a:pPr>
+                      <a:r>
+                        <a:rPr lang="en-US" sz="1000" dirty="0">
+                          <a:solidFill>
+                            <a:schemeClr val="tx1"/>
+                          </a:solidFill>
+                          <a:latin typeface="Calibri" pitchFamily="34" charset="0"/>
+                          <a:ea typeface="Calibri" pitchFamily="34" charset="-122"/>
+                          <a:cs typeface="Calibri" pitchFamily="34" charset="-120"/>
+                        </a:rPr>
+                        <a:t>Abierta</a:t>
+                      </a:r>
+                      <a:endParaRPr lang="en-US" sz="1000" dirty="0">
+                        <a:latin typeface="Calibri" charset="0"/>
+                        <a:ea typeface="Calibri" charset="0"/>
+                        <a:cs typeface="Calibri" charset="0"/>
+                      </a:endParaRPr>
+                    </a:p>
+                  </a:txBody>
+                  <a:tcPr marL="54864" marR="54864" marT="27432" marB="27432" anchor="t">
+                    <a:lnL w="6350" cap="flat" cmpd="sng" algn="ctr">
+                      <a:solidFill>
+                        <a:srgbClr val="D9DEE0"/>
+                      </a:solidFill>
+                      <a:prstDash val="solid"/>
+                      <a:round/>
+                      <a:headEnd type="none" w="med" len="med"/>
+                      <a:tailEnd type="none" w="med" len="med"/>
+                    </a:lnL>
+                    <a:lnR w="6350" cap="flat" cmpd="sng" algn="ctr">
+                      <a:solidFill>
+                        <a:srgbClr val="D9DEE0"/>
+                      </a:solidFill>
+                      <a:prstDash val="solid"/>
+                      <a:round/>
+                      <a:headEnd type="none" w="med" len="med"/>
+                      <a:tailEnd type="none" w="med" len="med"/>
+                    </a:lnR>
+                    <a:lnT w="6350" cap="flat" cmpd="sng" algn="ctr">
+                      <a:solidFill>
+                        <a:srgbClr val="D9DEE0"/>
+                      </a:solidFill>
+                      <a:prstDash val="solid"/>
+                      <a:round/>
+                      <a:headEnd type="none" w="med" len="med"/>
+                      <a:tailEnd type="none" w="med" len="med"/>
+                    </a:lnT>
+                    <a:lnB w="6350" cap="flat" cmpd="sng" algn="ctr">
+                      <a:solidFill>
+                        <a:srgbClr val="D9DEE0"/>
+                      </a:solidFill>
+                      <a:prstDash val="solid"/>
+                      <a:round/>
+                      <a:headEnd type="none" w="med" len="med"/>
+                      <a:tailEnd type="none" w="med" len="med"/>
+                    </a:lnB>
+                    <a:solidFill>
+                      <a:schemeClr val="bg1"/>
+                    </a:solidFill>
+                  </a:tcPr>
+                </a:tc>
+                <a:tc>
+                  <a:txBody>
+                    <a:bodyPr/>
+                    <a:lstStyle/>
+                    <a:p>
+                      <a:pPr indent="0" marL="0">
+                        <a:buNone/>
+                      </a:pPr>
+                      <a:r>
+                        <a:rPr lang="en-US" sz="1000" dirty="0">
+                          <a:solidFill>
+                            <a:schemeClr val="tx1"/>
+                          </a:solidFill>
+                          <a:latin typeface="Calibri" pitchFamily="34" charset="0"/>
+                          <a:ea typeface="Calibri" pitchFamily="34" charset="-122"/>
+                          <a:cs typeface="Calibri" pitchFamily="34" charset="-120"/>
+                        </a:rPr>
+                        <a:t>PENDIENTE</a:t>
+                      </a:r>
+                      <a:endParaRPr lang="en-US" sz="1000" dirty="0">
+                        <a:latin typeface="Calibri" charset="0"/>
+                        <a:ea typeface="Calibri" charset="0"/>
+                        <a:cs typeface="Calibri" charset="0"/>
+                      </a:endParaRPr>
+                    </a:p>
+                  </a:txBody>
+                  <a:tcPr marL="54864" marR="54864" marT="27432" marB="27432" anchor="t">
+                    <a:lnL w="6350" cap="flat" cmpd="sng" algn="ctr">
+                      <a:solidFill>
+                        <a:srgbClr val="D9DEE0"/>
+                      </a:solidFill>
+                      <a:prstDash val="solid"/>
+                      <a:round/>
+                      <a:headEnd type="none" w="med" len="med"/>
+                      <a:tailEnd type="none" w="med" len="med"/>
+                    </a:lnL>
+                    <a:lnR w="6350" cap="flat" cmpd="sng" algn="ctr">
+                      <a:solidFill>
+                        <a:srgbClr val="D9DEE0"/>
+                      </a:solidFill>
+                      <a:prstDash val="solid"/>
+                      <a:round/>
+                      <a:headEnd type="none" w="med" len="med"/>
+                      <a:tailEnd type="none" w="med" len="med"/>
+                    </a:lnR>
+                    <a:lnT w="6350" cap="flat" cmpd="sng" algn="ctr">
+                      <a:solidFill>
+                        <a:srgbClr val="D9DEE0"/>
+                      </a:solidFill>
+                      <a:prstDash val="solid"/>
+                      <a:round/>
+                      <a:headEnd type="none" w="med" len="med"/>
+                      <a:tailEnd type="none" w="med" len="med"/>
+                    </a:lnT>
+                    <a:lnB w="6350" cap="flat" cmpd="sng" algn="ctr">
+                      <a:solidFill>
+                        <a:srgbClr val="D9DEE0"/>
+                      </a:solidFill>
+                      <a:prstDash val="solid"/>
+                      <a:round/>
+                      <a:headEnd type="none" w="med" len="med"/>
+                      <a:tailEnd type="none" w="med" len="med"/>
+                    </a:lnB>
+                    <a:solidFill>
+                      <a:schemeClr val="bg1"/>
+                    </a:solidFill>
+                  </a:tcPr>
+                </a:tc>
+                <a:tc>
+                  <a:txBody>
+                    <a:bodyPr/>
+                    <a:lstStyle/>
+                    <a:p>
+                      <a:pPr indent="0" marL="0">
+                        <a:buNone/>
+                      </a:pPr>
+                      <a:r>
+                        <a:rPr lang="en-US" sz="1000" dirty="0">
+                          <a:solidFill>
+                            <a:schemeClr val="tx1"/>
+                          </a:solidFill>
+                          <a:latin typeface="Calibri" pitchFamily="34" charset="0"/>
+                          <a:ea typeface="Calibri" pitchFamily="34" charset="-122"/>
+                          <a:cs typeface="Calibri" pitchFamily="34" charset="-120"/>
+                        </a:rPr>
+                        <a:t>DBS: canal. Máquina y número de parte: no se deducen</a:t>
+                      </a:r>
+                      <a:endParaRPr lang="en-US" sz="1000" dirty="0">
+                        <a:latin typeface="Calibri" charset="0"/>
+                        <a:ea typeface="Calibri" charset="0"/>
+                        <a:cs typeface="Calibri" charset="0"/>
+                      </a:endParaRPr>
+                    </a:p>
+                  </a:txBody>
+                  <a:tcPr marL="54864" marR="54864" marT="27432" marB="27432" anchor="t">
+                    <a:lnL w="6350" cap="flat" cmpd="sng" algn="ctr">
+                      <a:solidFill>
+                        <a:srgbClr val="D9DEE0"/>
+                      </a:solidFill>
+                      <a:prstDash val="solid"/>
+                      <a:round/>
+                      <a:headEnd type="none" w="med" len="med"/>
+                      <a:tailEnd type="none" w="med" len="med"/>
+                    </a:lnL>
+                    <a:lnR w="6350" cap="flat" cmpd="sng" algn="ctr">
+                      <a:solidFill>
+                        <a:srgbClr val="D9DEE0"/>
+                      </a:solidFill>
+                      <a:prstDash val="solid"/>
+                      <a:round/>
+                      <a:headEnd type="none" w="med" len="med"/>
+                      <a:tailEnd type="none" w="med" len="med"/>
+                    </a:lnR>
+                    <a:lnT w="6350" cap="flat" cmpd="sng" algn="ctr">
+                      <a:solidFill>
+                        <a:srgbClr val="D9DEE0"/>
+                      </a:solidFill>
+                      <a:prstDash val="solid"/>
+                      <a:round/>
+                      <a:headEnd type="none" w="med" len="med"/>
+                      <a:tailEnd type="none" w="med" len="med"/>
+                    </a:lnT>
+                    <a:lnB w="6350" cap="flat" cmpd="sng" algn="ctr">
+                      <a:solidFill>
+                        <a:srgbClr val="D9DEE0"/>
+                      </a:solidFill>
+                      <a:prstDash val="solid"/>
+                      <a:round/>
+                      <a:headEnd type="none" w="med" len="med"/>
+                      <a:tailEnd type="none" w="med" len="med"/>
+                    </a:lnB>
+                    <a:solidFill>
+                      <a:schemeClr val="bg1"/>
+                    </a:solidFill>
+                  </a:tcPr>
+                </a:tc>
+              </a:tr>
+            </a:tbl>
+          </a:graphicData>
+        </a:graphic>
+      </p:graphicFrame>
+      <p:sp>
+        <p:nvSpPr>
+          <p:cNvPr id="4" name="Text 1"/>
+          <p:cNvSpPr txBox="1"/>
+          <p:nvPr/>
+        </p:nvSpPr>
+        <p:spPr>
+          <a:xfrm>
+            <a:off x="548640" y="5989320"/>
+            <a:ext cx="11091672" cy="411480"/>
+          </a:xfrm>
+          <a:prstGeom prst="rect">
+            <a:avLst/>
+          </a:prstGeom>
+          <a:noFill/>
+          <a:ln/>
+        </p:spPr>
+        <p:txBody>
+          <a:bodyPr wrap="square" lIns="0" tIns="0" rIns="0" bIns="0" rtlCol="0" anchor="t"/>
+          <a:lstStyle/>
+          <a:p>
+            <a:pPr indent="0" marL="0">
+              <a:buNone/>
+            </a:pPr>
+            <a:r>
+              <a:rPr lang="en-US" sz="1000" dirty="0">
+                <a:solidFill>
+                  <a:schemeClr val="accent4"/>
+                </a:solidFill>
+                <a:latin typeface="Calibri" pitchFamily="34" charset="0"/>
+                <a:ea typeface="Calibri" pitchFamily="34" charset="-122"/>
+                <a:cs typeface="Calibri" pitchFamily="34" charset="-120"/>
+              </a:rPr>
+              <a:t>Los montos son potencial anual registrado, no facturación. Los montos de las oportunidades declaradas son los que dio Marcos. Las dos de Grupo Occidente comparten la Cliente clave GRUPO OCCIDENTE S.A. DE C.V. ACATLAN JAL con la oportunidad de GAO; que esa cuenta sea la empresa de gaoaluminio.com lo afirma Marcos, la web no lo confirma. Responsables históricos del CRM: confirmar el vigente antes de asignar trabajo.</a:t>
+            </a:r>
+            <a:endParaRPr lang="en-US" sz="1000" dirty="0"/>
+          </a:p>
+        </p:txBody>
+      </p:sp>
+      <p:sp>
+        <p:nvSpPr>
+          <p:cNvPr id="25" name="Slide Number Placeholder 0"/>
+          <p:cNvSpPr>
+            <a:spLocks noGrp="1"/>
+          </p:cNvSpPr>
+          <p:nvPr>
+            <p:ph type="sldNum" sz="quarter" idx="4294967295"/>
+          </p:nvPr>
+        </p:nvSpPr>
+        <p:spPr>
+          <a:xfrm>
+            <a:off x="11338560" y="6446520"/>
+            <a:ext cx="457200" cy="274320"/>
+          </a:xfrm>
+          <a:prstGeom prst="rect">
+            <a:avLst/>
+          </a:prstGeom>
+          <a:extLst>
+            <a:ext uri="{C572A759-6A51-4108-AA02-DFA0A04FC94B}">
+              <ma14:wrappingTextBoxFlag xmlns:ma14="http://schemas.microsoft.com/office/mac/drawingml/2011/main" val="0"/>
+            </a:ext>
+          </a:extLst>
+        </p:spPr>
+        <p:txBody>
+          <a:bodyPr/>
+          <a:lstStyle>
+            <a:lvl1pPr>
+              <a:defRPr sz="1000">
+                <a:solidFill>
+                  <a:schemeClr val="accent4"/>
+                </a:solidFill>
+              </a:defRPr>
+            </a:lvl1pPr>
+          </a:lstStyle>
+          <a:p>
+            <a:pPr algn="r"/>
+            <a:fld id="{F7021451-1387-4CA6-816F-3879F97B5CBC}" type="slidenum">
+              <a:rPr b="0" lang="en-US"/>
+              <a:t>11</a:t>
             </a:fld>
             <a:endParaRPr lang="en-US"/>
           </a:p>
@@ -5723,7 +9181,7 @@
                 <a:ea typeface="Cambria" pitchFamily="34" charset="-122"/>
                 <a:cs typeface="Cambria" pitchFamily="34" charset="-120"/>
               </a:rPr>
-              <a:t>Seis réplicas evaluadas: 2 sí condicionadas, 3 parciales, 1 no</a:t>
+              <a:t>Seis réplicas evaluadas: 1 sí condicionada, 4 parciales, 1 no</a:t>
             </a:r>
             <a:endParaRPr lang="en-US" sz="2800" dirty="0"/>
           </a:p>
@@ -5890,7 +9348,7 @@
                 <a:ea typeface="Cambria" pitchFamily="34" charset="-122"/>
                 <a:cs typeface="Cambria" pitchFamily="34" charset="-120"/>
               </a:rPr>
-              <a:t>2</a:t>
+              <a:t>1</a:t>
             </a:r>
             <a:endParaRPr lang="en-US" sz="5400" dirty="0"/>
           </a:p>
@@ -5929,7 +9387,7 @@
                 <a:ea typeface="Calibri" pitchFamily="34" charset="-122"/>
                 <a:cs typeface="Calibri" pitchFamily="34" charset="-120"/>
               </a:rPr>
-              <a:t>réplicas SÍ, condicionadas al sitio: Pilgrim's Tepeji y Bachoco Lagos</a:t>
+              <a:t>réplica SÍ, condicionada a confirmar el sitio: Pilgrim's Tepeji</a:t>
             </a:r>
             <a:endParaRPr lang="en-US" sz="1400" dirty="0"/>
           </a:p>
@@ -5993,7 +9451,7 @@
                 <a:ea typeface="Cambria" pitchFamily="34" charset="-122"/>
                 <a:cs typeface="Cambria" pitchFamily="34" charset="-120"/>
               </a:rPr>
-              <a:t>3</a:t>
+              <a:t>4</a:t>
             </a:r>
             <a:endParaRPr lang="en-US" sz="5400" dirty="0"/>
           </a:p>
@@ -6032,7 +9490,7 @@
                 <a:ea typeface="Calibri" pitchFamily="34" charset="-122"/>
                 <a:cs typeface="Calibri" pitchFamily="34" charset="-120"/>
               </a:rPr>
-              <a:t>PARCIAL: SuKarne TIF 718, Pilgrim's Toluca y Bafar Lerma</a:t>
+              <a:t>PARCIAL: Bachoco Lagos, SuKarne TIF 718, Pilgrim's Toluca y Bafar Lerma</a:t>
             </a:r>
             <a:endParaRPr lang="en-US" sz="1400" dirty="0"/>
           </a:p>
@@ -6198,7 +9656,7 @@
                 <a:ea typeface="Calibri" pitchFamily="34" charset="-122"/>
                 <a:cs typeface="Calibri" pitchFamily="34" charset="-120"/>
               </a:rPr>
-              <a:t>Bachoco Lagos de Moreno no es prospección nueva: hay una oportunidad perdida en 2020 en el CRM (motivo no disponible), y Marcos informa que compañeros de otras regiones ya atienden la cuenta.</a:t>
+              <a:t>Bachoco Lagos de Moreno no es prospección nueva: el CRM tiene la oportunidad perdida «7.1 PCC C2B-Bachoco Lagos- Bamac Guadalajara» (2020; motivo no disponible). Marcos informa que compañeros de otras regiones ya atienden la cuenta; falta confirmar si incluye Lagos.</a:t>
             </a:r>
             <a:endParaRPr lang="en-US" sz="1700" dirty="0"/>
           </a:p>
@@ -6219,7 +9677,7 @@
                 <a:ea typeface="Calibri" pitchFamily="34" charset="-122"/>
                 <a:cs typeface="Calibri" pitchFamily="34" charset="-120"/>
               </a:rPr>
-              <a:t>Bafar tiene 0 oportunidades ganadas en el CRM. Marcos abrió oportunidades con La Piedad (Michoacán), declaración suya; número de oportunidad PENDIENTE. Gates no atendía a este usuario.</a:t>
+              <a:t>Bafar tiene 0 ganadas en el CRM (corte 12-ago-2026). Marcos abrió dos oportunidades con La Piedad (Michoacán), n.º 813492 y 814010, por 650,220 y 265,000 MXN según él; aún fuera del corte del CRM. Gates no atendía a este usuario.</a:t>
             </a:r>
             <a:endParaRPr lang="en-US" sz="1700" dirty="0"/>
           </a:p>
@@ -6677,7 +10135,7 @@
                 <a:ea typeface="Cambria" pitchFamily="34" charset="-122"/>
                 <a:cs typeface="Cambria" pitchFamily="34" charset="-120"/>
               </a:rPr>
-              <a:t>Carne en México: el consumo crece más que la producción</a:t>
+              <a:t>Carne: consumo +4.5% y producción +2.6% en 2025 (HIPÓTESIS)</a:t>
             </a:r>
             <a:endParaRPr lang="en-US" sz="2800" dirty="0"/>
           </a:p>
@@ -7070,7 +10528,7 @@
                 <a:ea typeface="Calibri" pitchFamily="34" charset="-122"/>
                 <a:cs typeface="Calibri" pitchFamily="34" charset="-120"/>
               </a:rPr>
-              <a:t>Pilgrim's: 1,300 millones de dólares en México 2026–2030, +38% de capacidad (Presidencia, 15-ene-2026). Bafar: parque agroindustrial de La Piedad, 650 mdd, en obra.</a:t>
+              <a:t>Pilgrim's: 1,300 millones de dólares en México 2026–2030, +38% de capacidad (Presidencia, 15-ene-2026). Bafar: parque agroindustrial de La Piedad, 650 mdd, en obra (Reporte Anual 2024).</a:t>
             </a:r>
             <a:endParaRPr lang="en-US" sz="1500" dirty="0"/>
           </a:p>
@@ -7419,9 +10877,9 @@
               <a:tblPr/>
               <a:tblGrid>
                 <a:gridCol w="1234440"/>
-                <a:gridCol w="5120640"/>
+                <a:gridCol w="4846320"/>
                 <a:gridCol w="1005840"/>
-                <a:gridCol w="640080"/>
+                <a:gridCol w="914400"/>
                 <a:gridCol w="1737360"/>
                 <a:gridCol w="1353312"/>
               </a:tblGrid>
@@ -7647,7 +11105,7 @@
                           <a:ea typeface="Calibri" pitchFamily="34" charset="-122"/>
                           <a:cs typeface="Calibri" pitchFamily="34" charset="-120"/>
                         </a:rPr>
-                        <a:t>Año</a:t>
+                        <a:t>Año de cierre</a:t>
                       </a:r>
                       <a:endParaRPr lang="en-US" sz="1200" dirty="0">
                         <a:latin typeface="Calibri" charset="0"/>
@@ -10462,7 +13920,7 @@
                 <a:ea typeface="Calibri" pitchFamily="34" charset="-122"/>
                 <a:cs typeface="Calibri" pitchFamily="34" charset="-120"/>
               </a:rPr>
-              <a:t>La nomenclatura da solo la familia. Máquina, número de parte e intervalo de reemplazo: PENDIENTE. Si la banda TPU de Pilgrim's es de transmisión o de transporte, y cuál de los TIF A-88, A-14 y 794 de Gómez Palacio es el origen: PENDIENTE.</a:t>
+              <a:t>La nomenclatura da solo la familia. Máquina, número de parte e intervalo de reemplazo: PENDIENTE. Si la banda TPU de Pilgrim's es de transmisión o de transporte, cuál de los TIF A-88, A-14 y 794 de Gómez Palacio es el origen de Pilgrim's, y el domicilio del origen de Bachoco: PENDIENTE.</a:t>
             </a:r>
             <a:endParaRPr lang="en-US" sz="1400" dirty="0"/>
           </a:p>
@@ -10480,7 +13938,7 @@
                 <a:ea typeface="Calibri" pitchFamily="34" charset="-122"/>
                 <a:cs typeface="Calibri" pitchFamily="34" charset="-120"/>
               </a:rPr>
-              <a:t>SuKarne: las bandas de Lucero son las que sostienen la réplica en TIF 718; la manguera hidráulica no aplica allí. Bafar: réplica de perfil de negocio, evidencia más débil.</a:t>
+              <a:t>SuKarne: las bandas de Lucero sostienen la réplica en TIF 718; la manguera hidráulica ligada a sacrificio, rendimiento y taller no aplica allí (circuitos en andenes y frío: por validar). Bafar: réplica de perfil de negocio, evidencia más débil.</a:t>
             </a:r>
             <a:endParaRPr lang="en-US" sz="1400" dirty="0"/>
           </a:p>
@@ -11045,7 +14503,7 @@
                           <a:ea typeface="Calibri" pitchFamily="34" charset="-122"/>
                           <a:cs typeface="Calibri" pitchFamily="34" charset="-120"/>
                         </a:rPr>
-                        <a:t>10 TIF: 9 a nombre de SuKarne en el padrón y el 645 de Lucero, registrado como Ganadería y Rastro de la Laguna y atribuido al grupo por sukarne.com. Vista Hermosa y Lucero: modelos de referencia por regla de trabajo.</a:t>
+                        <a:t>10 TIF en 9 domicilios (431 y 561 comparten; el 630 es almacén frigorífico). Varios están a nombre de otras razones sociales del grupo (Vizur, S.K., y Ganadería y Rastro de la Laguna para el 645) y se atribuyen por sukarne.com. Vista Hermosa y Lucero: modelos por regla de trabajo.</a:t>
                       </a:r>
                       <a:endParaRPr lang="en-US" sz="1200" dirty="0">
                         <a:latin typeface="Calibri" charset="0"/>
@@ -11113,7 +14571,7 @@
                           <a:ea typeface="Calibri" pitchFamily="34" charset="-122"/>
                           <a:cs typeface="Calibri" pitchFamily="34" charset="-120"/>
                         </a:rPr>
-                        <a:t>10 ganadas; suma de potenciales anuales registrados: 2.68 millones MXN. Monarca («TIF 43» en el CRM, «431» en otra fuente) y Ganadería Integral SK se atribuyen por nombre: sin ellas, 8 ganadas y 2.23 millones.</a:t>
+                        <a:t>10 ganadas; suma de potenciales anuales registrados: 2.68 millones MXN. Monarca («TIF 43» en el CRM, «431» en SENASICA y sukarne.com) y Ganadería Integral SK se atribuyen por nombre: sin ellas, 8 ganadas y 2.23 millones.</a:t>
                       </a:r>
                       <a:endParaRPr lang="en-US" sz="1200" dirty="0">
                         <a:latin typeface="Calibri" charset="0"/>
@@ -11408,7 +14866,7 @@
                           <a:ea typeface="Calibri" pitchFamily="34" charset="-122"/>
                           <a:cs typeface="Calibri" pitchFamily="34" charset="-120"/>
                         </a:rPr>
-                        <a:t>31 ganadas; suma 10.59 millones MXN. Lagos de Moreno: una oportunidad perdida en 2020, motivo no disponible.</a:t>
+                        <a:t>31 ganadas; suma 10.59 millones MXN. Lagos de Moreno: «7.1 PCC C2B-Bachoco Lagos- Bamac Guadalajara», perdida en 2020, motivo no disponible.</a:t>
                       </a:r>
                       <a:endParaRPr lang="en-US" sz="1200" dirty="0">
                         <a:latin typeface="Calibri" charset="0"/>
@@ -11998,7 +15456,7 @@
                           <a:ea typeface="Calibri" pitchFamily="34" charset="-122"/>
                           <a:cs typeface="Calibri" pitchFamily="34" charset="-120"/>
                         </a:rPr>
-                        <a:t>0 ganadas. Búsqueda por «Bafar» y «Strattega»: solo 2 oportunidades, perdidas en 2023 (PT-PU BELTS, motivo no disponible). Subsidiarias con otro nombre: PENDIENTE.</a:t>
+                        <a:t>0 ganadas. Búsqueda por «Bafar» y «Strattega» (corte 12-ago-2026): solo 2 oportunidades, perdidas en 2023 (PT-PU BELTS, motivo no disponible). Subsidiarias con otro nombre: PENDIENTE. Marcos reporta 2 nuevas de La Piedad (813492, 814010).</a:t>
                       </a:r>
                       <a:endParaRPr lang="en-US" sz="1200" dirty="0">
                         <a:latin typeface="Calibri" charset="0"/>
@@ -12066,7 +15524,7 @@
                           <a:ea typeface="Calibri" pitchFamily="34" charset="-122"/>
                           <a:cs typeface="Calibri" pitchFamily="34" charset="-120"/>
                         </a:rPr>
-                        <a:t>Ventas netas +14.8% en 2025 y +17.1% en 2T-2026, incluye tiendas propias. Marcos abrió oportunidades con La Piedad y dice que Gates casi no tiene presencia.</a:t>
+                        <a:t>Ventas netas +14.8% en 2025 y +17.1% en 2T-2026, incluye tiendas propias. Marcos dice que Gates casi no tiene presencia en La Piedad.</a:t>
                       </a:r>
                       <a:endParaRPr lang="en-US" sz="1200" dirty="0">
                         <a:latin typeface="Calibri" charset="0"/>
@@ -12155,7 +15613,7 @@
                 <a:ea typeface="Calibri" pitchFamily="34" charset="-122"/>
                 <a:cs typeface="Calibri" pitchFamily="34" charset="-120"/>
               </a:rPr>
-              <a:t>Sumas = potencial anual registrado de ganadas de varios años (2019–2026): no son monto anual ni facturación. Fuera de Elegible hay 13 ganadas más de Bachoco y 3 de SuKarne, no contadas. Fuentes en el apéndice 2. Estados de Bachoco y Bafar: declaración de Marcos, 14-oct-2026. Grupos acordados en la junta con Ricardo, no ranking de mercado.</a:t>
+              <a:t>Sumas = potencial anual registrado de ganadas de varios años (2019–2026): no son monto anual ni facturación, y pueden repetir importes entre años. Fuera de Elegible hay 13 ganadas más de Bachoco y 3 de SuKarne, no contadas. Fuentes en el apéndice 2. Estados de Bachoco y Bafar: declaración de Marcos, 14-oct-2026. Grupos acordados en la junta con Ricardo, no ranking de mercado.</a:t>
             </a:r>
             <a:endParaRPr lang="en-US" sz="1000" dirty="0"/>
           </a:p>
@@ -12660,7 +16118,7 @@
                           <a:ea typeface="Calibri" pitchFamily="34" charset="-122"/>
                           <a:cs typeface="Calibri" pitchFamily="34" charset="-120"/>
                         </a:rPr>
-                        <a:t>Bafar · Complejo productivo La Piedad (incluye el Complejo Agroindustrial de 650 mdd, en obra)</a:t>
+                        <a:t>Bafar · Complejo productivo La Piedad (incluye el Complejo Agroindustrial de 650 mdd, en obra según el Reporte Anual 2024; avance actual ND)</a:t>
                       </a:r>
                       <a:endParaRPr lang="en-US" sz="1200" dirty="0">
                         <a:latin typeface="Calibri" charset="0"/>
@@ -12796,7 +16254,7 @@
                           <a:ea typeface="Calibri" pitchFamily="34" charset="-122"/>
                           <a:cs typeface="Calibri" pitchFamily="34" charset="-120"/>
                         </a:rPr>
-                        <a:t>Marcos abrió oportunidades (declaración; n.º PENDIENTE). Domicilio y TIF: ND (¿TIF 126 de Strattega? por verificar). Lo que opera puede tener reposición (HIPÓTESIS); lo que está en obra no es demanda actual.</a:t>
+                        <a:t>Marcos reporta «3.1 MI Grupo bafar, sab de cv - La piedad FP-HYDRAULICS-813492» (650,220 MXN) y «7.1 PTI Grupo bafar, sab de cv - La piedad- Ryasa Morelia PT-IND SYNCH BELTS-814010» (265,000 MXN; Ryasa es canal); no están en el CRM del 12-ago. Domicilio y TIF: ND (¿TIF 126 de Strattega?). Lo que opera puede tener reposición (HIPÓTESIS); lo que está en obra no es demanda actual.</a:t>
                       </a:r>
                       <a:endParaRPr lang="en-US" sz="1200" dirty="0">
                         <a:latin typeface="Calibri" charset="0"/>
@@ -13002,7 +16460,7 @@
                           <a:ea typeface="Calibri" pitchFamily="34" charset="-122"/>
                           <a:cs typeface="Calibri" pitchFamily="34" charset="-120"/>
                         </a:rPr>
-                        <a:t>SÍ, CONDICIONADO</a:t>
+                        <a:t>PARCIAL</a:t>
                       </a:r>
                       <a:endParaRPr lang="en-US" sz="1100" dirty="0">
                         <a:latin typeface="Calibri" charset="0"/>
@@ -13049,7 +16507,7 @@
                       <a:tailEnd type="none" w="med" len="med"/>
                     </a:lnB>
                     <a:solidFill>
-                      <a:schemeClr val="accent2"/>
+                      <a:schemeClr val="accent3"/>
                     </a:solidFill>
                   </a:tcPr>
                 </a:tc>
@@ -13070,7 +16528,7 @@
                           <a:ea typeface="Calibri" pitchFamily="34" charset="-122"/>
                           <a:cs typeface="Calibri" pitchFamily="34" charset="-120"/>
                         </a:rPr>
-                        <a:t>Oportunidad perdida «7.1 PCC C2B-Bachoco Lagos- Bamac Guadalajara» (O-00218689, 2020, 834,766.20 MXN registrado; Bamac es canal; motivo no disponible). Confirmar si es el TIF A-183: la dirección difiere (km 12.5 contra 13.5, otro CP y municipio).</a:t>
+                        <a:t>Oportunidad perdida «7.1 PCC C2B-Bachoco Lagos- Bamac Guadalajara» (O-00218689, 2020, 834,766.20 MXN registrado; Bamac es canal; motivo no disponible). Sin áreas verificadas en destino ni en origen; sube a SÍ si es el TIF A-183, pero la dirección difiere (km 12.5 contra 13.5, otro CP y municipio).</a:t>
                       </a:r>
                       <a:endParaRPr lang="en-US" sz="1200" dirty="0">
                         <a:latin typeface="Calibri" charset="0"/>
@@ -13344,7 +16802,7 @@
                           <a:ea typeface="Calibri" pitchFamily="34" charset="-122"/>
                           <a:cs typeface="Calibri" pitchFamily="34" charset="-120"/>
                         </a:rPr>
-                        <a:t>Confirmar con el domicilio que son el mismo sitio; si no, baja a PARCIAL. Tepeji declara embutidos y pasta que el origen no tiene: aplicación nueva, no réplica.</a:t>
+                        <a:t>Confirmar con el domicilio que son el mismo sitio; si no, baja a PARCIAL. El TIF A-239 declara embutidos y pasta que el origen no tiene: aplicación nueva, no réplica.</a:t>
                       </a:r>
                       <a:endParaRPr lang="en-US" sz="1200" dirty="0">
                         <a:latin typeface="Calibri" charset="0"/>
@@ -14529,7 +17987,7 @@
                 <a:ea typeface="Calibri" pitchFamily="34" charset="-122"/>
                 <a:cs typeface="Calibri" pitchFamily="34" charset="-120"/>
               </a:rPr>
-              <a:t>Fuentes: Directorio TIF SENASICA, 7-sep-2026 · Reporte Anual 2024 de Bafar · Expansión, 12-abr-2023 · directorios comerciales para Tepeji, Toluca, Lerma y Lagos (apéndice) · CRM Base_Simbiosis. Todas las réplicas son HIPÓTESIS hasta visita. Oportunidades de La Piedad: declaración de Marcos, 14-oct-2026.</a:t>
+              <a:t>Fuentes: Directorio TIF SENASICA, 7-sep-2026 · Reporte Anual 2024 de Bafar · Expansión, 12-abr-2023 · directorios comerciales para Tepeji, Toluca, Lerma y Lagos (apéndice) · CRM Base_Simbiosis. Todas las réplicas son HIPÓTESIS hasta visita. Oportunidades de La Piedad y GAO: datos tal como los dio Marcos el 14-oct-2026, sin verificar en el CRM.</a:t>
             </a:r>
             <a:endParaRPr lang="en-US" sz="1000" dirty="0"/>
           </a:p>
@@ -14709,7 +18167,7 @@
               </a:rPr>
               <a:t>Hallazgos adicionales (no reemplazan a los cuatro)</a:t>
             </a:r>
-            <a:endParaRPr lang="en-US" sz="1500" dirty="0"/>
+            <a:endParaRPr lang="en-US" sz="1400" dirty="0"/>
           </a:p>
           <a:p>
             <a:pPr marL="342900" indent="-342900">
@@ -14720,7 +18178,7 @@
               <a:buChar char="•"/>
             </a:pPr>
             <a:r>
-              <a:rPr lang="en-US" sz="1500" dirty="0">
+              <a:rPr lang="en-US" sz="1400" dirty="0">
                 <a:solidFill>
                   <a:schemeClr val="tx1"/>
                 </a:solidFill>
@@ -14728,9 +18186,9 @@
                 <a:ea typeface="Calibri" pitchFamily="34" charset="-122"/>
                 <a:cs typeface="Calibri" pitchFamily="34" charset="-120"/>
               </a:rPr>
-              <a:t>Qualtia y Sigma: carnes frías. Qualtia: 4 TIF y 1 ganada en el CRM. Sigma: 15 TIF en 8 estados (padrón de sep-2026) y 7 ganadas en el CRM. Quedan documentados para ampliar si Ricardo lo decide.</a:t>
+              <a:t>Qualtia y Sigma: carnes frías. Qualtia: 4 TIF y 1 ganada en el CRM. Sigma: 15 TIF en 8 estados (padrón de sep-2026) y 7 ganadas en el CRM, solo bajo razón social Sigma; con subsidiarias atribuidas habría más: PENDIENTE. Quedan documentados para ampliar si Ricardo lo decide.</a:t>
             </a:r>
-            <a:endParaRPr lang="en-US" sz="1500" dirty="0"/>
+            <a:endParaRPr lang="en-US" sz="1400" dirty="0"/>
           </a:p>
           <a:p>
             <a:pPr marL="342900" indent="-342900">
@@ -14741,7 +18199,7 @@
               <a:buChar char="•"/>
             </a:pPr>
             <a:r>
-              <a:rPr lang="en-US" sz="1500" dirty="0">
+              <a:rPr lang="en-US" sz="1400" dirty="0">
                 <a:solidFill>
                   <a:schemeClr val="tx1"/>
                 </a:solidFill>
@@ -14749,9 +18207,9 @@
                 <a:ea typeface="Calibri" pitchFamily="34" charset="-122"/>
                 <a:cs typeface="Calibri" pitchFamily="34" charset="-120"/>
               </a:rPr>
-              <a:t>GAO Aluminio, Acatlán de Juárez, Jalisco: extrusión de aluminio (gaoaluminio.com, consultada el 14-oct-2026). Marcos abrió una oportunidad y reporta muchas necesidades hidráulicas (declaración suya). N.º de oportunidad, razón social, equipos y capacidad: PENDIENTE o ND.</a:t>
+              <a:t>GAO Aluminio, Acatlán de Juárez, Jalisco: extrusión de aluminio (gaoaluminio.com, 14-oct-2026). Marcos reporta «7.1 HID EFG5K Grupo Occidente S.A. de C.V. Acatlan Jal - DBS Gdl» (DBS es canal) y muchas necesidades hidráulicas. N.º y monto: PENDIENTE; equipos y capacidad: ND. La misma Cliente clave ya tiene 2 oportunidades perdidas en 2025 (742222 y 782913): no es terreno virgen.</a:t>
             </a:r>
-            <a:endParaRPr lang="en-US" sz="1500" dirty="0"/>
+            <a:endParaRPr lang="en-US" sz="1400" dirty="0"/>
           </a:p>
           <a:p>
             <a:pPr marL="342900" indent="-342900">
@@ -14759,7 +18217,7 @@
               <a:buChar char="•"/>
             </a:pPr>
             <a:r>
-              <a:rPr lang="en-US" sz="1500" dirty="0">
+              <a:rPr lang="en-US" sz="1400" dirty="0">
                 <a:solidFill>
                   <a:schemeClr val="tx1"/>
                 </a:solidFill>
@@ -14769,7 +18227,7 @@
               </a:rPr>
               <a:t>GAO no es proteína animal: Ricardo decide si entra al programa como caso de campo nuevo.</a:t>
             </a:r>
-            <a:endParaRPr lang="en-US" sz="1500" dirty="0"/>
+            <a:endParaRPr lang="en-US" sz="1400" dirty="0"/>
           </a:p>
         </p:txBody>
       </p:sp>
@@ -14855,7 +18313,7 @@
                 <a:ea typeface="Calibri" pitchFamily="34" charset="-122"/>
                 <a:cs typeface="Calibri" pitchFamily="34" charset="-120"/>
               </a:rPr>
-              <a:t>Pasar los números de oportunidad de Bafar La Piedad y GAO.</a:t>
+              <a:t>Pasar el número y el monto de la oportunidad de GAO, y confirmar que GAO es «Grupo Occidente» (la web no usa ese nombre).</a:t>
             </a:r>
             <a:endParaRPr lang="en-US" sz="1500" dirty="0"/>
           </a:p>
@@ -14957,7 +18415,7 @@
                 <a:ea typeface="Calibri" pitchFamily="34" charset="-122"/>
                 <a:cs typeface="Calibri" pitchFamily="34" charset="-120"/>
               </a:rPr>
-              <a:t>Pronóstico 2027; confirmar el subsector 311 y las cifras de Comecarne con el original.</a:t>
+              <a:t>Verificar las oportunidades 813492 y 814010 en el CRM; pronóstico 2027; confirmar subsector 311 y Comecarne con el original.</a:t>
             </a:r>
             <a:endParaRPr lang="en-US" sz="1500" dirty="0"/>
           </a:p>
@@ -15707,7 +19165,7 @@
                           <a:ea typeface="Calibri" pitchFamily="34" charset="-122"/>
                           <a:cs typeface="Calibri" pitchFamily="34" charset="-120"/>
                         </a:rPr>
-                        <a:t>Industria alimentaria (311): −0.4% a +2.2% mensual 2026 (HIPÓTESIS)</a:t>
+                        <a:t>Industria alimentaria (311): variación anual de −0.4% a +2.2% en meses de 2026 (HIPÓTESIS)</a:t>
                       </a:r>
                       <a:endParaRPr lang="en-US" sz="1100" dirty="0">
                         <a:latin typeface="Calibri" charset="0"/>

</xml_diff>

<commit_message>
Entregable 1 v5: cierra los bloqueantes de la tercera auditoria
Lagos sube a SI solo si se confirma el TIF A-183 y el origen Guanajuato;
la seleccion de los cuatro grupos queda como indicada por Marcos, sin
acta, pendiente de confirmar con Ricardo; apendices con el campo
Proveedor CRM de cada canal; se corrigen CSV de trabajo que
contradecian el deck (Bafar 'caso ganado', 'cercania a la Region 32',
nota de Lerma).

Co-Authored-By: Claude Sonnet 5.5 <noreply@anthropic.com>
Claude-Session: https://claude.ai/code/session_01NzdY9gSJuZdYXnSeKazui4
</commit_message>
<xml_diff>
--- a/entregables/Simbiosis_IR_Proteina_Animal_Entregable1.pptx
+++ b/entregables/Simbiosis_IR_Proteina_Animal_Entregable1.pptx
@@ -117,33 +117,33 @@
   <p:extLst>
     <p:ext uri="{521415D9-36F7-43E2-AB2F-B90AF26B5E84}">
       <p14:sectionLst xmlns:p14="http://schemas.microsoft.com/office/powerpoint/2010/main">
-        <p14:section name="Resumen" id="{a0d70c26-75b7-63a4-3bec-9b66aa141751}">
+        <p14:section name="Resumen" id="{f1f3b5eb-674f-e096-49f7-a50405115db9}">
           <p14:sldIdLst>
             <p14:sldId id="257"/>
           </p14:sldIdLst>
         </p14:section>
-        <p14:section name="Mercado" id="{41db5a8a-d61d-0a16-b3aa-572b6c01e3ec}">
+        <p14:section name="Mercado" id="{dc4cb9c1-91de-60f4-f025-04c5f216d3e3}">
           <p14:sldIdLst>
             <p14:sldId id="258"/>
             <p14:sldId id="259"/>
           </p14:sldIdLst>
         </p14:section>
-        <p14:section name="Experiencia" id="{6c3cac80-1947-bea7-5a2e-44065b3baefb}">
+        <p14:section name="Experiencia" id="{fdefeb47-83e6-edb7-2737-e2d91c3a8b87}">
           <p14:sldIdLst>
             <p14:sldId id="260"/>
           </p14:sldIdLst>
         </p14:section>
-        <p14:section name="Grupos" id="{e4d561f9-bb7e-f2f0-aed4-41f6abe68a67}">
+        <p14:section name="Grupos" id="{0521ed78-243d-7d7a-8442-d0dd9a2450e9}">
           <p14:sldIdLst>
             <p14:sldId id="261"/>
           </p14:sldIdLst>
         </p14:section>
-        <p14:section name="Plantas" id="{02a37fdd-8b3e-8837-c656-880701316c00}">
+        <p14:section name="Plantas" id="{5bf1ac2f-92ba-ce11-7a48-9fb606d360fd}">
           <p14:sldIdLst>
             <p14:sldId id="262"/>
           </p14:sldIdLst>
         </p14:section>
-        <p14:section name="Cierre" id="{f07915fc-6b58-c44c-3e73-f0ae05cf8cf5}">
+        <p14:section name="Cierre" id="{595203d0-3a47-c74e-16d5-7c402f740618}">
           <p14:sldIdLst>
             <p14:sldId id="263"/>
             <p14:sldId id="264"/>
@@ -151,7 +151,7 @@
             <p14:sldId id="266"/>
           </p14:sldIdLst>
         </p14:section>
-        <p14:section name="Default-1" id="{980d443d-4922-a1b8-fc84-5f58625e9212}">
+        <p14:section name="Default-1" id="{6376a952-87da-0433-f30a-9703e2db0a19}">
           <p14:sldIdLst>
             <p14:sldId id="256"/>
           </p14:sldIdLst>
@@ -1151,7 +1151,7 @@
           <a:p>
             <a:r>
               <a:rPr lang="en-US" dirty="0"/>
-              <a:t>Portada. El entregable va de lo macro (alimentos y bebidas) a lo micro (proteína animal), a los cuatro grupos acordados para esta lámina (no es un ranking de mercado), y termina en plantas concretas por estado.</a:t>
+              <a:t>Portada. El entregable va de lo macro (alimentos y bebidas) a lo micro (proteína animal), a los cuatro grupos que Marcos indicó para esta lámina (no es un ranking de mercado; sin acta, por confirmar con Ricardo), y termina en plantas concretas por estado.</a:t>
             </a:r>
             <a:endParaRPr lang="en-US" dirty="0"/>
           </a:p>
@@ -1415,7 +1415,7 @@
           <a:p>
             <a:r>
               <a:rPr lang="en-US" dirty="0"/>
-              <a:t>Las cifras salen de la validación técnica del 12 de septiembre. La parte de Bachoco (atendido por otras regiones) y Bafar (oportunidades abiertas en La Piedad) son declaraciones de Marcos del 14 de octubre; no traen número de oportunidad, quedan PENDIENTE de registrar.</a:t>
+              <a:t>Las cifras salen de la validación técnica del 12 de septiembre, ajustada el 14 de octubre (Lagos baja a PARCIAL). La parte de Bachoco (atendido por otras regiones) y Bafar (oportunidades abiertas en La Piedad) son declaraciones de Marcos del 14 de octubre; no traen número de oportunidad, quedan PENDIENTE de registrar.</a:t>
             </a:r>
             <a:endParaRPr lang="en-US" dirty="0"/>
           </a:p>
@@ -3434,7 +3434,7 @@
                           <a:ea typeface="Calibri" pitchFamily="34" charset="-122"/>
                           <a:cs typeface="Calibri" pitchFamily="34" charset="-120"/>
                         </a:rPr>
-                        <a:t>TIF de SuKarne, Pilgrim's, Bachoco, Qualtia y Sigma; TIF 94 sin sacrificio</a:t>
+                        <a:t>TIF de SuKarne, Pilgrim's, Bachoco, Qualtia y Sigma; TIF 94 sin sacrificio; TIF 126 de Strattega en Michoacán (¿La Piedad?, no confirmado)</a:t>
                       </a:r>
                       <a:endParaRPr lang="en-US" sz="1000" dirty="0">
                         <a:latin typeface="Calibri" charset="0"/>
@@ -3708,7 +3708,7 @@
                           <a:ea typeface="Calibri" pitchFamily="34" charset="-122"/>
                           <a:cs typeface="Calibri" pitchFamily="34" charset="-120"/>
                         </a:rPr>
-                        <a:t>Bachoco: 64 plantas en 10 complejos</a:t>
+                        <a:t>Bachoco: 64 plantas en 10 complejos (una fuente de 2009 hablaba de siete; se usa la más reciente)</a:t>
                       </a:r>
                       <a:endParaRPr lang="en-US" sz="1000" dirty="0">
                         <a:latin typeface="Calibri" charset="0"/>
@@ -4256,7 +4256,7 @@
                           <a:ea typeface="Calibri" pitchFamily="34" charset="-122"/>
                           <a:cs typeface="Calibri" pitchFamily="34" charset="-120"/>
                         </a:rPr>
-                        <a:t>SuKarne: TIF 645 (Lucero) atribuido al grupo</a:t>
+                        <a:t>SuKarne: TIF 645 (Lucero), 111 (Vizur) y 105 (S.K.) atribuidos al grupo</a:t>
                       </a:r>
                       <a:endParaRPr lang="en-US" sz="1000" dirty="0">
                         <a:latin typeface="Calibri" charset="0"/>
@@ -5620,7 +5620,7 @@
         </p:nvSpPr>
         <p:spPr>
           <a:xfrm>
-            <a:off x="548640" y="4846320"/>
+            <a:off x="548640" y="5166360"/>
             <a:ext cx="11091672" cy="365760"/>
           </a:xfrm>
           <a:prstGeom prst="rect">
@@ -5785,11 +5785,11 @@
             <a:tbl>
               <a:tblPr/>
               <a:tblGrid>
-                <a:gridCol w="4754880"/>
+                <a:gridCol w="3931920"/>
                 <a:gridCol w="1005840"/>
-                <a:gridCol w="1188720"/>
-                <a:gridCol w="1737360"/>
-                <a:gridCol w="2404872"/>
+                <a:gridCol w="1005840"/>
+                <a:gridCol w="1371600"/>
+                <a:gridCol w="3776472"/>
               </a:tblGrid>
               <a:tr h="0">
                 <a:tc>
@@ -6505,7 +6505,7 @@
                           <a:ea typeface="Calibri" pitchFamily="34" charset="-122"/>
                           <a:cs typeface="Calibri" pitchFamily="34" charset="-120"/>
                         </a:rPr>
-                        <a:t>Bamac: canal</a:t>
+                        <a:t>Bamac (nomenclatura). Proveedor CRM: BANDAS Y MANGUERAS EL CAMINO SA DE - 60311 - GUADALAJARA. Propietario CRM: Marcos Arevalo</a:t>
                       </a:r>
                       <a:endParaRPr lang="en-US" sz="1000" dirty="0">
                         <a:latin typeface="Calibri" charset="0"/>
@@ -6847,7 +6847,7 @@
                           <a:ea typeface="Calibri" pitchFamily="34" charset="-122"/>
                           <a:cs typeface="Calibri" pitchFamily="34" charset="-120"/>
                         </a:rPr>
-                        <a:t>Rorisa: canal</a:t>
+                        <a:t>Rorisa (nomenclatura). Proveedor CRM: RODAMIENTOS Y REPRESENTACIONES INDU - 62314 - CHIHUAHUA</a:t>
                       </a:r>
                       <a:endParaRPr lang="en-US" sz="1000" dirty="0">
                         <a:latin typeface="Calibri" charset="0"/>
@@ -7189,7 +7189,7 @@
                           <a:ea typeface="Calibri" pitchFamily="34" charset="-122"/>
                           <a:cs typeface="Calibri" pitchFamily="34" charset="-120"/>
                         </a:rPr>
-                        <a:t>Interbandas: canal</a:t>
+                        <a:t>Interbandas (nomenclatura). Proveedor CRM: INTERNACIONAL DE BANDAS Y SERVICIOS - 110109 - CHIHUAHUA</a:t>
                       </a:r>
                       <a:endParaRPr lang="en-US" sz="1000" dirty="0">
                         <a:latin typeface="Calibri" charset="0"/>
@@ -7531,7 +7531,7 @@
                           <a:ea typeface="Calibri" pitchFamily="34" charset="-122"/>
                           <a:cs typeface="Calibri" pitchFamily="34" charset="-120"/>
                         </a:rPr>
-                        <a:t>Binasa: canal</a:t>
+                        <a:t>Binasa (nomenclatura). Proveedor CRM: BINASA TLAQUEPAQUE S. DE R.L. DE C.V. - 11115 - LEON,GTO.</a:t>
                       </a:r>
                       <a:endParaRPr lang="en-US" sz="1000" dirty="0">
                         <a:latin typeface="Calibri" charset="0"/>
@@ -7873,7 +7873,7 @@
                           <a:ea typeface="Calibri" pitchFamily="34" charset="-122"/>
                           <a:cs typeface="Calibri" pitchFamily="34" charset="-120"/>
                         </a:rPr>
-                        <a:t>Binasa y BRR: canal</a:t>
+                        <a:t>Binasa y BRR (nomenclatura). Proveedor CRM: BRR Rodamientos y Refacciones (BINASA)</a:t>
                       </a:r>
                       <a:endParaRPr lang="en-US" sz="1000" dirty="0">
                         <a:latin typeface="Calibri" charset="0"/>
@@ -9734,7 +9734,7 @@
                 <a:ea typeface="Calibri" pitchFamily="34" charset="-122"/>
                 <a:cs typeface="Calibri" pitchFamily="34" charset="-120"/>
               </a:rPr>
-              <a:t>Fuente: HIPOTESIS_REPLICA.csv (validación del 12-sep-2026) y declaraciones de campo de Marcos del 14-oct-2026. Todas las réplicas están en HIPÓTESIS hasta confirmar en visita.</a:t>
+              <a:t>Fuente: HIPOTESIS_REPLICA.csv (validación del 12-sep-2026, ajustada el 14-oct-2026: Lagos baja a PARCIAL) y declaraciones de campo de Marcos del 14-oct-2026. Todas las réplicas están en HIPÓTESIS hasta confirmar en visita.</a:t>
             </a:r>
             <a:endParaRPr lang="en-US" sz="1000" dirty="0"/>
           </a:p>
@@ -14503,7 +14503,7 @@
                           <a:ea typeface="Calibri" pitchFamily="34" charset="-122"/>
                           <a:cs typeface="Calibri" pitchFamily="34" charset="-120"/>
                         </a:rPr>
-                        <a:t>10 TIF en 9 domicilios (431 y 561 comparten; el 630 es almacén frigorífico). Varios están a nombre de otras razones sociales del grupo (Vizur, S.K., y Ganadería y Rastro de la Laguna para el 645) y se atribuyen por sukarne.com. Vista Hermosa y Lucero: modelos por regla de trabajo.</a:t>
+                        <a:t>10 TIF en 9 domicilios (431 y 561 comparten; el 630 es almacén frigorífico). Varios están a nombre de otras razones sociales del grupo (Vizur, S.K., y Ganadería y Rastro de la Laguna para el 645) y se atribuyen por sukarne.com.</a:t>
                       </a:r>
                       <a:endParaRPr lang="en-US" sz="1200" dirty="0">
                         <a:latin typeface="Calibri" charset="0"/>
@@ -15456,7 +15456,7 @@
                           <a:ea typeface="Calibri" pitchFamily="34" charset="-122"/>
                           <a:cs typeface="Calibri" pitchFamily="34" charset="-120"/>
                         </a:rPr>
-                        <a:t>0 ganadas. Búsqueda por «Bafar» y «Strattega» (corte 12-ago-2026): solo 2 oportunidades, perdidas en 2023 (PT-PU BELTS, motivo no disponible). Subsidiarias con otro nombre: PENDIENTE. Marcos reporta 2 nuevas de La Piedad (813492, 814010).</a:t>
+                        <a:t>0 ganadas. Búsqueda «Bafar» y «Strattega» (corte 12-ago-2026): solo 2 perdidas en 2023 (PT-PU BELTS, motivo no disponible). Subsidiarias con otro nombre: PENDIENTE.</a:t>
                       </a:r>
                       <a:endParaRPr lang="en-US" sz="1200" dirty="0">
                         <a:latin typeface="Calibri" charset="0"/>
@@ -15613,7 +15613,7 @@
                 <a:ea typeface="Calibri" pitchFamily="34" charset="-122"/>
                 <a:cs typeface="Calibri" pitchFamily="34" charset="-120"/>
               </a:rPr>
-              <a:t>Sumas = potencial anual registrado de ganadas de varios años (2019–2026): no son monto anual ni facturación, y pueden repetir importes entre años. Fuera de Elegible hay 13 ganadas más de Bachoco y 3 de SuKarne, no contadas. Fuentes en el apéndice 2. Estados de Bachoco y Bafar: declaración de Marcos, 14-oct-2026. Grupos acordados en la junta con Ricardo, no ranking de mercado.</a:t>
+              <a:t>Sumas = potencial anual registrado de ganadas de varios años (2019–2026), no monto anual ni facturación; pueden repetir importes. Fuera de Elegible: 13 ganadas más de Bachoco y 3 de SuKarne. Declaraciones de Marcos (14-oct-2026): «atendido por otras regiones» y las oportunidades de La Piedad. Selección de los cuatro grupos: indicada por Marcos como la de la junta con Ricardo; sin acta, PENDIENTE de confirmar. No es un ranking de mercado.</a:t>
             </a:r>
             <a:endParaRPr lang="en-US" sz="1000" dirty="0"/>
           </a:p>
@@ -16528,7 +16528,7 @@
                           <a:ea typeface="Calibri" pitchFamily="34" charset="-122"/>
                           <a:cs typeface="Calibri" pitchFamily="34" charset="-120"/>
                         </a:rPr>
-                        <a:t>Oportunidad perdida «7.1 PCC C2B-Bachoco Lagos- Bamac Guadalajara» (O-00218689, 2020, 834,766.20 MXN registrado; Bamac es canal; motivo no disponible). Sin áreas verificadas en destino ni en origen; sube a SÍ si es el TIF A-183, pero la dirección difiere (km 12.5 contra 13.5, otro CP y municipio).</a:t>
+                        <a:t>Oportunidad perdida «7.1 PCC C2B-Bachoco Lagos- Bamac Guadalajara» (O-00218689, 2020, 834,766.20 MXN registrado; Bamac es canal; motivo no disponible). Sin áreas verificadas en destino ni en origen; sube a SÍ si es el TIF A-183 (la dirección difiere: km 12.5 contra 13.5, otro CP y municipio) y se confirman domicilio y áreas del origen Guanajuato.</a:t>
                       </a:r>
                       <a:endParaRPr lang="en-US" sz="1200" dirty="0">
                         <a:latin typeface="Calibri" charset="0"/>
@@ -18186,7 +18186,7 @@
                 <a:ea typeface="Calibri" pitchFamily="34" charset="-122"/>
                 <a:cs typeface="Calibri" pitchFamily="34" charset="-120"/>
               </a:rPr>
-              <a:t>Qualtia y Sigma: carnes frías. Qualtia: 4 TIF y 1 ganada en el CRM. Sigma: 15 TIF en 8 estados (padrón de sep-2026) y 7 ganadas en el CRM, solo bajo razón social Sigma; con subsidiarias atribuidas habría más: PENDIENTE. Quedan documentados para ampliar si Ricardo lo decide.</a:t>
+              <a:t>Qualtia y Sigma: carnes frías. Qualtia: 4 TIF y 1 ganada en el CRM. Sigma: 15 TIF en 8 estados (padrón de sep-2026) y 7 ganadas en el CRM, solo bajo razón social Sigma (una de las 7 es una base de mantenimiento, no una planta); subsidiarias con otro nombre: PENDIENTE. Quedan documentados para ampliar si Ricardo lo decide.</a:t>
             </a:r>
             <a:endParaRPr lang="en-US" sz="1400" dirty="0"/>
           </a:p>
@@ -18376,7 +18376,7 @@
                 <a:ea typeface="Calibri" pitchFamily="34" charset="-122"/>
                 <a:cs typeface="Calibri" pitchFamily="34" charset="-120"/>
               </a:rPr>
-              <a:t>Cerrar identidades: Tepeji = TIF A-239; Lagos = TIF A-183 (la dirección difiere); Lerma = Toluca; TIF de La Piedad.</a:t>
+              <a:t>Cerrar identidades: Tepeji = TIF A-239; Lagos = TIF A-183 (la dirección difiere) y el origen Guanajuato de Bachoco; Lerma = Toluca; TIF de La Piedad.</a:t>
             </a:r>
             <a:endParaRPr lang="en-US" sz="1500" dirty="0"/>
           </a:p>

</xml_diff>

<commit_message>
Entregable 1 v6: cierra los puntos de la cuarta auditoria
La oportunidad 742222 queda marcada como Excluida (no sustenta
resultados); la identidad GAO = Grupo Occidente queda como afirmacion de
Marcos, no como hecho; los montos de las oportunidades de La Piedad se
rotulan como potencial anual segun Marcos, no facturacion.

Co-Authored-By: Claude Sonnet 5.5 <noreply@anthropic.com>
Claude-Session: https://claude.ai/code/session_01NzdY9gSJuZdYXnSeKazui4
</commit_message>
<xml_diff>
--- a/entregables/Simbiosis_IR_Proteina_Animal_Entregable1.pptx
+++ b/entregables/Simbiosis_IR_Proteina_Animal_Entregable1.pptx
@@ -117,33 +117,33 @@
   <p:extLst>
     <p:ext uri="{521415D9-36F7-43E2-AB2F-B90AF26B5E84}">
       <p14:sectionLst xmlns:p14="http://schemas.microsoft.com/office/powerpoint/2010/main">
-        <p14:section name="Resumen" id="{f1f3b5eb-674f-e096-49f7-a50405115db9}">
+        <p14:section name="Resumen" id="{0a58abea-56f5-f4b0-5b53-e33c9177ae7a}">
           <p14:sldIdLst>
             <p14:sldId id="257"/>
           </p14:sldIdLst>
         </p14:section>
-        <p14:section name="Mercado" id="{dc4cb9c1-91de-60f4-f025-04c5f216d3e3}">
+        <p14:section name="Mercado" id="{5a89a573-bc5f-b95f-9749-328139f134a3}">
           <p14:sldIdLst>
             <p14:sldId id="258"/>
             <p14:sldId id="259"/>
           </p14:sldIdLst>
         </p14:section>
-        <p14:section name="Experiencia" id="{fdefeb47-83e6-edb7-2737-e2d91c3a8b87}">
+        <p14:section name="Experiencia" id="{9864a090-c699-bc5f-3d5c-743027e79b5c}">
           <p14:sldIdLst>
             <p14:sldId id="260"/>
           </p14:sldIdLst>
         </p14:section>
-        <p14:section name="Grupos" id="{0521ed78-243d-7d7a-8442-d0dd9a2450e9}">
+        <p14:section name="Grupos" id="{1569b183-7338-e045-6cfc-597375451974}">
           <p14:sldIdLst>
             <p14:sldId id="261"/>
           </p14:sldIdLst>
         </p14:section>
-        <p14:section name="Plantas" id="{5bf1ac2f-92ba-ce11-7a48-9fb606d360fd}">
+        <p14:section name="Plantas" id="{1cbce440-0105-265f-a854-7d3681c2abab}">
           <p14:sldIdLst>
             <p14:sldId id="262"/>
           </p14:sldIdLst>
         </p14:section>
-        <p14:section name="Cierre" id="{595203d0-3a47-c74e-16d5-7c402f740618}">
+        <p14:section name="Cierre" id="{ce50e38d-98fe-7805-8735-0bd3c3925855}">
           <p14:sldIdLst>
             <p14:sldId id="263"/>
             <p14:sldId id="264"/>
@@ -151,7 +151,7 @@
             <p14:sldId id="266"/>
           </p14:sldIdLst>
         </p14:section>
-        <p14:section name="Default-1" id="{6376a952-87da-0433-f30a-9703e2db0a19}">
+        <p14:section name="Default-1" id="{c83a232a-38bb-d8a8-216b-cb4c51729f01}">
           <p14:sldIdLst>
             <p14:sldId id="256"/>
           </p14:sldIdLst>
@@ -1415,7 +1415,7 @@
           <a:p>
             <a:r>
               <a:rPr lang="en-US" dirty="0"/>
-              <a:t>Las cifras salen de la validación técnica del 12 de septiembre, ajustada el 14 de octubre (Lagos baja a PARCIAL). La parte de Bachoco (atendido por otras regiones) y Bafar (oportunidades abiertas en La Piedad) son declaraciones de Marcos del 14 de octubre; no traen número de oportunidad, quedan PENDIENTE de registrar.</a:t>
+              <a:t>Las cifras salen de la validación técnica del 12 de septiembre, ajustada el 14 de octubre (Lagos baja a PARCIAL). La parte de Bachoco (atendido por otras regiones) y Bafar (oportunidades abiertas en La Piedad) son declaraciones de Marcos del 14 de octubre; las oportunidades de La Piedad traen número y monto dados por Marcos, fuera del corte del 12-ago-2026: PENDIENTE de verificar en el CRM; la de GAO no trae número ni monto.</a:t>
             </a:r>
             <a:endParaRPr lang="en-US" dirty="0"/>
           </a:p>
@@ -3434,7 +3434,7 @@
                           <a:ea typeface="Calibri" pitchFamily="34" charset="-122"/>
                           <a:cs typeface="Calibri" pitchFamily="34" charset="-120"/>
                         </a:rPr>
-                        <a:t>TIF de SuKarne, Pilgrim's, Bachoco, Qualtia y Sigma; TIF 94 sin sacrificio; TIF 126 de Strattega en Michoacán (¿La Piedad?, no confirmado)</a:t>
+                        <a:t>TIF de SuKarne, Pilgrim's, Bachoco, Qualtia y Sigma; TIF 94 sin sacrificio; TIF 126 de Strattega, subsidiaria de Bafar según los archivos de trabajo, en Michoacán (¿La Piedad?, no confirmado)</a:t>
                       </a:r>
                       <a:endParaRPr lang="en-US" sz="1000" dirty="0">
                         <a:latin typeface="Calibri" charset="0"/>
@@ -6013,7 +6013,7 @@
                           <a:ea typeface="Calibri" pitchFamily="34" charset="-122"/>
                           <a:cs typeface="Calibri" pitchFamily="34" charset="-120"/>
                         </a:rPr>
-                        <a:t>MXN (potencial anual registrado)</a:t>
+                        <a:t>MXN (potencial anual; en las declaradas, según Marcos)</a:t>
                       </a:r>
                       <a:endParaRPr lang="en-US" sz="1100" dirty="0">
                         <a:latin typeface="Calibri" charset="0"/>
@@ -6151,7 +6151,7 @@
                           <a:ea typeface="Calibri" pitchFamily="34" charset="-122"/>
                           <a:cs typeface="Calibri" pitchFamily="34" charset="-120"/>
                         </a:rPr>
-                        <a:t>En Base_Simbiosis.xlsx (hoja DETALLE, Elegible), verificadas el 14-oct-2026; año = Año cierre</a:t>
+                        <a:t>En Base_Simbiosis.xlsx (hoja DETALLE), verificadas el 14-oct-2026; Elegible, salvo 742222: Excluida por tipo de oportunidad de distribución; año = Año cierre</a:t>
                       </a:r>
                       <a:endParaRPr lang="en-US" sz="1100" dirty="0">
                         <a:latin typeface="Calibri" charset="0"/>
@@ -7395,7 +7395,7 @@
                           <a:ea typeface="Calibri" pitchFamily="34" charset="-122"/>
                           <a:cs typeface="Calibri" pitchFamily="34" charset="-120"/>
                         </a:rPr>
-                        <a:t>Lost 2025</a:t>
+                        <a:t>Lost 2025 (Excluida)</a:t>
                       </a:r>
                       <a:endParaRPr lang="en-US" sz="1000" dirty="0">
                         <a:latin typeface="Calibri" charset="0"/>
@@ -9070,7 +9070,7 @@
                 <a:ea typeface="Calibri" pitchFamily="34" charset="-122"/>
                 <a:cs typeface="Calibri" pitchFamily="34" charset="-120"/>
               </a:rPr>
-              <a:t>Los montos son potencial anual registrado, no facturación. Los montos de las oportunidades declaradas son los que dio Marcos. Las dos de Grupo Occidente comparten la Cliente clave GRUPO OCCIDENTE S.A. DE C.V. ACATLAN JAL con la oportunidad de GAO; que esa cuenta sea la empresa de gaoaluminio.com lo afirma Marcos, la web no lo confirma. Responsables históricos del CRM: confirmar el vigente antes de asignar trabajo.</a:t>
+              <a:t>Montos: potencial anual, no facturación. La nomenclatura de la oportunidad de GAO que dio Marcos coincide con la Cliente clave GRUPO OCCIDENTE S.A. DE C.V. ACATLAN JAL de las dos de arriba; que esa cuenta sea la empresa de gaoaluminio.com lo afirma Marcos, la web no lo confirma. La 742222 está excluida y no sustenta resultados. Responsables históricos del CRM: confirmar el vigente antes de asignar trabajo.</a:t>
             </a:r>
             <a:endParaRPr lang="en-US" sz="1000" dirty="0"/>
           </a:p>
@@ -9637,7 +9637,7 @@
               </a:rPr>
               <a:t>Lo que cambia el mensaje para Ricardo</a:t>
             </a:r>
-            <a:endParaRPr lang="en-US" sz="1700" dirty="0"/>
+            <a:endParaRPr lang="en-US" sz="1600" dirty="0"/>
           </a:p>
           <a:p>
             <a:pPr marL="342900" indent="-342900">
@@ -9648,7 +9648,7 @@
               <a:buChar char="•"/>
             </a:pPr>
             <a:r>
-              <a:rPr lang="en-US" sz="1700" dirty="0">
+              <a:rPr lang="en-US" sz="1600" dirty="0">
                 <a:solidFill>
                   <a:schemeClr val="tx1"/>
                 </a:solidFill>
@@ -9658,7 +9658,7 @@
               </a:rPr>
               <a:t>Bachoco Lagos de Moreno no es prospección nueva: el CRM tiene la oportunidad perdida «7.1 PCC C2B-Bachoco Lagos- Bamac Guadalajara» (2020; motivo no disponible). Marcos informa que compañeros de otras regiones ya atienden la cuenta; falta confirmar si incluye Lagos.</a:t>
             </a:r>
-            <a:endParaRPr lang="en-US" sz="1700" dirty="0"/>
+            <a:endParaRPr lang="en-US" sz="1600" dirty="0"/>
           </a:p>
           <a:p>
             <a:pPr marL="342900" indent="-342900">
@@ -9669,7 +9669,7 @@
               <a:buChar char="•"/>
             </a:pPr>
             <a:r>
-              <a:rPr lang="en-US" sz="1700" dirty="0">
+              <a:rPr lang="en-US" sz="1600" dirty="0">
                 <a:solidFill>
                   <a:schemeClr val="tx1"/>
                 </a:solidFill>
@@ -9677,9 +9677,9 @@
                 <a:ea typeface="Calibri" pitchFamily="34" charset="-122"/>
                 <a:cs typeface="Calibri" pitchFamily="34" charset="-120"/>
               </a:rPr>
-              <a:t>Bafar tiene 0 ganadas en el CRM (corte 12-ago-2026). Marcos abrió dos oportunidades con La Piedad (Michoacán), n.º 813492 y 814010, por 650,220 y 265,000 MXN según él; aún fuera del corte del CRM. Gates no atendía a este usuario.</a:t>
+              <a:t>Bafar tiene 0 ganadas en el CRM (corte 12-ago-2026). Marcos abrió dos oportunidades con La Piedad (lámina 7): potencial anual según él de 650,220 y 265,000 MXN, no facturación; fuera del corte del CRM. Según Marcos, Gates no atendía a este usuario.</a:t>
             </a:r>
-            <a:endParaRPr lang="en-US" sz="1700" dirty="0"/>
+            <a:endParaRPr lang="en-US" sz="1600" dirty="0"/>
           </a:p>
           <a:p>
             <a:pPr marL="342900" indent="-342900">
@@ -9687,7 +9687,7 @@
               <a:buChar char="•"/>
             </a:pPr>
             <a:r>
-              <a:rPr lang="en-US" sz="1700" dirty="0">
+              <a:rPr lang="en-US" sz="1600" dirty="0">
                 <a:solidFill>
                   <a:schemeClr val="tx1"/>
                 </a:solidFill>
@@ -9697,7 +9697,7 @@
               </a:rPr>
               <a:t>Este borrador cubre UN mercado candidato (proteína animal). La selección de tres mercados y nueve usuarios sigue abierta.</a:t>
             </a:r>
-            <a:endParaRPr lang="en-US" sz="1700" dirty="0"/>
+            <a:endParaRPr lang="en-US" sz="1600" dirty="0"/>
           </a:p>
         </p:txBody>
       </p:sp>
@@ -16254,7 +16254,7 @@
                           <a:ea typeface="Calibri" pitchFamily="34" charset="-122"/>
                           <a:cs typeface="Calibri" pitchFamily="34" charset="-120"/>
                         </a:rPr>
-                        <a:t>Marcos reporta «3.1 MI Grupo bafar, sab de cv - La piedad FP-HYDRAULICS-813492» (650,220 MXN) y «7.1 PTI Grupo bafar, sab de cv - La piedad- Ryasa Morelia PT-IND SYNCH BELTS-814010» (265,000 MXN; Ryasa es canal); no están en el CRM del 12-ago. Domicilio y TIF: ND (¿TIF 126 de Strattega?). Lo que opera puede tener reposición (HIPÓTESIS); lo que está en obra no es demanda actual.</a:t>
+                        <a:t>Marcos reporta «3.1 MI Grupo bafar, sab de cv - La piedad FP-HYDRAULICS-813492» (potencial anual según Marcos: 650,220 MXN) y «7.1 PTI Grupo bafar, sab de cv - La piedad- Ryasa Morelia PT-IND SYNCH BELTS-814010» (265,000 MXN según Marcos; Ryasa es canal); no están en el CRM del 12-ago. Domicilio y TIF: ND (¿TIF 126 de Strattega?). Lo que opera puede tener reposición (HIPÓTESIS); lo que está en obra no es demanda actual.</a:t>
                       </a:r>
                       <a:endParaRPr lang="en-US" sz="1200" dirty="0">
                         <a:latin typeface="Calibri" charset="0"/>
@@ -17987,7 +17987,7 @@
                 <a:ea typeface="Calibri" pitchFamily="34" charset="-122"/>
                 <a:cs typeface="Calibri" pitchFamily="34" charset="-120"/>
               </a:rPr>
-              <a:t>Fuentes: Directorio TIF SENASICA, 7-sep-2026 · Reporte Anual 2024 de Bafar · Expansión, 12-abr-2023 · directorios comerciales para Tepeji, Toluca, Lerma y Lagos (apéndice) · CRM Base_Simbiosis. Todas las réplicas son HIPÓTESIS hasta visita. Oportunidades de La Piedad y GAO: datos tal como los dio Marcos el 14-oct-2026, sin verificar en el CRM.</a:t>
+              <a:t>Fuentes: Directorio TIF SENASICA, 7-sep-2026 · Reporte Anual 2024 de Bafar · Expansión, 12-abr-2023 · directorios comerciales para Tepeji, Toluca, Lerma y Lagos (apéndice) · CRM Base_Simbiosis. Todas las réplicas son HIPÓTESIS hasta visita. Oportunidades de La Piedad: datos tal como los dio Marcos el 14-oct-2026, sin verificar en el CRM.</a:t>
             </a:r>
             <a:endParaRPr lang="en-US" sz="1000" dirty="0"/>
           </a:p>
@@ -18207,7 +18207,7 @@
                 <a:ea typeface="Calibri" pitchFamily="34" charset="-122"/>
                 <a:cs typeface="Calibri" pitchFamily="34" charset="-120"/>
               </a:rPr>
-              <a:t>GAO Aluminio, Acatlán de Juárez, Jalisco: extrusión de aluminio (gaoaluminio.com, 14-oct-2026). Marcos reporta «7.1 HID EFG5K Grupo Occidente S.A. de C.V. Acatlan Jal - DBS Gdl» (DBS es canal) y muchas necesidades hidráulicas. N.º y monto: PENDIENTE; equipos y capacidad: ND. La misma Cliente clave ya tiene 2 oportunidades perdidas en 2025 (742222 y 782913): no es terreno virgen.</a:t>
+              <a:t>GAO Aluminio, Acatlán de Juárez, Jalisco: extrusión de aluminio (gaoaluminio.com, 14-oct-2026). Marcos reporta «7.1 HID EFG5K Grupo Occidente S.A. de C.V. Acatlan Jal - DBS Gdl» (DBS es canal) y muchas necesidades hidráulicas. N.º y monto: PENDIENTE; equipos y capacidad: ND. La nomenclatura coincide con la Cliente clave GRUPO OCCIDENTE S.A. DE C.V. ACATLAN JAL, con «7.1 HID MXT Grupo Occidente Acatlan - BRR Binasa -782913» perdida en 2025 (n.º 782913) y otra excluida por ser de distribución. Si GAO es esa cuenta (según Marcos; PENDIENTE), no es terreno virgen.</a:t>
             </a:r>
             <a:endParaRPr lang="en-US" sz="1400" dirty="0"/>
           </a:p>
@@ -18376,7 +18376,7 @@
                 <a:ea typeface="Calibri" pitchFamily="34" charset="-122"/>
                 <a:cs typeface="Calibri" pitchFamily="34" charset="-120"/>
               </a:rPr>
-              <a:t>Cerrar identidades: Tepeji = TIF A-239; Lagos = TIF A-183 (la dirección difiere) y el origen Guanajuato de Bachoco; Lerma = Toluca; TIF de La Piedad.</a:t>
+              <a:t>Cerrar identidades: Tepeji = TIF A-239; Lagos = TIF A-183 (la dirección difiere); domicilio y áreas del origen Bachoco Guanajuato; Lerma = Toluca; TIF de La Piedad.</a:t>
             </a:r>
             <a:endParaRPr lang="en-US" sz="1500" dirty="0"/>
           </a:p>
@@ -18397,7 +18397,7 @@
                 <a:ea typeface="Calibri" pitchFamily="34" charset="-122"/>
                 <a:cs typeface="Calibri" pitchFamily="34" charset="-120"/>
               </a:rPr>
-              <a:t>Buscar en el CRM las subsidiarias de Bafar con otro nombre.</a:t>
+              <a:t>Buscar en el CRM las subsidiarias de Bafar con otro nombre, y confirmar quién lleva hoy la cuenta Grupo Occidente Acatlán.</a:t>
             </a:r>
             <a:endParaRPr lang="en-US" sz="1500" dirty="0"/>
           </a:p>

</xml_diff>

<commit_message>
Entregable 1 v7: auditoria cerrada, pulido de redaccion
Quinta auditoria sin bloqueantes. Se unifica la redaccion sobre La
Piedad, se rotula el monto de 814010 como potencial anual segun Marcos y
se cita el Reporte Anual 2024 de Bafar como fuente de Strattega.

Co-Authored-By: Claude Sonnet 5.5 <noreply@anthropic.com>
Claude-Session: https://claude.ai/code/session_01NzdY9gSJuZdYXnSeKazui4
</commit_message>
<xml_diff>
--- a/entregables/Simbiosis_IR_Proteina_Animal_Entregable1.pptx
+++ b/entregables/Simbiosis_IR_Proteina_Animal_Entregable1.pptx
@@ -117,33 +117,33 @@
   <p:extLst>
     <p:ext uri="{521415D9-36F7-43E2-AB2F-B90AF26B5E84}">
       <p14:sectionLst xmlns:p14="http://schemas.microsoft.com/office/powerpoint/2010/main">
-        <p14:section name="Resumen" id="{0a58abea-56f5-f4b0-5b53-e33c9177ae7a}">
+        <p14:section name="Resumen" id="{b38693eb-07f4-7117-0ac1-2348187196e0}">
           <p14:sldIdLst>
             <p14:sldId id="257"/>
           </p14:sldIdLst>
         </p14:section>
-        <p14:section name="Mercado" id="{5a89a573-bc5f-b95f-9749-328139f134a3}">
+        <p14:section name="Mercado" id="{b5cb3108-c928-7635-b7ed-dfe0108b4baf}">
           <p14:sldIdLst>
             <p14:sldId id="258"/>
             <p14:sldId id="259"/>
           </p14:sldIdLst>
         </p14:section>
-        <p14:section name="Experiencia" id="{9864a090-c699-bc5f-3d5c-743027e79b5c}">
+        <p14:section name="Experiencia" id="{87c90a6e-b6d5-5943-a011-837b4da29bb5}">
           <p14:sldIdLst>
             <p14:sldId id="260"/>
           </p14:sldIdLst>
         </p14:section>
-        <p14:section name="Grupos" id="{1569b183-7338-e045-6cfc-597375451974}">
+        <p14:section name="Grupos" id="{7e6cad0d-8fb6-7979-fefe-1acbcbe5ff1c}">
           <p14:sldIdLst>
             <p14:sldId id="261"/>
           </p14:sldIdLst>
         </p14:section>
-        <p14:section name="Plantas" id="{1cbce440-0105-265f-a854-7d3681c2abab}">
+        <p14:section name="Plantas" id="{46809ad9-be1f-7354-0d75-0af2c63270ac}">
           <p14:sldIdLst>
             <p14:sldId id="262"/>
           </p14:sldIdLst>
         </p14:section>
-        <p14:section name="Cierre" id="{ce50e38d-98fe-7805-8735-0bd3c3925855}">
+        <p14:section name="Cierre" id="{36853ca0-a791-eeac-4e37-1cc6bea7085c}">
           <p14:sldIdLst>
             <p14:sldId id="263"/>
             <p14:sldId id="264"/>
@@ -151,7 +151,7 @@
             <p14:sldId id="266"/>
           </p14:sldIdLst>
         </p14:section>
-        <p14:section name="Default-1" id="{c83a232a-38bb-d8a8-216b-cb4c51729f01}">
+        <p14:section name="Default-1" id="{1dc18fb6-4206-d258-147c-57c02336bc98}">
           <p14:sldIdLst>
             <p14:sldId id="256"/>
           </p14:sldIdLst>
@@ -3434,7 +3434,7 @@
                           <a:ea typeface="Calibri" pitchFamily="34" charset="-122"/>
                           <a:cs typeface="Calibri" pitchFamily="34" charset="-120"/>
                         </a:rPr>
-                        <a:t>TIF de SuKarne, Pilgrim's, Bachoco, Qualtia y Sigma; TIF 94 sin sacrificio; TIF 126 de Strattega, subsidiaria de Bafar según los archivos de trabajo, en Michoacán (¿La Piedad?, no confirmado)</a:t>
+                        <a:t>TIF de SuKarne, Pilgrim's, Bachoco, Qualtia y Sigma; TIF 94 sin sacrificio; TIF 126 de Strattega, subsidiaria de Bafar según el Reporte Anual 2024, en Michoacán (¿La Piedad?, no confirmado)</a:t>
                       </a:r>
                       <a:endParaRPr lang="en-US" sz="1000" dirty="0">
                         <a:latin typeface="Calibri" charset="0"/>
@@ -15524,7 +15524,7 @@
                           <a:ea typeface="Calibri" pitchFamily="34" charset="-122"/>
                           <a:cs typeface="Calibri" pitchFamily="34" charset="-120"/>
                         </a:rPr>
-                        <a:t>Ventas netas +14.8% en 2025 y +17.1% en 2T-2026, incluye tiendas propias. Marcos dice que Gates casi no tiene presencia en La Piedad.</a:t>
+                        <a:t>Ventas netas +14.8% en 2025 y +17.1% en 2T-2026, incluye tiendas propias. Según Marcos, Gates no atendía a este usuario.</a:t>
                       </a:r>
                       <a:endParaRPr lang="en-US" sz="1200" dirty="0">
                         <a:latin typeface="Calibri" charset="0"/>
@@ -16254,7 +16254,7 @@
                           <a:ea typeface="Calibri" pitchFamily="34" charset="-122"/>
                           <a:cs typeface="Calibri" pitchFamily="34" charset="-120"/>
                         </a:rPr>
-                        <a:t>Marcos reporta «3.1 MI Grupo bafar, sab de cv - La piedad FP-HYDRAULICS-813492» (potencial anual según Marcos: 650,220 MXN) y «7.1 PTI Grupo bafar, sab de cv - La piedad- Ryasa Morelia PT-IND SYNCH BELTS-814010» (265,000 MXN según Marcos; Ryasa es canal); no están en el CRM del 12-ago. Domicilio y TIF: ND (¿TIF 126 de Strattega?). Lo que opera puede tener reposición (HIPÓTESIS); lo que está en obra no es demanda actual.</a:t>
+                        <a:t>Marcos reporta «3.1 MI Grupo bafar, sab de cv - La piedad FP-HYDRAULICS-813492» (potencial anual según Marcos: 650,220 MXN) y «7.1 PTI Grupo bafar, sab de cv - La piedad- Ryasa Morelia PT-IND SYNCH BELTS-814010» (potencial anual según Marcos: 265,000 MXN, no facturación; Ryasa es canal); no están en el CRM del 12-ago. Domicilio y TIF: ND (¿TIF 126 de Strattega?). Lo que opera puede tener reposición (HIPÓTESIS); lo que está en obra no es demanda actual.</a:t>
                       </a:r>
                       <a:endParaRPr lang="en-US" sz="1200" dirty="0">
                         <a:latin typeface="Calibri" charset="0"/>

</xml_diff>